<commit_message>
Add build tooling and docs for Zambia retail deck
- Add package.json (pptxgenjs ^4.0.1) with `npm run build` script
- Add .gitignore (node_modules, editor/OS cruft, stray output)
- Add README.md with project overview, regen steps, and data sources
- Fix build script output path (hardcoded Linux path -> zambia_retail_v2.pptx)
- Regenerate deck with pptxgenjs 4.0.1

Co-Authored-By: Claude Opus 4.8 (1M context) <noreply@anthropic.com>
</commit_message>
<xml_diff>
--- a/zambia_retail_v2.pptx
+++ b/zambia_retail_v2.pptx
@@ -4,9 +4,6 @@
   <p:sldMasterIdLst>
     <p:sldMasterId id="2147483648" r:id="rId1"/>
   </p:sldMasterIdLst>
-  <p:notesMasterIdLst>
-    <p:notesMasterId r:id="rId11"/>
-  </p:notesMasterIdLst>
   <p:sldIdLst>
     <p:sldId id="256" r:id="rId2"/>
     <p:sldId id="257" r:id="rId3"/>
@@ -18,7 +15,10 @@
     <p:sldId id="263" r:id="rId9"/>
     <p:sldId id="264" r:id="rId10"/>
   </p:sldIdLst>
-  <p:sldSz cx="9144000" cy="5143500" type="screen16x9"/>
+  <p:notesMasterIdLst>
+    <p:notesMasterId r:id="rId11"/>
+  </p:notesMasterIdLst>
+  <p:sldSz cx="9144000" cy="5143500"/>
   <p:notesSz cx="5143500" cy="9144000"/>
   <p:defaultTextStyle>
     <a:lvl1pPr marL="0" algn="l" defTabSz="914400" rtl="0" eaLnBrk="1" latinLnBrk="0" hangingPunct="1">
@@ -112,20 +112,13 @@
       </a:defRPr>
     </a:lvl9pPr>
   </p:defaultTextStyle>
-  <p:extLst>
-    <p:ext uri="{EFAFB233-063F-42B5-8137-9DF3F51BA10A}">
-      <p15:sldGuideLst xmlns:p15="http://schemas.microsoft.com/office/powerpoint/2012/main"/>
-    </p:ext>
-  </p:extLst>
 </p:presentation>
 </file>
 
 <file path=ppt/charts/chart1.xml><?xml version="1.0" encoding="utf-8"?>
-<c:chartSpace xmlns:c="http://schemas.openxmlformats.org/drawingml/2006/chart" xmlns:a="http://schemas.openxmlformats.org/drawingml/2006/main" xmlns:r="http://schemas.openxmlformats.org/officeDocument/2006/relationships" xmlns:c16r2="http://schemas.microsoft.com/office/drawing/2015/06/chart">
+<c:chartSpace xmlns:c="http://schemas.openxmlformats.org/drawingml/2006/chart" xmlns:a="http://schemas.openxmlformats.org/drawingml/2006/main" xmlns:r="http://schemas.openxmlformats.org/officeDocument/2006/relationships">
   <c:date1904 val="0"/>
-  <c:lang val="en-US"/>
   <c:roundedCorners val="0"/>
-  <c:style val="2"/>
   <c:chart>
     <c:title>
       <c:tx>
@@ -142,7 +135,7 @@
               </a:defRPr>
             </a:pPr>
             <a:r>
-              <a:rPr lang="en-US" sz="1000" b="0" i="0" u="none" strike="noStrike">
+              <a:rPr sz="1000" b="0" i="0" u="none" strike="noStrike">
                 <a:solidFill>
                   <a:srgbClr val="8A9BA8"/>
                 </a:solidFill>
@@ -153,6 +146,7 @@
           </a:p>
         </c:rich>
       </c:tx>
+      <c:layout/>
       <c:overlay val="0"/>
     </c:title>
     <c:autoTitleDeleted val="0"/>
@@ -183,6 +177,30 @@
             <a:effectLst/>
           </c:spPr>
           <c:invertIfNegative val="0"/>
+          <c:dLbls>
+            <c:numFmt formatCode="#,##0" sourceLinked="0"/>
+            <c:txPr>
+              <a:bodyPr/>
+              <a:lstStyle/>
+              <a:p>
+                <a:pPr>
+                  <a:defRPr b="0" i="0" strike="noStrike" sz="900" u="none">
+                    <a:solidFill>
+                      <a:srgbClr val="1C2B36"/>
+                    </a:solidFill>
+                    <a:latin typeface="Arial"/>
+                  </a:defRPr>
+                </a:pPr>
+              </a:p>
+            </c:txPr>
+            <c:showLegendKey val="0"/>
+            <c:showVal val="1"/>
+            <c:showCatName val="0"/>
+            <c:showSerName val="0"/>
+            <c:showPercent val="0"/>
+            <c:showBubbleSize val="0"/>
+            <c:showLeaderLines val="0"/>
+          </c:dLbls>
           <c:dPt>
             <c:idx val="0"/>
             <c:invertIfNegative val="0"/>
@@ -193,11 +211,6 @@
               </a:solidFill>
               <a:effectLst/>
             </c:spPr>
-            <c:extLst>
-              <c:ext xmlns:c16="http://schemas.microsoft.com/office/drawing/2014/chart" uri="{C3380CC4-5D6E-409C-BE32-E72D297353CC}">
-                <c16:uniqueId val="{00000001-DC78-484F-BB28-2D9EB75ABBFE}"/>
-              </c:ext>
-            </c:extLst>
           </c:dPt>
           <c:dPt>
             <c:idx val="1"/>
@@ -209,11 +222,6 @@
               </a:solidFill>
               <a:effectLst/>
             </c:spPr>
-            <c:extLst>
-              <c:ext xmlns:c16="http://schemas.microsoft.com/office/drawing/2014/chart" uri="{C3380CC4-5D6E-409C-BE32-E72D297353CC}">
-                <c16:uniqueId val="{00000003-DC78-484F-BB28-2D9EB75ABBFE}"/>
-              </c:ext>
-            </c:extLst>
           </c:dPt>
           <c:dPt>
             <c:idx val="2"/>
@@ -225,11 +233,6 @@
               </a:solidFill>
               <a:effectLst/>
             </c:spPr>
-            <c:extLst>
-              <c:ext xmlns:c16="http://schemas.microsoft.com/office/drawing/2014/chart" uri="{C3380CC4-5D6E-409C-BE32-E72D297353CC}">
-                <c16:uniqueId val="{00000005-DC78-484F-BB28-2D9EB75ABBFE}"/>
-              </c:ext>
-            </c:extLst>
           </c:dPt>
           <c:dPt>
             <c:idx val="3"/>
@@ -241,11 +244,6 @@
               </a:solidFill>
               <a:effectLst/>
             </c:spPr>
-            <c:extLst>
-              <c:ext xmlns:c16="http://schemas.microsoft.com/office/drawing/2014/chart" uri="{C3380CC4-5D6E-409C-BE32-E72D297353CC}">
-                <c16:uniqueId val="{00000007-DC78-484F-BB28-2D9EB75ABBFE}"/>
-              </c:ext>
-            </c:extLst>
           </c:dPt>
           <c:dPt>
             <c:idx val="4"/>
@@ -257,11 +255,6 @@
               </a:solidFill>
               <a:effectLst/>
             </c:spPr>
-            <c:extLst>
-              <c:ext xmlns:c16="http://schemas.microsoft.com/office/drawing/2014/chart" uri="{C3380CC4-5D6E-409C-BE32-E72D297353CC}">
-                <c16:uniqueId val="{00000009-DC78-484F-BB28-2D9EB75ABBFE}"/>
-              </c:ext>
-            </c:extLst>
           </c:dPt>
           <c:dPt>
             <c:idx val="5"/>
@@ -273,11 +266,6 @@
               </a:solidFill>
               <a:effectLst/>
             </c:spPr>
-            <c:extLst>
-              <c:ext xmlns:c16="http://schemas.microsoft.com/office/drawing/2014/chart" uri="{C3380CC4-5D6E-409C-BE32-E72D297353CC}">
-                <c16:uniqueId val="{0000000B-DC78-484F-BB28-2D9EB75ABBFE}"/>
-              </c:ext>
-            </c:extLst>
           </c:dPt>
           <c:dPt>
             <c:idx val="6"/>
@@ -289,77 +277,37 @@
               </a:solidFill>
               <a:effectLst/>
             </c:spPr>
-            <c:extLst>
-              <c:ext xmlns:c16="http://schemas.microsoft.com/office/drawing/2014/chart" uri="{C3380CC4-5D6E-409C-BE32-E72D297353CC}">
-                <c16:uniqueId val="{0000000D-DC78-484F-BB28-2D9EB75ABBFE}"/>
-              </c:ext>
-            </c:extLst>
           </c:dPt>
-          <c:dLbls>
-            <c:numFmt formatCode="#,##0" sourceLinked="0"/>
-            <c:spPr>
-              <a:noFill/>
-              <a:ln>
-                <a:noFill/>
-              </a:ln>
-              <a:effectLst/>
-            </c:spPr>
-            <c:txPr>
-              <a:bodyPr/>
-              <a:lstStyle/>
-              <a:p>
-                <a:pPr>
-                  <a:defRPr sz="900" b="0" i="0" u="none" strike="noStrike">
-                    <a:solidFill>
-                      <a:srgbClr val="1C2B36"/>
-                    </a:solidFill>
-                    <a:latin typeface="Arial"/>
-                  </a:defRPr>
-                </a:pPr>
-                <a:endParaRPr lang="en-US"/>
-              </a:p>
-            </c:txPr>
-            <c:showLegendKey val="0"/>
-            <c:showVal val="1"/>
-            <c:showCatName val="0"/>
-            <c:showSerName val="0"/>
-            <c:showPercent val="0"/>
-            <c:showBubbleSize val="0"/>
-            <c:showLeaderLines val="0"/>
-            <c:extLst>
-              <c:ext xmlns:c15="http://schemas.microsoft.com/office/drawing/2012/chart" uri="{CE6537A1-D6FC-4f65-9D91-7224C49458BB}">
-                <c15:showLeaderLines val="0"/>
-              </c:ext>
-            </c:extLst>
-          </c:dLbls>
           <c:cat>
-            <c:strRef>
+            <c:multiLvlStrRef>
               <c:f>Sheet1!$A$2:$A$8</c:f>
-              <c:strCache>
+              <c:multiLvlStrCache>
                 <c:ptCount val="7"/>
-                <c:pt idx="0">
-                  <c:v>2023</c:v>
-                </c:pt>
-                <c:pt idx="1">
-                  <c:v>2024</c:v>
-                </c:pt>
-                <c:pt idx="2">
-                  <c:v>2025</c:v>
-                </c:pt>
-                <c:pt idx="3">
-                  <c:v>2026e</c:v>
-                </c:pt>
-                <c:pt idx="4">
-                  <c:v>2027e</c:v>
-                </c:pt>
-                <c:pt idx="5">
-                  <c:v>2028e</c:v>
-                </c:pt>
-                <c:pt idx="6">
-                  <c:v>2029e</c:v>
-                </c:pt>
-              </c:strCache>
-            </c:strRef>
+                <c:lvl>
+                  <c:pt idx="0">
+                    <c:v>2023</c:v>
+                  </c:pt>
+                  <c:pt idx="1">
+                    <c:v>2024</c:v>
+                  </c:pt>
+                  <c:pt idx="2">
+                    <c:v>2025</c:v>
+                  </c:pt>
+                  <c:pt idx="3">
+                    <c:v>2026e</c:v>
+                  </c:pt>
+                  <c:pt idx="4">
+                    <c:v>2027e</c:v>
+                  </c:pt>
+                  <c:pt idx="5">
+                    <c:v>2028e</c:v>
+                  </c:pt>
+                  <c:pt idx="6">
+                    <c:v>2029e</c:v>
+                  </c:pt>
+                </c:lvl>
+              </c:multiLvlStrCache>
+            </c:multiLvlStrRef>
           </c:cat>
           <c:val>
             <c:numRef>
@@ -391,23 +339,36 @@
               </c:numCache>
             </c:numRef>
           </c:val>
-          <c:extLst>
-            <c:ext xmlns:c16="http://schemas.microsoft.com/office/drawing/2014/chart" uri="{C3380CC4-5D6E-409C-BE32-E72D297353CC}">
-              <c16:uniqueId val="{0000000E-DC78-484F-BB28-2D9EB75ABBFE}"/>
-            </c:ext>
-          </c:extLst>
         </c:ser>
         <c:dLbls>
+          <c:numFmt formatCode="#,##0" sourceLinked="0"/>
+          <c:txPr>
+            <a:bodyPr/>
+            <a:lstStyle/>
+            <a:p>
+              <a:pPr>
+                <a:defRPr b="0" i="0" strike="noStrike" sz="900" u="none">
+                  <a:solidFill>
+                    <a:srgbClr val="1C2B36"/>
+                  </a:solidFill>
+                  <a:latin typeface="Arial"/>
+                </a:defRPr>
+              </a:pPr>
+            </a:p>
+          </c:txPr>
           <c:showLegendKey val="0"/>
           <c:showVal val="1"/>
           <c:showCatName val="0"/>
           <c:showSerName val="0"/>
           <c:showPercent val="0"/>
           <c:showBubbleSize val="0"/>
+          <c:showLeaderLines val="0"/>
         </c:dLbls>
         <c:gapWidth val="150"/>
+        <c:overlap val="0"/>
         <c:axId val="2094734554"/>
         <c:axId val="2094734552"/>
+        <c:axId val="2094734556"/>
       </c:barChart>
       <c:catAx>
         <c:axId val="2094734554"/>
@@ -448,7 +409,6 @@
         <c:crosses val="autoZero"/>
         <c:auto val="1"/>
         <c:lblAlgn val="ctr"/>
-        <c:lblOffset val="100"/>
         <c:noMultiLvlLbl val="1"/>
       </c:catAx>
       <c:valAx>
@@ -511,7 +471,6 @@
     </c:plotArea>
     <c:plotVisOnly val="1"/>
     <c:dispBlanksAs val="span"/>
-    <c:showDLblsOverMax val="1"/>
   </c:chart>
   <c:spPr>
     <a:solidFill>
@@ -550,10 +509,234 @@
           <a:chExt cx="0" cy="0"/>
         </a:xfrm>
       </p:grpSpPr>
+      <p:sp>
+        <p:nvSpPr>
+          <p:cNvPr id="2" name="Header Placeholder 1"/>
+          <p:cNvSpPr>
+            <a:spLocks noGrp="1"/>
+          </p:cNvSpPr>
+          <p:nvPr>
+            <p:ph type="hdr" sz="quarter"/>
+          </p:nvPr>
+        </p:nvSpPr>
+        <p:spPr>
+          <a:xfrm>
+            <a:off x="0" y="0"/>
+            <a:ext cx="2971800" cy="458788"/>
+          </a:xfrm>
+          <a:prstGeom prst="rect">
+            <a:avLst/>
+          </a:prstGeom>
+        </p:spPr>
+        <p:txBody>
+          <a:bodyPr vert="horz" lIns="91440" tIns="45720" rIns="91440" bIns="45720" rtlCol="0"/>
+          <a:lstStyle>
+            <a:lvl1pPr algn="l">
+              <a:defRPr sz="1200"/>
+            </a:lvl1pPr>
+          </a:lstStyle>
+          <a:p>
+            <a:endParaRPr lang="en-US"/>
+          </a:p>
+        </p:txBody>
+      </p:sp>
+      <p:sp>
+        <p:nvSpPr>
+          <p:cNvPr id="3" name="Date Placeholder 2"/>
+          <p:cNvSpPr>
+            <a:spLocks noGrp="1"/>
+          </p:cNvSpPr>
+          <p:nvPr>
+            <p:ph type="dt" idx="1"/>
+          </p:nvPr>
+        </p:nvSpPr>
+        <p:spPr>
+          <a:xfrm>
+            <a:off x="3884613" y="0"/>
+            <a:ext cx="2971800" cy="458788"/>
+          </a:xfrm>
+          <a:prstGeom prst="rect">
+            <a:avLst/>
+          </a:prstGeom>
+        </p:spPr>
+        <p:txBody>
+          <a:bodyPr vert="horz" lIns="91440" tIns="45720" rIns="91440" bIns="45720" rtlCol="0"/>
+          <a:lstStyle>
+            <a:lvl1pPr algn="r">
+              <a:defRPr sz="1200"/>
+            </a:lvl1pPr>
+          </a:lstStyle>
+          <a:p>
+            <a:fld id="{5282F153-3F37-0F45-9E97-73ACFA13230C}" type="datetimeFigureOut">
+              <a:rPr lang="en-US"/>
+              <a:t>7/23/19</a:t>
+            </a:fld>
+            <a:endParaRPr lang="en-US"/>
+          </a:p>
+        </p:txBody>
+      </p:sp>
+      <p:sp>
+        <p:nvSpPr>
+          <p:cNvPr id="4" name="Slide Image Placeholder 3"/>
+          <p:cNvSpPr>
+            <a:spLocks noGrp="1" noRot="1" noChangeAspect="1"/>
+          </p:cNvSpPr>
+          <p:nvPr>
+            <p:ph type="sldImg" idx="2"/>
+          </p:nvPr>
+        </p:nvSpPr>
+        <p:spPr>
+          <a:xfrm>
+            <a:off x="685800" y="1143000"/>
+            <a:ext cx="5486400" cy="3086100"/>
+          </a:xfrm>
+          <a:prstGeom prst="rect">
+            <a:avLst/>
+          </a:prstGeom>
+          <a:noFill/>
+          <a:ln w="12700">
+            <a:solidFill>
+              <a:prstClr val="black"/>
+            </a:solidFill>
+          </a:ln>
+        </p:spPr>
+        <p:txBody>
+          <a:bodyPr vert="horz" lIns="91440" tIns="45720" rIns="91440" bIns="45720" rtlCol="0" anchor="ctr"/>
+          <a:lstStyle/>
+          <a:p>
+            <a:endParaRPr lang="en-US"/>
+          </a:p>
+        </p:txBody>
+      </p:sp>
+      <p:sp>
+        <p:nvSpPr>
+          <p:cNvPr id="5" name="Notes Placeholder 4"/>
+          <p:cNvSpPr>
+            <a:spLocks noGrp="1"/>
+          </p:cNvSpPr>
+          <p:nvPr>
+            <p:ph type="body" sz="quarter" idx="3"/>
+          </p:nvPr>
+        </p:nvSpPr>
+        <p:spPr>
+          <a:xfrm>
+            <a:off x="685800" y="4400550"/>
+            <a:ext cx="5486400" cy="3600450"/>
+          </a:xfrm>
+          <a:prstGeom prst="rect">
+            <a:avLst/>
+          </a:prstGeom>
+        </p:spPr>
+        <p:txBody>
+          <a:bodyPr vert="horz" lIns="91440" tIns="45720" rIns="91440" bIns="45720" rtlCol="0"/>
+          <a:lstStyle/>
+          <a:p>
+            <a:pPr lvl="0"/>
+            <a:r>
+              <a:rPr lang="en-US"/>
+              <a:t>Click to edit Master text styles</a:t>
+            </a:r>
+          </a:p>
+          <a:p>
+            <a:pPr lvl="1"/>
+            <a:r>
+              <a:rPr lang="en-US"/>
+              <a:t>Second level</a:t>
+            </a:r>
+          </a:p>
+          <a:p>
+            <a:pPr lvl="2"/>
+            <a:r>
+              <a:rPr lang="en-US"/>
+              <a:t>Third level</a:t>
+            </a:r>
+          </a:p>
+          <a:p>
+            <a:pPr lvl="3"/>
+            <a:r>
+              <a:rPr lang="en-US"/>
+              <a:t>Fourth level</a:t>
+            </a:r>
+          </a:p>
+          <a:p>
+            <a:pPr lvl="4"/>
+            <a:r>
+              <a:rPr lang="en-US"/>
+              <a:t>Fifth level</a:t>
+            </a:r>
+          </a:p>
+        </p:txBody>
+      </p:sp>
+      <p:sp>
+        <p:nvSpPr>
+          <p:cNvPr id="6" name="Footer Placeholder 5"/>
+          <p:cNvSpPr>
+            <a:spLocks noGrp="1"/>
+          </p:cNvSpPr>
+          <p:nvPr>
+            <p:ph type="ftr" sz="quarter" idx="4"/>
+          </p:nvPr>
+        </p:nvSpPr>
+        <p:spPr>
+          <a:xfrm>
+            <a:off x="0" y="8685213"/>
+            <a:ext cx="2971800" cy="458787"/>
+          </a:xfrm>
+          <a:prstGeom prst="rect">
+            <a:avLst/>
+          </a:prstGeom>
+        </p:spPr>
+        <p:txBody>
+          <a:bodyPr vert="horz" lIns="91440" tIns="45720" rIns="91440" bIns="45720" rtlCol="0" anchor="b"/>
+          <a:lstStyle>
+            <a:lvl1pPr algn="l">
+              <a:defRPr sz="1200"/>
+            </a:lvl1pPr>
+          </a:lstStyle>
+          <a:p>
+            <a:endParaRPr lang="en-US"/>
+          </a:p>
+        </p:txBody>
+      </p:sp>
+      <p:sp>
+        <p:nvSpPr>
+          <p:cNvPr id="7" name="Slide Number Placeholder 6"/>
+          <p:cNvSpPr>
+            <a:spLocks noGrp="1"/>
+          </p:cNvSpPr>
+          <p:nvPr>
+            <p:ph type="sldNum" sz="quarter" idx="5"/>
+          </p:nvPr>
+        </p:nvSpPr>
+        <p:spPr>
+          <a:xfrm>
+            <a:off x="3884613" y="8685213"/>
+            <a:ext cx="2971800" cy="458787"/>
+          </a:xfrm>
+          <a:prstGeom prst="rect">
+            <a:avLst/>
+          </a:prstGeom>
+        </p:spPr>
+        <p:txBody>
+          <a:bodyPr vert="horz" lIns="91440" tIns="45720" rIns="91440" bIns="45720" rtlCol="0" anchor="b"/>
+          <a:lstStyle>
+            <a:lvl1pPr algn="r">
+              <a:defRPr sz="1200"/>
+            </a:lvl1pPr>
+          </a:lstStyle>
+          <a:p>
+            <a:fld id="{CE5E9CC1-C706-0F49-92D6-E571CC5EEA8F}" type="slidenum">
+              <a:rPr lang="en-US"/>
+              <a:t>‹#›</a:t>
+            </a:fld>
+            <a:endParaRPr lang="en-US"/>
+          </a:p>
+        </p:txBody>
+      </p:sp>
     </p:spTree>
     <p:extLst>
       <p:ext uri="{BB962C8B-B14F-4D97-AF65-F5344CB8AC3E}">
-        <p14:creationId xmlns:p14="http://schemas.microsoft.com/office/powerpoint/2010/main" val="302130326"/>
+        <p14:creationId xmlns:p14="http://schemas.microsoft.com/office/powerpoint/2010/main" val="1024086991"/>
       </p:ext>
     </p:extLst>
   </p:cSld>
@@ -697,6 +880,10 @@
           <a:bodyPr/>
           <a:lstStyle/>
           <a:p>
+            <a:r>
+              <a:rPr lang="en-US" dirty="0"/>
+              <a:t/>
+            </a:r>
             <a:endParaRPr lang="en-US" dirty="0"/>
           </a:p>
         </p:txBody>
@@ -781,6 +968,10 @@
           <a:bodyPr/>
           <a:lstStyle/>
           <a:p>
+            <a:r>
+              <a:rPr lang="en-US" dirty="0"/>
+              <a:t/>
+            </a:r>
             <a:endParaRPr lang="en-US" dirty="0"/>
           </a:p>
         </p:txBody>
@@ -865,6 +1056,10 @@
           <a:bodyPr/>
           <a:lstStyle/>
           <a:p>
+            <a:r>
+              <a:rPr lang="en-US" dirty="0"/>
+              <a:t/>
+            </a:r>
             <a:endParaRPr lang="en-US" dirty="0"/>
           </a:p>
         </p:txBody>
@@ -949,6 +1144,10 @@
           <a:bodyPr/>
           <a:lstStyle/>
           <a:p>
+            <a:r>
+              <a:rPr lang="en-US" dirty="0"/>
+              <a:t/>
+            </a:r>
             <a:endParaRPr lang="en-US" dirty="0"/>
           </a:p>
         </p:txBody>
@@ -1033,6 +1232,10 @@
           <a:bodyPr/>
           <a:lstStyle/>
           <a:p>
+            <a:r>
+              <a:rPr lang="en-US" dirty="0"/>
+              <a:t/>
+            </a:r>
             <a:endParaRPr lang="en-US" dirty="0"/>
           </a:p>
         </p:txBody>
@@ -1117,6 +1320,10 @@
           <a:bodyPr/>
           <a:lstStyle/>
           <a:p>
+            <a:r>
+              <a:rPr lang="en-US" dirty="0"/>
+              <a:t/>
+            </a:r>
             <a:endParaRPr lang="en-US" dirty="0"/>
           </a:p>
         </p:txBody>
@@ -1201,6 +1408,10 @@
           <a:bodyPr/>
           <a:lstStyle/>
           <a:p>
+            <a:r>
+              <a:rPr lang="en-US" dirty="0"/>
+              <a:t/>
+            </a:r>
             <a:endParaRPr lang="en-US" dirty="0"/>
           </a:p>
         </p:txBody>
@@ -1285,6 +1496,10 @@
           <a:bodyPr/>
           <a:lstStyle/>
           <a:p>
+            <a:r>
+              <a:rPr lang="en-US" dirty="0"/>
+              <a:t/>
+            </a:r>
             <a:endParaRPr lang="en-US" dirty="0"/>
           </a:p>
         </p:txBody>
@@ -1369,6 +1584,10 @@
           <a:bodyPr/>
           <a:lstStyle/>
           <a:p>
+            <a:r>
+              <a:rPr lang="en-US" dirty="0"/>
+              <a:t/>
+            </a:r>
             <a:endParaRPr lang="en-US" dirty="0"/>
           </a:p>
         </p:txBody>
@@ -1442,11 +1661,6 @@
 <file path=ppt/slideMasters/slideMaster1.xml><?xml version="1.0" encoding="utf-8"?>
 <p:sldMaster xmlns:a="http://schemas.openxmlformats.org/drawingml/2006/main" xmlns:r="http://schemas.openxmlformats.org/officeDocument/2006/relationships" xmlns:p="http://schemas.openxmlformats.org/presentationml/2006/main">
   <p:cSld>
-    <p:bg>
-      <p:bgRef idx="1001">
-        <a:schemeClr val="bg1"/>
-      </p:bgRef>
-    </p:bg>
     <p:spTree>
       <p:nvGrpSpPr>
         <p:cNvPr id="1" name=""/>
@@ -1729,7 +1943,6 @@
         <a:solidFill>
           <a:srgbClr val="1C2B36"/>
         </a:solidFill>
-        <a:effectLst/>
       </p:bgPr>
     </p:bg>
     <p:spTree>
@@ -1774,13 +1987,6 @@
             <a:prstDash val="solid"/>
           </a:ln>
         </p:spPr>
-        <p:txBody>
-          <a:bodyPr/>
-          <a:lstStyle/>
-          <a:p>
-            <a:endParaRPr lang="en-US"/>
-          </a:p>
-        </p:txBody>
       </p:sp>
       <p:sp>
         <p:nvSpPr>
@@ -1810,13 +2016,6 @@
             <a:prstDash val="solid"/>
           </a:ln>
         </p:spPr>
-        <p:txBody>
-          <a:bodyPr/>
-          <a:lstStyle/>
-          <a:p>
-            <a:endParaRPr lang="en-US"/>
-          </a:p>
-        </p:txBody>
       </p:sp>
       <p:sp>
         <p:nvSpPr>
@@ -1839,11 +2038,11 @@
           <a:bodyPr wrap="square" lIns="0" tIns="0" rIns="0" bIns="0" rtlCol="0" anchor="ctr"/>
           <a:lstStyle/>
           <a:p>
-            <a:pPr marL="0" indent="0">
-              <a:buNone/>
-            </a:pPr>
-            <a:r>
-              <a:rPr lang="en-US" sz="1000" kern="0" spc="400" dirty="0">
+            <a:pPr indent="0" marL="0">
+              <a:buNone/>
+            </a:pPr>
+            <a:r>
+              <a:rPr lang="en-US" sz="1000" spc="400" kern="0" dirty="0">
                 <a:solidFill>
                   <a:srgbClr val="8A9BA8"/>
                 </a:solidFill>
@@ -1878,7 +2077,7 @@
           <a:bodyPr wrap="square" lIns="0" tIns="0" rIns="0" bIns="0" rtlCol="0" anchor="ctr"/>
           <a:lstStyle/>
           <a:p>
-            <a:pPr marL="0" indent="0">
+            <a:pPr indent="0" marL="0">
               <a:buNone/>
             </a:pPr>
             <a:r>
@@ -1895,7 +2094,7 @@
             <a:endParaRPr lang="en-US" sz="4400" dirty="0"/>
           </a:p>
           <a:p>
-            <a:pPr marL="0" indent="0">
+            <a:pPr indent="0" marL="0">
               <a:buNone/>
             </a:pPr>
             <a:r>
@@ -1934,7 +2133,7 @@
           <a:bodyPr wrap="square" lIns="0" tIns="0" rIns="0" bIns="0" rtlCol="0" anchor="ctr"/>
           <a:lstStyle/>
           <a:p>
-            <a:pPr marL="0" indent="0">
+            <a:pPr indent="0" marL="0">
               <a:buNone/>
             </a:pPr>
             <a:r>
@@ -1980,13 +2179,6 @@
             <a:prstDash val="solid"/>
           </a:ln>
         </p:spPr>
-        <p:txBody>
-          <a:bodyPr/>
-          <a:lstStyle/>
-          <a:p>
-            <a:endParaRPr lang="en-US"/>
-          </a:p>
-        </p:txBody>
       </p:sp>
       <p:sp>
         <p:nvSpPr>
@@ -2009,7 +2201,7 @@
           <a:bodyPr wrap="square" lIns="0" tIns="0" rIns="0" bIns="0" rtlCol="0" anchor="ctr"/>
           <a:lstStyle/>
           <a:p>
-            <a:pPr marL="0" indent="0">
+            <a:pPr indent="0" marL="0">
               <a:buNone/>
             </a:pPr>
             <a:r>
@@ -2043,7 +2235,6 @@
         <a:solidFill>
           <a:srgbClr val="FFFFFF"/>
         </a:solidFill>
-        <a:effectLst/>
       </p:bgPr>
     </p:bg>
     <p:spTree>
@@ -2081,7 +2272,7 @@
           <a:bodyPr wrap="square" lIns="0" tIns="0" rIns="0" bIns="0" rtlCol="0" anchor="ctr"/>
           <a:lstStyle/>
           <a:p>
-            <a:pPr marL="0" indent="0">
+            <a:pPr indent="0" marL="0">
               <a:buNone/>
             </a:pPr>
             <a:r>
@@ -2123,13 +2314,6 @@
             <a:prstDash val="solid"/>
           </a:ln>
         </p:spPr>
-        <p:txBody>
-          <a:bodyPr/>
-          <a:lstStyle/>
-          <a:p>
-            <a:endParaRPr lang="en-US"/>
-          </a:p>
-        </p:txBody>
       </p:sp>
       <p:sp>
         <p:nvSpPr>
@@ -2152,7 +2336,7 @@
           <a:bodyPr wrap="square" lIns="0" tIns="0" rIns="0" bIns="0" rtlCol="0" anchor="ctr"/>
           <a:lstStyle/>
           <a:p>
-            <a:pPr marL="0" indent="0">
+            <a:pPr indent="0" marL="0">
               <a:buNone/>
             </a:pPr>
             <a:r>
@@ -2191,7 +2375,7 @@
           <a:bodyPr wrap="square" lIns="0" tIns="0" rIns="0" bIns="0" rtlCol="0" anchor="ctr"/>
           <a:lstStyle/>
           <a:p>
-            <a:pPr marL="0" indent="0">
+            <a:pPr indent="0" marL="0">
               <a:buNone/>
             </a:pPr>
             <a:r>
@@ -2233,13 +2417,6 @@
             <a:prstDash val="solid"/>
           </a:ln>
         </p:spPr>
-        <p:txBody>
-          <a:bodyPr/>
-          <a:lstStyle/>
-          <a:p>
-            <a:endParaRPr lang="en-US"/>
-          </a:p>
-        </p:txBody>
       </p:sp>
       <p:sp>
         <p:nvSpPr>
@@ -2262,7 +2439,7 @@
           <a:bodyPr wrap="square" lIns="0" tIns="0" rIns="0" bIns="0" rtlCol="0" anchor="ctr"/>
           <a:lstStyle/>
           <a:p>
-            <a:pPr marL="0" indent="0">
+            <a:pPr indent="0" marL="0">
               <a:buNone/>
             </a:pPr>
             <a:r>
@@ -2301,7 +2478,7 @@
           <a:bodyPr wrap="square" lIns="0" tIns="0" rIns="0" bIns="0" rtlCol="0" anchor="ctr"/>
           <a:lstStyle/>
           <a:p>
-            <a:pPr marL="0" indent="0">
+            <a:pPr indent="0" marL="0">
               <a:buNone/>
             </a:pPr>
             <a:r>
@@ -2343,13 +2520,6 @@
             <a:prstDash val="solid"/>
           </a:ln>
         </p:spPr>
-        <p:txBody>
-          <a:bodyPr/>
-          <a:lstStyle/>
-          <a:p>
-            <a:endParaRPr lang="en-US"/>
-          </a:p>
-        </p:txBody>
       </p:sp>
       <p:sp>
         <p:nvSpPr>
@@ -2372,7 +2542,7 @@
           <a:bodyPr wrap="square" lIns="0" tIns="0" rIns="0" bIns="0" rtlCol="0" anchor="ctr"/>
           <a:lstStyle/>
           <a:p>
-            <a:pPr marL="0" indent="0">
+            <a:pPr indent="0" marL="0">
               <a:buNone/>
             </a:pPr>
             <a:r>
@@ -2411,7 +2581,7 @@
           <a:bodyPr wrap="square" lIns="0" tIns="0" rIns="0" bIns="0" rtlCol="0" anchor="ctr"/>
           <a:lstStyle/>
           <a:p>
-            <a:pPr marL="0" indent="0">
+            <a:pPr indent="0" marL="0">
               <a:buNone/>
             </a:pPr>
             <a:r>
@@ -2453,13 +2623,6 @@
             <a:prstDash val="solid"/>
           </a:ln>
         </p:spPr>
-        <p:txBody>
-          <a:bodyPr/>
-          <a:lstStyle/>
-          <a:p>
-            <a:endParaRPr lang="en-US"/>
-          </a:p>
-        </p:txBody>
       </p:sp>
       <p:sp>
         <p:nvSpPr>
@@ -2482,7 +2645,7 @@
           <a:bodyPr wrap="square" lIns="0" tIns="0" rIns="0" bIns="0" rtlCol="0" anchor="ctr"/>
           <a:lstStyle/>
           <a:p>
-            <a:pPr marL="0" indent="0">
+            <a:pPr indent="0" marL="0">
               <a:buNone/>
             </a:pPr>
             <a:r>
@@ -2521,7 +2684,7 @@
           <a:bodyPr wrap="square" lIns="0" tIns="0" rIns="0" bIns="0" rtlCol="0" anchor="ctr"/>
           <a:lstStyle/>
           <a:p>
-            <a:pPr marL="0" indent="0">
+            <a:pPr indent="0" marL="0">
               <a:buNone/>
             </a:pPr>
             <a:r>
@@ -2563,13 +2726,6 @@
             <a:prstDash val="solid"/>
           </a:ln>
         </p:spPr>
-        <p:txBody>
-          <a:bodyPr/>
-          <a:lstStyle/>
-          <a:p>
-            <a:endParaRPr lang="en-US"/>
-          </a:p>
-        </p:txBody>
       </p:sp>
       <p:sp>
         <p:nvSpPr>
@@ -2592,7 +2748,7 @@
           <a:bodyPr wrap="square" lIns="0" tIns="0" rIns="0" bIns="0" rtlCol="0" anchor="ctr"/>
           <a:lstStyle/>
           <a:p>
-            <a:pPr marL="0" indent="0">
+            <a:pPr indent="0" marL="0">
               <a:buNone/>
             </a:pPr>
             <a:r>
@@ -2631,7 +2787,7 @@
           <a:bodyPr wrap="square" lIns="0" tIns="0" rIns="0" bIns="0" rtlCol="0" anchor="ctr"/>
           <a:lstStyle/>
           <a:p>
-            <a:pPr marL="0" indent="0">
+            <a:pPr indent="0" marL="0">
               <a:buNone/>
             </a:pPr>
             <a:r>
@@ -2673,13 +2829,6 @@
             <a:prstDash val="solid"/>
           </a:ln>
         </p:spPr>
-        <p:txBody>
-          <a:bodyPr/>
-          <a:lstStyle/>
-          <a:p>
-            <a:endParaRPr lang="en-US"/>
-          </a:p>
-        </p:txBody>
       </p:sp>
       <p:sp>
         <p:nvSpPr>
@@ -2702,7 +2851,7 @@
           <a:bodyPr wrap="square" lIns="0" tIns="0" rIns="0" bIns="0" rtlCol="0" anchor="ctr"/>
           <a:lstStyle/>
           <a:p>
-            <a:pPr marL="0" indent="0">
+            <a:pPr indent="0" marL="0">
               <a:buNone/>
             </a:pPr>
             <a:r>
@@ -2741,7 +2890,7 @@
           <a:bodyPr wrap="square" lIns="0" tIns="0" rIns="0" bIns="0" rtlCol="0" anchor="ctr"/>
           <a:lstStyle/>
           <a:p>
-            <a:pPr marL="0" indent="0">
+            <a:pPr indent="0" marL="0">
               <a:buNone/>
             </a:pPr>
             <a:r>
@@ -2775,7 +2924,6 @@
         <a:solidFill>
           <a:srgbClr val="FFFFFF"/>
         </a:solidFill>
-        <a:effectLst/>
       </p:bgPr>
     </p:bg>
     <p:spTree>
@@ -2813,7 +2961,7 @@
           <a:bodyPr wrap="square" lIns="0" tIns="0" rIns="0" bIns="0" rtlCol="0" anchor="ctr"/>
           <a:lstStyle/>
           <a:p>
-            <a:pPr marL="0" indent="0">
+            <a:pPr indent="0" marL="0">
               <a:buNone/>
             </a:pPr>
             <a:r>
@@ -2855,13 +3003,6 @@
             <a:prstDash val="solid"/>
           </a:ln>
         </p:spPr>
-        <p:txBody>
-          <a:bodyPr/>
-          <a:lstStyle/>
-          <a:p>
-            <a:endParaRPr lang="en-US"/>
-          </a:p>
-        </p:txBody>
       </p:sp>
       <p:sp>
         <p:nvSpPr>
@@ -2884,7 +3025,7 @@
           <a:bodyPr wrap="square" lIns="0" tIns="0" rIns="0" bIns="0" rtlCol="0" anchor="ctr"/>
           <a:lstStyle/>
           <a:p>
-            <a:pPr marL="0" indent="0">
+            <a:pPr indent="0" marL="0">
               <a:buNone/>
             </a:pPr>
             <a:r>
@@ -2926,13 +3067,6 @@
             <a:prstDash val="solid"/>
           </a:ln>
         </p:spPr>
-        <p:txBody>
-          <a:bodyPr/>
-          <a:lstStyle/>
-          <a:p>
-            <a:endParaRPr lang="en-US"/>
-          </a:p>
-        </p:txBody>
       </p:sp>
       <p:sp>
         <p:nvSpPr>
@@ -2958,13 +3092,6 @@
             <a:prstDash val="solid"/>
           </a:ln>
         </p:spPr>
-        <p:txBody>
-          <a:bodyPr/>
-          <a:lstStyle/>
-          <a:p>
-            <a:endParaRPr lang="en-US"/>
-          </a:p>
-        </p:txBody>
       </p:sp>
       <p:sp>
         <p:nvSpPr>
@@ -2987,7 +3114,7 @@
           <a:bodyPr wrap="square" lIns="0" tIns="0" rIns="0" bIns="0" rtlCol="0" anchor="ctr"/>
           <a:lstStyle/>
           <a:p>
-            <a:pPr marL="0" indent="0">
+            <a:pPr indent="0" marL="0">
               <a:buNone/>
             </a:pPr>
             <a:r>
@@ -3026,7 +3153,7 @@
           <a:bodyPr wrap="square" lIns="0" tIns="0" rIns="0" bIns="0" rtlCol="0" anchor="ctr"/>
           <a:lstStyle/>
           <a:p>
-            <a:pPr marL="0" indent="0">
+            <a:pPr indent="0" marL="0">
               <a:buNone/>
             </a:pPr>
             <a:r>
@@ -3068,13 +3195,6 @@
             <a:prstDash val="solid"/>
           </a:ln>
         </p:spPr>
-        <p:txBody>
-          <a:bodyPr/>
-          <a:lstStyle/>
-          <a:p>
-            <a:endParaRPr lang="en-US"/>
-          </a:p>
-        </p:txBody>
       </p:sp>
       <p:sp>
         <p:nvSpPr>
@@ -3100,13 +3220,6 @@
             <a:prstDash val="solid"/>
           </a:ln>
         </p:spPr>
-        <p:txBody>
-          <a:bodyPr/>
-          <a:lstStyle/>
-          <a:p>
-            <a:endParaRPr lang="en-US"/>
-          </a:p>
-        </p:txBody>
       </p:sp>
       <p:sp>
         <p:nvSpPr>
@@ -3129,7 +3242,7 @@
           <a:bodyPr wrap="square" lIns="0" tIns="0" rIns="0" bIns="0" rtlCol="0" anchor="ctr"/>
           <a:lstStyle/>
           <a:p>
-            <a:pPr marL="0" indent="0">
+            <a:pPr indent="0" marL="0">
               <a:buNone/>
             </a:pPr>
             <a:r>
@@ -3168,7 +3281,7 @@
           <a:bodyPr wrap="square" lIns="0" tIns="0" rIns="0" bIns="0" rtlCol="0" anchor="ctr"/>
           <a:lstStyle/>
           <a:p>
-            <a:pPr marL="0" indent="0">
+            <a:pPr indent="0" marL="0">
               <a:buNone/>
             </a:pPr>
             <a:r>
@@ -3210,13 +3323,6 @@
             <a:prstDash val="solid"/>
           </a:ln>
         </p:spPr>
-        <p:txBody>
-          <a:bodyPr/>
-          <a:lstStyle/>
-          <a:p>
-            <a:endParaRPr lang="en-US"/>
-          </a:p>
-        </p:txBody>
       </p:sp>
       <p:sp>
         <p:nvSpPr>
@@ -3242,13 +3348,6 @@
             <a:prstDash val="solid"/>
           </a:ln>
         </p:spPr>
-        <p:txBody>
-          <a:bodyPr/>
-          <a:lstStyle/>
-          <a:p>
-            <a:endParaRPr lang="en-US"/>
-          </a:p>
-        </p:txBody>
       </p:sp>
       <p:sp>
         <p:nvSpPr>
@@ -3271,7 +3370,7 @@
           <a:bodyPr wrap="square" lIns="0" tIns="0" rIns="0" bIns="0" rtlCol="0" anchor="ctr"/>
           <a:lstStyle/>
           <a:p>
-            <a:pPr marL="0" indent="0">
+            <a:pPr indent="0" marL="0">
               <a:buNone/>
             </a:pPr>
             <a:r>
@@ -3310,7 +3409,7 @@
           <a:bodyPr wrap="square" lIns="0" tIns="0" rIns="0" bIns="0" rtlCol="0" anchor="ctr"/>
           <a:lstStyle/>
           <a:p>
-            <a:pPr marL="0" indent="0">
+            <a:pPr indent="0" marL="0">
               <a:buNone/>
             </a:pPr>
             <a:r>
@@ -3322,7 +3421,7 @@
                 <a:ea typeface="Poppins" pitchFamily="34" charset="-122"/>
                 <a:cs typeface="Poppins" pitchFamily="34" charset="-120"/>
               </a:rPr>
-              <a:t>Platforms like Amazon</a:t>
+              <a:t>Platforms like Jumia</a:t>
             </a:r>
             <a:endParaRPr lang="en-US" sz="1100" dirty="0"/>
           </a:p>
@@ -3352,13 +3451,6 @@
             <a:prstDash val="solid"/>
           </a:ln>
         </p:spPr>
-        <p:txBody>
-          <a:bodyPr/>
-          <a:lstStyle/>
-          <a:p>
-            <a:endParaRPr lang="en-US"/>
-          </a:p>
-        </p:txBody>
       </p:sp>
       <p:sp>
         <p:nvSpPr>
@@ -3384,13 +3476,6 @@
             <a:prstDash val="solid"/>
           </a:ln>
         </p:spPr>
-        <p:txBody>
-          <a:bodyPr/>
-          <a:lstStyle/>
-          <a:p>
-            <a:endParaRPr lang="en-US"/>
-          </a:p>
-        </p:txBody>
       </p:sp>
       <p:sp>
         <p:nvSpPr>
@@ -3413,7 +3498,7 @@
           <a:bodyPr wrap="square" lIns="0" tIns="0" rIns="0" bIns="0" rtlCol="0" anchor="ctr"/>
           <a:lstStyle/>
           <a:p>
-            <a:pPr marL="0" indent="0">
+            <a:pPr indent="0" marL="0">
               <a:buNone/>
             </a:pPr>
             <a:r>
@@ -3452,7 +3537,7 @@
           <a:bodyPr wrap="square" lIns="0" tIns="0" rIns="0" bIns="0" rtlCol="0" anchor="ctr"/>
           <a:lstStyle/>
           <a:p>
-            <a:pPr marL="0" indent="0">
+            <a:pPr indent="0" marL="0">
               <a:buNone/>
             </a:pPr>
             <a:r>
@@ -3486,7 +3571,6 @@
         <a:solidFill>
           <a:srgbClr val="FFFFFF"/>
         </a:solidFill>
-        <a:effectLst/>
       </p:bgPr>
     </p:bg>
     <p:spTree>
@@ -3524,7 +3608,7 @@
           <a:bodyPr wrap="square" lIns="0" tIns="0" rIns="0" bIns="0" rtlCol="0" anchor="ctr"/>
           <a:lstStyle/>
           <a:p>
-            <a:pPr marL="0" indent="0">
+            <a:pPr indent="0" marL="0">
               <a:buNone/>
             </a:pPr>
             <a:r>
@@ -3566,13 +3650,6 @@
             <a:prstDash val="solid"/>
           </a:ln>
         </p:spPr>
-        <p:txBody>
-          <a:bodyPr/>
-          <a:lstStyle/>
-          <a:p>
-            <a:endParaRPr lang="en-US"/>
-          </a:p>
-        </p:txBody>
       </p:sp>
       <p:sp>
         <p:nvSpPr>
@@ -3595,7 +3672,7 @@
           <a:bodyPr wrap="square" lIns="0" tIns="0" rIns="0" bIns="0" rtlCol="0" anchor="ctr"/>
           <a:lstStyle/>
           <a:p>
-            <a:pPr marL="0" indent="0" algn="ctr">
+            <a:pPr algn="ctr" indent="0" marL="0">
               <a:buNone/>
             </a:pPr>
             <a:r>
@@ -3634,7 +3711,7 @@
           <a:bodyPr wrap="square" lIns="0" tIns="0" rIns="0" bIns="0" rtlCol="0" anchor="ctr"/>
           <a:lstStyle/>
           <a:p>
-            <a:pPr marL="0" indent="0" algn="ctr">
+            <a:pPr algn="ctr" indent="0" marL="0">
               <a:buNone/>
             </a:pPr>
             <a:r>
@@ -3676,13 +3753,6 @@
             <a:prstDash val="solid"/>
           </a:ln>
         </p:spPr>
-        <p:txBody>
-          <a:bodyPr/>
-          <a:lstStyle/>
-          <a:p>
-            <a:endParaRPr lang="en-US"/>
-          </a:p>
-        </p:txBody>
       </p:sp>
       <p:sp>
         <p:nvSpPr>
@@ -3705,7 +3775,7 @@
           <a:bodyPr wrap="square" lIns="0" tIns="0" rIns="0" bIns="0" rtlCol="0" anchor="ctr"/>
           <a:lstStyle/>
           <a:p>
-            <a:pPr marL="0" indent="0" algn="ctr">
+            <a:pPr algn="ctr" indent="0" marL="0">
               <a:buNone/>
             </a:pPr>
             <a:r>
@@ -3744,7 +3814,7 @@
           <a:bodyPr wrap="square" lIns="0" tIns="0" rIns="0" bIns="0" rtlCol="0" anchor="ctr"/>
           <a:lstStyle/>
           <a:p>
-            <a:pPr marL="0" indent="0" algn="ctr">
+            <a:pPr algn="ctr" indent="0" marL="0">
               <a:buNone/>
             </a:pPr>
             <a:r>
@@ -3786,13 +3856,6 @@
             <a:prstDash val="solid"/>
           </a:ln>
         </p:spPr>
-        <p:txBody>
-          <a:bodyPr/>
-          <a:lstStyle/>
-          <a:p>
-            <a:endParaRPr lang="en-US"/>
-          </a:p>
-        </p:txBody>
       </p:sp>
       <p:sp>
         <p:nvSpPr>
@@ -3815,7 +3878,7 @@
           <a:bodyPr wrap="square" lIns="0" tIns="0" rIns="0" bIns="0" rtlCol="0" anchor="ctr"/>
           <a:lstStyle/>
           <a:p>
-            <a:pPr marL="0" indent="0" algn="ctr">
+            <a:pPr algn="ctr" indent="0" marL="0">
               <a:buNone/>
             </a:pPr>
             <a:r>
@@ -3854,7 +3917,7 @@
           <a:bodyPr wrap="square" lIns="0" tIns="0" rIns="0" bIns="0" rtlCol="0" anchor="ctr"/>
           <a:lstStyle/>
           <a:p>
-            <a:pPr marL="0" indent="0" algn="ctr">
+            <a:pPr algn="ctr" indent="0" marL="0">
               <a:buNone/>
             </a:pPr>
             <a:r>
@@ -3896,13 +3959,6 @@
             <a:prstDash val="solid"/>
           </a:ln>
         </p:spPr>
-        <p:txBody>
-          <a:bodyPr/>
-          <a:lstStyle/>
-          <a:p>
-            <a:endParaRPr lang="en-US"/>
-          </a:p>
-        </p:txBody>
       </p:sp>
       <p:sp>
         <p:nvSpPr>
@@ -3925,7 +3981,7 @@
           <a:bodyPr wrap="square" lIns="0" tIns="0" rIns="0" bIns="0" rtlCol="0" anchor="ctr"/>
           <a:lstStyle/>
           <a:p>
-            <a:pPr marL="0" indent="0">
+            <a:pPr indent="0" marL="0">
               <a:buNone/>
             </a:pPr>
             <a:r>
@@ -3964,7 +4020,7 @@
           <a:bodyPr wrap="square" lIns="0" tIns="0" rIns="0" bIns="0" rtlCol="0" anchor="ctr"/>
           <a:lstStyle/>
           <a:p>
-            <a:pPr marL="0" indent="0">
+            <a:pPr indent="0" marL="0">
               <a:buNone/>
             </a:pPr>
             <a:r>
@@ -4003,7 +4059,7 @@
           <a:bodyPr wrap="square" lIns="0" tIns="0" rIns="0" bIns="0" rtlCol="0" anchor="ctr"/>
           <a:lstStyle/>
           <a:p>
-            <a:pPr marL="0" indent="0">
+            <a:pPr indent="0" marL="0">
               <a:buNone/>
             </a:pPr>
             <a:r>
@@ -4045,13 +4101,6 @@
             <a:prstDash val="solid"/>
           </a:ln>
         </p:spPr>
-        <p:txBody>
-          <a:bodyPr/>
-          <a:lstStyle/>
-          <a:p>
-            <a:endParaRPr lang="en-US"/>
-          </a:p>
-        </p:txBody>
       </p:sp>
       <p:sp>
         <p:nvSpPr>
@@ -4074,7 +4123,7 @@
           <a:bodyPr wrap="square" lIns="0" tIns="0" rIns="0" bIns="0" rtlCol="0" anchor="ctr"/>
           <a:lstStyle/>
           <a:p>
-            <a:pPr marL="0" indent="0">
+            <a:pPr indent="0" marL="0">
               <a:buNone/>
             </a:pPr>
             <a:r>
@@ -4113,7 +4162,7 @@
           <a:bodyPr wrap="square" lIns="0" tIns="0" rIns="0" bIns="0" rtlCol="0" anchor="ctr"/>
           <a:lstStyle/>
           <a:p>
-            <a:pPr marL="0" indent="0">
+            <a:pPr indent="0" marL="0">
               <a:buNone/>
             </a:pPr>
             <a:r>
@@ -4152,7 +4201,7 @@
           <a:bodyPr wrap="square" lIns="0" tIns="0" rIns="0" bIns="0" rtlCol="0" anchor="ctr"/>
           <a:lstStyle/>
           <a:p>
-            <a:pPr marL="0" indent="0">
+            <a:pPr indent="0" marL="0">
               <a:buNone/>
             </a:pPr>
             <a:r>
@@ -4194,13 +4243,6 @@
             <a:prstDash val="solid"/>
           </a:ln>
         </p:spPr>
-        <p:txBody>
-          <a:bodyPr/>
-          <a:lstStyle/>
-          <a:p>
-            <a:endParaRPr lang="en-US"/>
-          </a:p>
-        </p:txBody>
       </p:sp>
       <p:sp>
         <p:nvSpPr>
@@ -4223,7 +4265,7 @@
           <a:bodyPr wrap="square" lIns="0" tIns="0" rIns="0" bIns="0" rtlCol="0" anchor="ctr"/>
           <a:lstStyle/>
           <a:p>
-            <a:pPr marL="0" indent="0">
+            <a:pPr indent="0" marL="0">
               <a:buNone/>
             </a:pPr>
             <a:r>
@@ -4262,7 +4304,7 @@
           <a:bodyPr wrap="square" lIns="0" tIns="0" rIns="0" bIns="0" rtlCol="0" anchor="ctr"/>
           <a:lstStyle/>
           <a:p>
-            <a:pPr marL="0" indent="0">
+            <a:pPr indent="0" marL="0">
               <a:buNone/>
             </a:pPr>
             <a:r>
@@ -4301,7 +4343,7 @@
           <a:bodyPr wrap="square" lIns="0" tIns="0" rIns="0" bIns="0" rtlCol="0" anchor="ctr"/>
           <a:lstStyle/>
           <a:p>
-            <a:pPr marL="0" indent="0">
+            <a:pPr indent="0" marL="0">
               <a:buNone/>
             </a:pPr>
             <a:r>
@@ -4335,7 +4377,6 @@
         <a:solidFill>
           <a:srgbClr val="FFFFFF"/>
         </a:solidFill>
-        <a:effectLst/>
       </p:bgPr>
     </p:bg>
     <p:spTree>
@@ -4373,7 +4414,7 @@
           <a:bodyPr wrap="square" lIns="0" tIns="0" rIns="0" bIns="0" rtlCol="0" anchor="ctr"/>
           <a:lstStyle/>
           <a:p>
-            <a:pPr marL="0" indent="0">
+            <a:pPr indent="0" marL="0">
               <a:buNone/>
             </a:pPr>
             <a:r>
@@ -4415,13 +4456,6 @@
             <a:prstDash val="solid"/>
           </a:ln>
         </p:spPr>
-        <p:txBody>
-          <a:bodyPr/>
-          <a:lstStyle/>
-          <a:p>
-            <a:endParaRPr lang="en-US"/>
-          </a:p>
-        </p:txBody>
       </p:sp>
       <p:sp>
         <p:nvSpPr>
@@ -4444,7 +4478,7 @@
           <a:bodyPr wrap="square" lIns="0" tIns="0" rIns="0" bIns="0" rtlCol="0" anchor="ctr"/>
           <a:lstStyle/>
           <a:p>
-            <a:pPr marL="0" indent="0" algn="ctr">
+            <a:pPr algn="ctr" indent="0" marL="0">
               <a:buNone/>
             </a:pPr>
             <a:r>
@@ -4483,7 +4517,7 @@
           <a:bodyPr wrap="square" lIns="0" tIns="0" rIns="0" bIns="0" rtlCol="0" anchor="ctr"/>
           <a:lstStyle/>
           <a:p>
-            <a:pPr marL="0" indent="0" algn="ctr">
+            <a:pPr algn="ctr" indent="0" marL="0">
               <a:buNone/>
             </a:pPr>
             <a:r>
@@ -4525,13 +4559,6 @@
             <a:prstDash val="solid"/>
           </a:ln>
         </p:spPr>
-        <p:txBody>
-          <a:bodyPr/>
-          <a:lstStyle/>
-          <a:p>
-            <a:endParaRPr lang="en-US"/>
-          </a:p>
-        </p:txBody>
       </p:sp>
       <p:sp>
         <p:nvSpPr>
@@ -4554,7 +4581,7 @@
           <a:bodyPr wrap="square" lIns="0" tIns="0" rIns="0" bIns="0" rtlCol="0" anchor="ctr"/>
           <a:lstStyle/>
           <a:p>
-            <a:pPr marL="0" indent="0" algn="ctr">
+            <a:pPr algn="ctr" indent="0" marL="0">
               <a:buNone/>
             </a:pPr>
             <a:r>
@@ -4593,7 +4620,7 @@
           <a:bodyPr wrap="square" lIns="0" tIns="0" rIns="0" bIns="0" rtlCol="0" anchor="ctr"/>
           <a:lstStyle/>
           <a:p>
-            <a:pPr marL="0" indent="0" algn="ctr">
+            <a:pPr algn="ctr" indent="0" marL="0">
               <a:buNone/>
             </a:pPr>
             <a:r>
@@ -4635,13 +4662,6 @@
             <a:prstDash val="solid"/>
           </a:ln>
         </p:spPr>
-        <p:txBody>
-          <a:bodyPr/>
-          <a:lstStyle/>
-          <a:p>
-            <a:endParaRPr lang="en-US"/>
-          </a:p>
-        </p:txBody>
       </p:sp>
       <p:sp>
         <p:nvSpPr>
@@ -4664,7 +4684,7 @@
           <a:bodyPr wrap="square" lIns="0" tIns="0" rIns="0" bIns="0" rtlCol="0" anchor="ctr"/>
           <a:lstStyle/>
           <a:p>
-            <a:pPr marL="0" indent="0" algn="ctr">
+            <a:pPr algn="ctr" indent="0" marL="0">
               <a:buNone/>
             </a:pPr>
             <a:r>
@@ -4703,7 +4723,7 @@
           <a:bodyPr wrap="square" lIns="0" tIns="0" rIns="0" bIns="0" rtlCol="0" anchor="ctr"/>
           <a:lstStyle/>
           <a:p>
-            <a:pPr marL="0" indent="0" algn="ctr">
+            <a:pPr algn="ctr" indent="0" marL="0">
               <a:buNone/>
             </a:pPr>
             <a:r>
@@ -4745,13 +4765,6 @@
             <a:prstDash val="solid"/>
           </a:ln>
         </p:spPr>
-        <p:txBody>
-          <a:bodyPr/>
-          <a:lstStyle/>
-          <a:p>
-            <a:endParaRPr lang="en-US"/>
-          </a:p>
-        </p:txBody>
       </p:sp>
       <p:sp>
         <p:nvSpPr>
@@ -4774,7 +4787,7 @@
           <a:bodyPr wrap="square" lIns="0" tIns="0" rIns="0" bIns="0" rtlCol="0" anchor="ctr"/>
           <a:lstStyle/>
           <a:p>
-            <a:pPr marL="0" indent="0" algn="ctr">
+            <a:pPr algn="ctr" indent="0" marL="0">
               <a:buNone/>
             </a:pPr>
             <a:r>
@@ -4813,7 +4826,7 @@
           <a:bodyPr wrap="square" lIns="0" tIns="0" rIns="0" bIns="0" rtlCol="0" anchor="ctr"/>
           <a:lstStyle/>
           <a:p>
-            <a:pPr marL="0" indent="0" algn="ctr">
+            <a:pPr algn="ctr" indent="0" marL="0">
               <a:buNone/>
             </a:pPr>
             <a:r>
@@ -4839,7 +4852,7 @@
         </p:nvSpPr>
         <p:spPr>
           <a:xfrm>
-            <a:off x="548640" y="2522765"/>
+            <a:off x="548640" y="2377440"/>
             <a:ext cx="4572000" cy="320040"/>
           </a:xfrm>
           <a:prstGeom prst="rect">
@@ -4852,7 +4865,7 @@
           <a:bodyPr wrap="square" lIns="0" tIns="0" rIns="0" bIns="0" rtlCol="0" anchor="ctr"/>
           <a:lstStyle/>
           <a:p>
-            <a:pPr marL="0" indent="0">
+            <a:pPr indent="0" marL="0">
               <a:buNone/>
             </a:pPr>
             <a:r>
@@ -4870,734 +4883,629 @@
           </a:p>
         </p:txBody>
       </p:sp>
-      <p:grpSp>
-        <p:nvGrpSpPr>
-          <p:cNvPr id="36" name="Group 35">
-            <a:extLst>
-              <a:ext uri="{FF2B5EF4-FFF2-40B4-BE49-F238E27FC236}">
-                <a16:creationId xmlns:a16="http://schemas.microsoft.com/office/drawing/2014/main" id="{910519FF-A8C6-9DA0-F68E-BDFF4A18C4D3}"/>
-              </a:ext>
-            </a:extLst>
-          </p:cNvPr>
-          <p:cNvGrpSpPr/>
-          <p:nvPr/>
-        </p:nvGrpSpPr>
-        <p:grpSpPr>
-          <a:xfrm>
-            <a:off x="548639" y="2983230"/>
-            <a:ext cx="4807131" cy="1536192"/>
-            <a:chOff x="548640" y="2834640"/>
-            <a:chExt cx="8183880" cy="1792224"/>
-          </a:xfrm>
-        </p:grpSpPr>
-        <p:sp>
-          <p:nvSpPr>
-            <p:cNvPr id="16" name="Text 14"/>
-            <p:cNvSpPr/>
-            <p:nvPr/>
-          </p:nvSpPr>
-          <p:spPr>
-            <a:xfrm>
-              <a:off x="548640" y="2834640"/>
-              <a:ext cx="2286000" cy="256032"/>
-            </a:xfrm>
-            <a:prstGeom prst="rect">
-              <a:avLst/>
-            </a:prstGeom>
-            <a:noFill/>
-            <a:ln/>
-          </p:spPr>
-          <p:txBody>
-            <a:bodyPr wrap="square" lIns="0" tIns="0" rIns="0" bIns="0" rtlCol="0" anchor="ctr"/>
-            <a:lstStyle/>
-            <a:p>
-              <a:pPr marL="0" indent="0">
-                <a:buNone/>
-              </a:pPr>
-              <a:r>
-                <a:rPr lang="en-US" sz="1000" dirty="0">
-                  <a:solidFill>
-                    <a:srgbClr val="2C3E35"/>
-                  </a:solidFill>
-                  <a:latin typeface="Poppins" pitchFamily="34" charset="0"/>
-                  <a:ea typeface="Poppins" pitchFamily="34" charset="-122"/>
-                  <a:cs typeface="Poppins" pitchFamily="34" charset="-120"/>
-                </a:rPr>
-                <a:t>Mobile money users</a:t>
-              </a:r>
-              <a:endParaRPr lang="en-US" sz="1000" dirty="0"/>
-            </a:p>
-          </p:txBody>
-        </p:sp>
-        <p:sp>
-          <p:nvSpPr>
-            <p:cNvPr id="17" name="Text 15"/>
-            <p:cNvSpPr/>
-            <p:nvPr/>
-          </p:nvSpPr>
-          <p:spPr>
-            <a:xfrm>
-              <a:off x="8229600" y="2834640"/>
-              <a:ext cx="502920" cy="256032"/>
-            </a:xfrm>
-            <a:prstGeom prst="rect">
-              <a:avLst/>
-            </a:prstGeom>
-            <a:noFill/>
-            <a:ln/>
-          </p:spPr>
-          <p:txBody>
-            <a:bodyPr wrap="square" lIns="0" tIns="0" rIns="0" bIns="0" rtlCol="0" anchor="ctr"/>
-            <a:lstStyle/>
-            <a:p>
-              <a:pPr marL="0" indent="0" algn="r">
-                <a:buNone/>
-              </a:pPr>
-              <a:r>
-                <a:rPr lang="en-US" sz="1000" b="1" dirty="0">
-                  <a:solidFill>
-                    <a:srgbClr val="2A7F6F"/>
-                  </a:solidFill>
-                  <a:latin typeface="Poppins" pitchFamily="34" charset="0"/>
-                  <a:ea typeface="Poppins" pitchFamily="34" charset="-122"/>
-                  <a:cs typeface="Poppins" pitchFamily="34" charset="-120"/>
-                </a:rPr>
-                <a:t>95%</a:t>
-              </a:r>
-              <a:endParaRPr lang="en-US" sz="1000" dirty="0"/>
-            </a:p>
-          </p:txBody>
-        </p:sp>
-        <p:sp>
-          <p:nvSpPr>
-            <p:cNvPr id="18" name="Shape 16"/>
-            <p:cNvSpPr/>
-            <p:nvPr/>
-          </p:nvSpPr>
-          <p:spPr>
-            <a:xfrm>
-              <a:off x="2926080" y="2880360"/>
-              <a:ext cx="5349240" cy="128016"/>
-            </a:xfrm>
-            <a:prstGeom prst="rect">
-              <a:avLst/>
-            </a:prstGeom>
+      <p:sp>
+        <p:nvSpPr>
+          <p:cNvPr id="16" name="Text 14"/>
+          <p:cNvSpPr/>
+          <p:nvPr/>
+        </p:nvSpPr>
+        <p:spPr>
+          <a:xfrm>
+            <a:off x="548640" y="2834640"/>
+            <a:ext cx="2286000" cy="256032"/>
+          </a:xfrm>
+          <a:prstGeom prst="rect">
+            <a:avLst/>
+          </a:prstGeom>
+          <a:noFill/>
+          <a:ln/>
+        </p:spPr>
+        <p:txBody>
+          <a:bodyPr wrap="square" lIns="0" tIns="0" rIns="0" bIns="0" rtlCol="0" anchor="ctr"/>
+          <a:lstStyle/>
+          <a:p>
+            <a:pPr indent="0" marL="0">
+              <a:buNone/>
+            </a:pPr>
+            <a:r>
+              <a:rPr lang="en-US" sz="1000" dirty="0">
+                <a:solidFill>
+                  <a:srgbClr val="2C3E35"/>
+                </a:solidFill>
+                <a:latin typeface="Poppins" pitchFamily="34" charset="0"/>
+                <a:ea typeface="Poppins" pitchFamily="34" charset="-122"/>
+                <a:cs typeface="Poppins" pitchFamily="34" charset="-120"/>
+              </a:rPr>
+              <a:t>Mobile money users</a:t>
+            </a:r>
+            <a:endParaRPr lang="en-US" sz="1000" dirty="0"/>
+          </a:p>
+        </p:txBody>
+      </p:sp>
+      <p:sp>
+        <p:nvSpPr>
+          <p:cNvPr id="17" name="Text 15"/>
+          <p:cNvSpPr/>
+          <p:nvPr/>
+        </p:nvSpPr>
+        <p:spPr>
+          <a:xfrm>
+            <a:off x="8229600" y="2834640"/>
+            <a:ext cx="502920" cy="256032"/>
+          </a:xfrm>
+          <a:prstGeom prst="rect">
+            <a:avLst/>
+          </a:prstGeom>
+          <a:noFill/>
+          <a:ln/>
+        </p:spPr>
+        <p:txBody>
+          <a:bodyPr wrap="square" lIns="0" tIns="0" rIns="0" bIns="0" rtlCol="0" anchor="ctr"/>
+          <a:lstStyle/>
+          <a:p>
+            <a:pPr algn="r" indent="0" marL="0">
+              <a:buNone/>
+            </a:pPr>
+            <a:r>
+              <a:rPr lang="en-US" sz="1000" b="1" dirty="0">
+                <a:solidFill>
+                  <a:srgbClr val="2A7F6F"/>
+                </a:solidFill>
+                <a:latin typeface="Poppins" pitchFamily="34" charset="0"/>
+                <a:ea typeface="Poppins" pitchFamily="34" charset="-122"/>
+                <a:cs typeface="Poppins" pitchFamily="34" charset="-120"/>
+              </a:rPr>
+              <a:t>95%</a:t>
+            </a:r>
+            <a:endParaRPr lang="en-US" sz="1000" dirty="0"/>
+          </a:p>
+        </p:txBody>
+      </p:sp>
+      <p:sp>
+        <p:nvSpPr>
+          <p:cNvPr id="18" name="Shape 16"/>
+          <p:cNvSpPr/>
+          <p:nvPr/>
+        </p:nvSpPr>
+        <p:spPr>
+          <a:xfrm>
+            <a:off x="2926080" y="2880360"/>
+            <a:ext cx="5349240" cy="128016"/>
+          </a:xfrm>
+          <a:prstGeom prst="rect">
+            <a:avLst/>
+          </a:prstGeom>
+          <a:solidFill>
+            <a:srgbClr val="EDF2F0"/>
+          </a:solidFill>
+          <a:ln w="12700">
             <a:solidFill>
               <a:srgbClr val="EDF2F0"/>
             </a:solidFill>
-            <a:ln w="12700">
-              <a:solidFill>
-                <a:srgbClr val="EDF2F0"/>
-              </a:solidFill>
-              <a:prstDash val="solid"/>
-            </a:ln>
-          </p:spPr>
-          <p:txBody>
-            <a:bodyPr/>
-            <a:lstStyle/>
-            <a:p>
-              <a:endParaRPr lang="en-US"/>
-            </a:p>
-          </p:txBody>
-        </p:sp>
-        <p:sp>
-          <p:nvSpPr>
-            <p:cNvPr id="19" name="Shape 17"/>
-            <p:cNvSpPr/>
-            <p:nvPr/>
-          </p:nvSpPr>
-          <p:spPr>
-            <a:xfrm>
-              <a:off x="2926080" y="2880360"/>
-              <a:ext cx="5081778" cy="128016"/>
-            </a:xfrm>
-            <a:prstGeom prst="rect">
-              <a:avLst/>
-            </a:prstGeom>
+            <a:prstDash val="solid"/>
+          </a:ln>
+        </p:spPr>
+      </p:sp>
+      <p:sp>
+        <p:nvSpPr>
+          <p:cNvPr id="19" name="Shape 17"/>
+          <p:cNvSpPr/>
+          <p:nvPr/>
+        </p:nvSpPr>
+        <p:spPr>
+          <a:xfrm>
+            <a:off x="2926080" y="2880360"/>
+            <a:ext cx="5081778" cy="128016"/>
+          </a:xfrm>
+          <a:prstGeom prst="rect">
+            <a:avLst/>
+          </a:prstGeom>
+          <a:solidFill>
+            <a:srgbClr val="2A7F6F"/>
+          </a:solidFill>
+          <a:ln w="12700">
             <a:solidFill>
               <a:srgbClr val="2A7F6F"/>
             </a:solidFill>
-            <a:ln w="12700">
-              <a:solidFill>
-                <a:srgbClr val="2A7F6F"/>
-              </a:solidFill>
-              <a:prstDash val="solid"/>
-            </a:ln>
-          </p:spPr>
-          <p:txBody>
-            <a:bodyPr/>
-            <a:lstStyle/>
-            <a:p>
-              <a:endParaRPr lang="en-US"/>
-            </a:p>
-          </p:txBody>
-        </p:sp>
-        <p:sp>
-          <p:nvSpPr>
-            <p:cNvPr id="20" name="Text 18"/>
-            <p:cNvSpPr/>
-            <p:nvPr/>
-          </p:nvSpPr>
-          <p:spPr>
-            <a:xfrm>
-              <a:off x="548640" y="3346704"/>
-              <a:ext cx="2286000" cy="256032"/>
-            </a:xfrm>
-            <a:prstGeom prst="rect">
-              <a:avLst/>
-            </a:prstGeom>
-            <a:noFill/>
-            <a:ln/>
-          </p:spPr>
-          <p:txBody>
-            <a:bodyPr wrap="square" lIns="0" tIns="0" rIns="0" bIns="0" rtlCol="0" anchor="ctr"/>
-            <a:lstStyle/>
-            <a:p>
-              <a:pPr marL="0" indent="0">
-                <a:buNone/>
-              </a:pPr>
-              <a:r>
-                <a:rPr lang="en-US" sz="1000" dirty="0">
-                  <a:solidFill>
-                    <a:srgbClr val="2C3E35"/>
-                  </a:solidFill>
-                  <a:latin typeface="Poppins" pitchFamily="34" charset="0"/>
-                  <a:ea typeface="Poppins" pitchFamily="34" charset="-122"/>
-                  <a:cs typeface="Poppins" pitchFamily="34" charset="-120"/>
-                </a:rPr>
-                <a:t>Mobile coverage</a:t>
-              </a:r>
-              <a:endParaRPr lang="en-US" sz="1000" dirty="0"/>
-            </a:p>
-          </p:txBody>
-        </p:sp>
-        <p:sp>
-          <p:nvSpPr>
-            <p:cNvPr id="21" name="Text 19"/>
-            <p:cNvSpPr/>
-            <p:nvPr/>
-          </p:nvSpPr>
-          <p:spPr>
-            <a:xfrm>
-              <a:off x="8229600" y="3346704"/>
-              <a:ext cx="502920" cy="256032"/>
-            </a:xfrm>
-            <a:prstGeom prst="rect">
-              <a:avLst/>
-            </a:prstGeom>
-            <a:noFill/>
-            <a:ln/>
-          </p:spPr>
-          <p:txBody>
-            <a:bodyPr wrap="square" lIns="0" tIns="0" rIns="0" bIns="0" rtlCol="0" anchor="ctr"/>
-            <a:lstStyle/>
-            <a:p>
-              <a:pPr marL="0" indent="0" algn="r">
-                <a:buNone/>
-              </a:pPr>
-              <a:r>
-                <a:rPr lang="en-US" sz="1000" b="1" dirty="0">
-                  <a:solidFill>
-                    <a:srgbClr val="2A7F6F"/>
-                  </a:solidFill>
-                  <a:latin typeface="Poppins" pitchFamily="34" charset="0"/>
-                  <a:ea typeface="Poppins" pitchFamily="34" charset="-122"/>
-                  <a:cs typeface="Poppins" pitchFamily="34" charset="-120"/>
-                </a:rPr>
-                <a:t>92%</a:t>
-              </a:r>
-              <a:endParaRPr lang="en-US" sz="1000" dirty="0"/>
-            </a:p>
-          </p:txBody>
-        </p:sp>
-        <p:sp>
-          <p:nvSpPr>
-            <p:cNvPr id="22" name="Shape 20"/>
-            <p:cNvSpPr/>
-            <p:nvPr/>
-          </p:nvSpPr>
-          <p:spPr>
-            <a:xfrm>
-              <a:off x="2926080" y="3392424"/>
-              <a:ext cx="5349240" cy="128016"/>
-            </a:xfrm>
-            <a:prstGeom prst="rect">
-              <a:avLst/>
-            </a:prstGeom>
+            <a:prstDash val="solid"/>
+          </a:ln>
+        </p:spPr>
+      </p:sp>
+      <p:sp>
+        <p:nvSpPr>
+          <p:cNvPr id="20" name="Text 18"/>
+          <p:cNvSpPr/>
+          <p:nvPr/>
+        </p:nvSpPr>
+        <p:spPr>
+          <a:xfrm>
+            <a:off x="548640" y="3346704"/>
+            <a:ext cx="2286000" cy="256032"/>
+          </a:xfrm>
+          <a:prstGeom prst="rect">
+            <a:avLst/>
+          </a:prstGeom>
+          <a:noFill/>
+          <a:ln/>
+        </p:spPr>
+        <p:txBody>
+          <a:bodyPr wrap="square" lIns="0" tIns="0" rIns="0" bIns="0" rtlCol="0" anchor="ctr"/>
+          <a:lstStyle/>
+          <a:p>
+            <a:pPr indent="0" marL="0">
+              <a:buNone/>
+            </a:pPr>
+            <a:r>
+              <a:rPr lang="en-US" sz="1000" dirty="0">
+                <a:solidFill>
+                  <a:srgbClr val="2C3E35"/>
+                </a:solidFill>
+                <a:latin typeface="Poppins" pitchFamily="34" charset="0"/>
+                <a:ea typeface="Poppins" pitchFamily="34" charset="-122"/>
+                <a:cs typeface="Poppins" pitchFamily="34" charset="-120"/>
+              </a:rPr>
+              <a:t>Mobile coverage</a:t>
+            </a:r>
+            <a:endParaRPr lang="en-US" sz="1000" dirty="0"/>
+          </a:p>
+        </p:txBody>
+      </p:sp>
+      <p:sp>
+        <p:nvSpPr>
+          <p:cNvPr id="21" name="Text 19"/>
+          <p:cNvSpPr/>
+          <p:nvPr/>
+        </p:nvSpPr>
+        <p:spPr>
+          <a:xfrm>
+            <a:off x="8229600" y="3346704"/>
+            <a:ext cx="502920" cy="256032"/>
+          </a:xfrm>
+          <a:prstGeom prst="rect">
+            <a:avLst/>
+          </a:prstGeom>
+          <a:noFill/>
+          <a:ln/>
+        </p:spPr>
+        <p:txBody>
+          <a:bodyPr wrap="square" lIns="0" tIns="0" rIns="0" bIns="0" rtlCol="0" anchor="ctr"/>
+          <a:lstStyle/>
+          <a:p>
+            <a:pPr algn="r" indent="0" marL="0">
+              <a:buNone/>
+            </a:pPr>
+            <a:r>
+              <a:rPr lang="en-US" sz="1000" b="1" dirty="0">
+                <a:solidFill>
+                  <a:srgbClr val="2A7F6F"/>
+                </a:solidFill>
+                <a:latin typeface="Poppins" pitchFamily="34" charset="0"/>
+                <a:ea typeface="Poppins" pitchFamily="34" charset="-122"/>
+                <a:cs typeface="Poppins" pitchFamily="34" charset="-120"/>
+              </a:rPr>
+              <a:t>92%</a:t>
+            </a:r>
+            <a:endParaRPr lang="en-US" sz="1000" dirty="0"/>
+          </a:p>
+        </p:txBody>
+      </p:sp>
+      <p:sp>
+        <p:nvSpPr>
+          <p:cNvPr id="22" name="Shape 20"/>
+          <p:cNvSpPr/>
+          <p:nvPr/>
+        </p:nvSpPr>
+        <p:spPr>
+          <a:xfrm>
+            <a:off x="2926080" y="3392424"/>
+            <a:ext cx="5349240" cy="128016"/>
+          </a:xfrm>
+          <a:prstGeom prst="rect">
+            <a:avLst/>
+          </a:prstGeom>
+          <a:solidFill>
+            <a:srgbClr val="EDF2F0"/>
+          </a:solidFill>
+          <a:ln w="12700">
             <a:solidFill>
               <a:srgbClr val="EDF2F0"/>
             </a:solidFill>
-            <a:ln w="12700">
-              <a:solidFill>
-                <a:srgbClr val="EDF2F0"/>
-              </a:solidFill>
-              <a:prstDash val="solid"/>
-            </a:ln>
-          </p:spPr>
-          <p:txBody>
-            <a:bodyPr/>
-            <a:lstStyle/>
-            <a:p>
-              <a:endParaRPr lang="en-US"/>
-            </a:p>
-          </p:txBody>
-        </p:sp>
-        <p:sp>
-          <p:nvSpPr>
-            <p:cNvPr id="23" name="Shape 21"/>
-            <p:cNvSpPr/>
-            <p:nvPr/>
-          </p:nvSpPr>
-          <p:spPr>
-            <a:xfrm>
-              <a:off x="2926080" y="3392424"/>
-              <a:ext cx="4921301" cy="128016"/>
-            </a:xfrm>
-            <a:prstGeom prst="rect">
-              <a:avLst/>
-            </a:prstGeom>
+            <a:prstDash val="solid"/>
+          </a:ln>
+        </p:spPr>
+      </p:sp>
+      <p:sp>
+        <p:nvSpPr>
+          <p:cNvPr id="23" name="Shape 21"/>
+          <p:cNvSpPr/>
+          <p:nvPr/>
+        </p:nvSpPr>
+        <p:spPr>
+          <a:xfrm>
+            <a:off x="2926080" y="3392424"/>
+            <a:ext cx="4921301" cy="128016"/>
+          </a:xfrm>
+          <a:prstGeom prst="rect">
+            <a:avLst/>
+          </a:prstGeom>
+          <a:solidFill>
+            <a:srgbClr val="2A7F6F"/>
+          </a:solidFill>
+          <a:ln w="12700">
             <a:solidFill>
               <a:srgbClr val="2A7F6F"/>
             </a:solidFill>
-            <a:ln w="12700">
-              <a:solidFill>
-                <a:srgbClr val="2A7F6F"/>
-              </a:solidFill>
-              <a:prstDash val="solid"/>
-            </a:ln>
-          </p:spPr>
-          <p:txBody>
-            <a:bodyPr/>
-            <a:lstStyle/>
-            <a:p>
-              <a:endParaRPr lang="en-US"/>
-            </a:p>
-          </p:txBody>
-        </p:sp>
-        <p:sp>
-          <p:nvSpPr>
-            <p:cNvPr id="24" name="Text 22"/>
-            <p:cNvSpPr/>
-            <p:nvPr/>
-          </p:nvSpPr>
-          <p:spPr>
-            <a:xfrm>
-              <a:off x="548640" y="3858768"/>
-              <a:ext cx="2286000" cy="256032"/>
-            </a:xfrm>
-            <a:prstGeom prst="rect">
-              <a:avLst/>
-            </a:prstGeom>
-            <a:noFill/>
-            <a:ln/>
-          </p:spPr>
-          <p:txBody>
-            <a:bodyPr wrap="square" lIns="0" tIns="0" rIns="0" bIns="0" rtlCol="0" anchor="ctr"/>
-            <a:lstStyle/>
-            <a:p>
-              <a:pPr marL="0" indent="0">
-                <a:buNone/>
-              </a:pPr>
-              <a:r>
-                <a:rPr lang="en-US" sz="1000" dirty="0">
-                  <a:solidFill>
-                    <a:srgbClr val="2C3E35"/>
-                  </a:solidFill>
-                  <a:latin typeface="Poppins" pitchFamily="34" charset="0"/>
-                  <a:ea typeface="Poppins" pitchFamily="34" charset="-122"/>
-                  <a:cs typeface="Poppins" pitchFamily="34" charset="-120"/>
-                </a:rPr>
-                <a:t>Internet users</a:t>
-              </a:r>
-              <a:endParaRPr lang="en-US" sz="1000" dirty="0"/>
-            </a:p>
-          </p:txBody>
-        </p:sp>
-        <p:sp>
-          <p:nvSpPr>
-            <p:cNvPr id="25" name="Text 23"/>
-            <p:cNvSpPr/>
-            <p:nvPr/>
-          </p:nvSpPr>
-          <p:spPr>
-            <a:xfrm>
-              <a:off x="8229600" y="3858768"/>
-              <a:ext cx="502920" cy="256032"/>
-            </a:xfrm>
-            <a:prstGeom prst="rect">
-              <a:avLst/>
-            </a:prstGeom>
-            <a:noFill/>
-            <a:ln/>
-          </p:spPr>
-          <p:txBody>
-            <a:bodyPr wrap="square" lIns="0" tIns="0" rIns="0" bIns="0" rtlCol="0" anchor="ctr"/>
-            <a:lstStyle/>
-            <a:p>
-              <a:pPr marL="0" indent="0" algn="r">
-                <a:buNone/>
-              </a:pPr>
-              <a:r>
-                <a:rPr lang="en-US" sz="1000" b="1" dirty="0">
-                  <a:solidFill>
-                    <a:srgbClr val="2A7F6F"/>
-                  </a:solidFill>
-                  <a:latin typeface="Poppins" pitchFamily="34" charset="0"/>
-                  <a:ea typeface="Poppins" pitchFamily="34" charset="-122"/>
-                  <a:cs typeface="Poppins" pitchFamily="34" charset="-120"/>
-                </a:rPr>
-                <a:t>33%</a:t>
-              </a:r>
-              <a:endParaRPr lang="en-US" sz="1000" dirty="0"/>
-            </a:p>
-          </p:txBody>
-        </p:sp>
-        <p:sp>
-          <p:nvSpPr>
-            <p:cNvPr id="26" name="Shape 24"/>
-            <p:cNvSpPr/>
-            <p:nvPr/>
-          </p:nvSpPr>
-          <p:spPr>
-            <a:xfrm>
-              <a:off x="2926080" y="3904488"/>
-              <a:ext cx="5349240" cy="128016"/>
-            </a:xfrm>
-            <a:prstGeom prst="rect">
-              <a:avLst/>
-            </a:prstGeom>
+            <a:prstDash val="solid"/>
+          </a:ln>
+        </p:spPr>
+      </p:sp>
+      <p:sp>
+        <p:nvSpPr>
+          <p:cNvPr id="24" name="Text 22"/>
+          <p:cNvSpPr/>
+          <p:nvPr/>
+        </p:nvSpPr>
+        <p:spPr>
+          <a:xfrm>
+            <a:off x="548640" y="3858768"/>
+            <a:ext cx="2286000" cy="256032"/>
+          </a:xfrm>
+          <a:prstGeom prst="rect">
+            <a:avLst/>
+          </a:prstGeom>
+          <a:noFill/>
+          <a:ln/>
+        </p:spPr>
+        <p:txBody>
+          <a:bodyPr wrap="square" lIns="0" tIns="0" rIns="0" bIns="0" rtlCol="0" anchor="ctr"/>
+          <a:lstStyle/>
+          <a:p>
+            <a:pPr indent="0" marL="0">
+              <a:buNone/>
+            </a:pPr>
+            <a:r>
+              <a:rPr lang="en-US" sz="1000" dirty="0">
+                <a:solidFill>
+                  <a:srgbClr val="2C3E35"/>
+                </a:solidFill>
+                <a:latin typeface="Poppins" pitchFamily="34" charset="0"/>
+                <a:ea typeface="Poppins" pitchFamily="34" charset="-122"/>
+                <a:cs typeface="Poppins" pitchFamily="34" charset="-120"/>
+              </a:rPr>
+              <a:t>Internet users</a:t>
+            </a:r>
+            <a:endParaRPr lang="en-US" sz="1000" dirty="0"/>
+          </a:p>
+        </p:txBody>
+      </p:sp>
+      <p:sp>
+        <p:nvSpPr>
+          <p:cNvPr id="25" name="Text 23"/>
+          <p:cNvSpPr/>
+          <p:nvPr/>
+        </p:nvSpPr>
+        <p:spPr>
+          <a:xfrm>
+            <a:off x="8229600" y="3858768"/>
+            <a:ext cx="502920" cy="256032"/>
+          </a:xfrm>
+          <a:prstGeom prst="rect">
+            <a:avLst/>
+          </a:prstGeom>
+          <a:noFill/>
+          <a:ln/>
+        </p:spPr>
+        <p:txBody>
+          <a:bodyPr wrap="square" lIns="0" tIns="0" rIns="0" bIns="0" rtlCol="0" anchor="ctr"/>
+          <a:lstStyle/>
+          <a:p>
+            <a:pPr algn="r" indent="0" marL="0">
+              <a:buNone/>
+            </a:pPr>
+            <a:r>
+              <a:rPr lang="en-US" sz="1000" b="1" dirty="0">
+                <a:solidFill>
+                  <a:srgbClr val="2A7F6F"/>
+                </a:solidFill>
+                <a:latin typeface="Poppins" pitchFamily="34" charset="0"/>
+                <a:ea typeface="Poppins" pitchFamily="34" charset="-122"/>
+                <a:cs typeface="Poppins" pitchFamily="34" charset="-120"/>
+              </a:rPr>
+              <a:t>33%</a:t>
+            </a:r>
+            <a:endParaRPr lang="en-US" sz="1000" dirty="0"/>
+          </a:p>
+        </p:txBody>
+      </p:sp>
+      <p:sp>
+        <p:nvSpPr>
+          <p:cNvPr id="26" name="Shape 24"/>
+          <p:cNvSpPr/>
+          <p:nvPr/>
+        </p:nvSpPr>
+        <p:spPr>
+          <a:xfrm>
+            <a:off x="2926080" y="3904488"/>
+            <a:ext cx="5349240" cy="128016"/>
+          </a:xfrm>
+          <a:prstGeom prst="rect">
+            <a:avLst/>
+          </a:prstGeom>
+          <a:solidFill>
+            <a:srgbClr val="EDF2F0"/>
+          </a:solidFill>
+          <a:ln w="12700">
             <a:solidFill>
               <a:srgbClr val="EDF2F0"/>
             </a:solidFill>
-            <a:ln w="12700">
-              <a:solidFill>
-                <a:srgbClr val="EDF2F0"/>
-              </a:solidFill>
-              <a:prstDash val="solid"/>
-            </a:ln>
-          </p:spPr>
-          <p:txBody>
-            <a:bodyPr/>
-            <a:lstStyle/>
-            <a:p>
-              <a:endParaRPr lang="en-US"/>
-            </a:p>
-          </p:txBody>
-        </p:sp>
-        <p:sp>
-          <p:nvSpPr>
-            <p:cNvPr id="27" name="Shape 25"/>
-            <p:cNvSpPr/>
-            <p:nvPr/>
-          </p:nvSpPr>
-          <p:spPr>
-            <a:xfrm>
-              <a:off x="2926080" y="3904488"/>
-              <a:ext cx="1765249" cy="128016"/>
-            </a:xfrm>
-            <a:prstGeom prst="rect">
-              <a:avLst/>
-            </a:prstGeom>
+            <a:prstDash val="solid"/>
+          </a:ln>
+        </p:spPr>
+      </p:sp>
+      <p:sp>
+        <p:nvSpPr>
+          <p:cNvPr id="27" name="Shape 25"/>
+          <p:cNvSpPr/>
+          <p:nvPr/>
+        </p:nvSpPr>
+        <p:spPr>
+          <a:xfrm>
+            <a:off x="2926080" y="3904488"/>
+            <a:ext cx="1765249" cy="128016"/>
+          </a:xfrm>
+          <a:prstGeom prst="rect">
+            <a:avLst/>
+          </a:prstGeom>
+          <a:solidFill>
+            <a:srgbClr val="2A7F6F">
+              <a:alpha val="60000"/>
+            </a:srgbClr>
+          </a:solidFill>
+          <a:ln w="12700">
             <a:solidFill>
               <a:srgbClr val="2A7F6F">
                 <a:alpha val="60000"/>
               </a:srgbClr>
             </a:solidFill>
-            <a:ln w="12700">
-              <a:solidFill>
-                <a:srgbClr val="2A7F6F">
-                  <a:alpha val="60000"/>
-                </a:srgbClr>
-              </a:solidFill>
-              <a:prstDash val="solid"/>
-            </a:ln>
-          </p:spPr>
-          <p:txBody>
-            <a:bodyPr/>
-            <a:lstStyle/>
-            <a:p>
-              <a:endParaRPr lang="en-US"/>
-            </a:p>
-          </p:txBody>
-        </p:sp>
-        <p:sp>
-          <p:nvSpPr>
-            <p:cNvPr id="28" name="Text 26"/>
-            <p:cNvSpPr/>
-            <p:nvPr/>
-          </p:nvSpPr>
-          <p:spPr>
-            <a:xfrm>
-              <a:off x="548640" y="4370832"/>
-              <a:ext cx="2286000" cy="256032"/>
-            </a:xfrm>
-            <a:prstGeom prst="rect">
-              <a:avLst/>
-            </a:prstGeom>
-            <a:noFill/>
-            <a:ln/>
-          </p:spPr>
-          <p:txBody>
-            <a:bodyPr wrap="square" lIns="0" tIns="0" rIns="0" bIns="0" rtlCol="0" anchor="ctr"/>
-            <a:lstStyle/>
-            <a:p>
-              <a:pPr marL="0" indent="0">
-                <a:buNone/>
-              </a:pPr>
-              <a:r>
-                <a:rPr lang="en-US" sz="1000" dirty="0">
-                  <a:solidFill>
-                    <a:srgbClr val="2C3E35"/>
-                  </a:solidFill>
-                  <a:latin typeface="Poppins" pitchFamily="34" charset="0"/>
-                  <a:ea typeface="Poppins" pitchFamily="34" charset="-122"/>
-                  <a:cs typeface="Poppins" pitchFamily="34" charset="-120"/>
-                </a:rPr>
-                <a:t>Bank account holders</a:t>
-              </a:r>
-              <a:endParaRPr lang="en-US" sz="1000" dirty="0"/>
-            </a:p>
-          </p:txBody>
-        </p:sp>
-        <p:sp>
-          <p:nvSpPr>
-            <p:cNvPr id="29" name="Text 27"/>
-            <p:cNvSpPr/>
-            <p:nvPr/>
-          </p:nvSpPr>
-          <p:spPr>
-            <a:xfrm>
-              <a:off x="8229600" y="4370832"/>
-              <a:ext cx="502920" cy="256032"/>
-            </a:xfrm>
-            <a:prstGeom prst="rect">
-              <a:avLst/>
-            </a:prstGeom>
-            <a:noFill/>
-            <a:ln/>
-          </p:spPr>
-          <p:txBody>
-            <a:bodyPr wrap="square" lIns="0" tIns="0" rIns="0" bIns="0" rtlCol="0" anchor="ctr"/>
-            <a:lstStyle/>
-            <a:p>
-              <a:pPr marL="0" indent="0" algn="r">
-                <a:buNone/>
-              </a:pPr>
-              <a:r>
-                <a:rPr lang="en-US" sz="1000" b="1" dirty="0">
-                  <a:solidFill>
-                    <a:srgbClr val="2A7F6F"/>
-                  </a:solidFill>
-                  <a:latin typeface="Poppins" pitchFamily="34" charset="0"/>
-                  <a:ea typeface="Poppins" pitchFamily="34" charset="-122"/>
-                  <a:cs typeface="Poppins" pitchFamily="34" charset="-120"/>
-                </a:rPr>
-                <a:t>23%</a:t>
-              </a:r>
-              <a:endParaRPr lang="en-US" sz="1000" dirty="0"/>
-            </a:p>
-          </p:txBody>
-        </p:sp>
-        <p:sp>
-          <p:nvSpPr>
-            <p:cNvPr id="30" name="Shape 28"/>
-            <p:cNvSpPr/>
-            <p:nvPr/>
-          </p:nvSpPr>
-          <p:spPr>
-            <a:xfrm>
-              <a:off x="2926080" y="4416552"/>
-              <a:ext cx="5349240" cy="128016"/>
-            </a:xfrm>
-            <a:prstGeom prst="rect">
-              <a:avLst/>
-            </a:prstGeom>
+            <a:prstDash val="solid"/>
+          </a:ln>
+        </p:spPr>
+      </p:sp>
+      <p:sp>
+        <p:nvSpPr>
+          <p:cNvPr id="28" name="Text 26"/>
+          <p:cNvSpPr/>
+          <p:nvPr/>
+        </p:nvSpPr>
+        <p:spPr>
+          <a:xfrm>
+            <a:off x="548640" y="4370832"/>
+            <a:ext cx="2286000" cy="256032"/>
+          </a:xfrm>
+          <a:prstGeom prst="rect">
+            <a:avLst/>
+          </a:prstGeom>
+          <a:noFill/>
+          <a:ln/>
+        </p:spPr>
+        <p:txBody>
+          <a:bodyPr wrap="square" lIns="0" tIns="0" rIns="0" bIns="0" rtlCol="0" anchor="ctr"/>
+          <a:lstStyle/>
+          <a:p>
+            <a:pPr indent="0" marL="0">
+              <a:buNone/>
+            </a:pPr>
+            <a:r>
+              <a:rPr lang="en-US" sz="1000" dirty="0">
+                <a:solidFill>
+                  <a:srgbClr val="2C3E35"/>
+                </a:solidFill>
+                <a:latin typeface="Poppins" pitchFamily="34" charset="0"/>
+                <a:ea typeface="Poppins" pitchFamily="34" charset="-122"/>
+                <a:cs typeface="Poppins" pitchFamily="34" charset="-120"/>
+              </a:rPr>
+              <a:t>Bank account holders</a:t>
+            </a:r>
+            <a:endParaRPr lang="en-US" sz="1000" dirty="0"/>
+          </a:p>
+        </p:txBody>
+      </p:sp>
+      <p:sp>
+        <p:nvSpPr>
+          <p:cNvPr id="29" name="Text 27"/>
+          <p:cNvSpPr/>
+          <p:nvPr/>
+        </p:nvSpPr>
+        <p:spPr>
+          <a:xfrm>
+            <a:off x="8229600" y="4370832"/>
+            <a:ext cx="502920" cy="256032"/>
+          </a:xfrm>
+          <a:prstGeom prst="rect">
+            <a:avLst/>
+          </a:prstGeom>
+          <a:noFill/>
+          <a:ln/>
+        </p:spPr>
+        <p:txBody>
+          <a:bodyPr wrap="square" lIns="0" tIns="0" rIns="0" bIns="0" rtlCol="0" anchor="ctr"/>
+          <a:lstStyle/>
+          <a:p>
+            <a:pPr algn="r" indent="0" marL="0">
+              <a:buNone/>
+            </a:pPr>
+            <a:r>
+              <a:rPr lang="en-US" sz="1000" b="1" dirty="0">
+                <a:solidFill>
+                  <a:srgbClr val="2A7F6F"/>
+                </a:solidFill>
+                <a:latin typeface="Poppins" pitchFamily="34" charset="0"/>
+                <a:ea typeface="Poppins" pitchFamily="34" charset="-122"/>
+                <a:cs typeface="Poppins" pitchFamily="34" charset="-120"/>
+              </a:rPr>
+              <a:t>23%</a:t>
+            </a:r>
+            <a:endParaRPr lang="en-US" sz="1000" dirty="0"/>
+          </a:p>
+        </p:txBody>
+      </p:sp>
+      <p:sp>
+        <p:nvSpPr>
+          <p:cNvPr id="30" name="Shape 28"/>
+          <p:cNvSpPr/>
+          <p:nvPr/>
+        </p:nvSpPr>
+        <p:spPr>
+          <a:xfrm>
+            <a:off x="2926080" y="4416552"/>
+            <a:ext cx="5349240" cy="128016"/>
+          </a:xfrm>
+          <a:prstGeom prst="rect">
+            <a:avLst/>
+          </a:prstGeom>
+          <a:solidFill>
+            <a:srgbClr val="EDF2F0"/>
+          </a:solidFill>
+          <a:ln w="12700">
             <a:solidFill>
               <a:srgbClr val="EDF2F0"/>
             </a:solidFill>
-            <a:ln w="12700">
-              <a:solidFill>
-                <a:srgbClr val="EDF2F0"/>
-              </a:solidFill>
-              <a:prstDash val="solid"/>
-            </a:ln>
-          </p:spPr>
-          <p:txBody>
-            <a:bodyPr/>
-            <a:lstStyle/>
-            <a:p>
-              <a:endParaRPr lang="en-US"/>
-            </a:p>
-          </p:txBody>
-        </p:sp>
-        <p:sp>
-          <p:nvSpPr>
-            <p:cNvPr id="31" name="Shape 29"/>
-            <p:cNvSpPr/>
-            <p:nvPr/>
-          </p:nvSpPr>
-          <p:spPr>
-            <a:xfrm>
-              <a:off x="2926080" y="4416552"/>
-              <a:ext cx="1230325" cy="128016"/>
-            </a:xfrm>
-            <a:prstGeom prst="rect">
-              <a:avLst/>
-            </a:prstGeom>
+            <a:prstDash val="solid"/>
+          </a:ln>
+        </p:spPr>
+      </p:sp>
+      <p:sp>
+        <p:nvSpPr>
+          <p:cNvPr id="31" name="Shape 29"/>
+          <p:cNvSpPr/>
+          <p:nvPr/>
+        </p:nvSpPr>
+        <p:spPr>
+          <a:xfrm>
+            <a:off x="2926080" y="4416552"/>
+            <a:ext cx="1230325" cy="128016"/>
+          </a:xfrm>
+          <a:prstGeom prst="rect">
+            <a:avLst/>
+          </a:prstGeom>
+          <a:solidFill>
+            <a:srgbClr val="2A7F6F">
+              <a:alpha val="60000"/>
+            </a:srgbClr>
+          </a:solidFill>
+          <a:ln w="12700">
             <a:solidFill>
               <a:srgbClr val="2A7F6F">
                 <a:alpha val="60000"/>
               </a:srgbClr>
             </a:solidFill>
-            <a:ln w="12700">
-              <a:solidFill>
-                <a:srgbClr val="2A7F6F">
-                  <a:alpha val="60000"/>
-                </a:srgbClr>
-              </a:solidFill>
-              <a:prstDash val="solid"/>
-            </a:ln>
-          </p:spPr>
-          <p:txBody>
-            <a:bodyPr/>
-            <a:lstStyle/>
-            <a:p>
-              <a:endParaRPr lang="en-US"/>
-            </a:p>
-          </p:txBody>
-        </p:sp>
-      </p:grpSp>
-      <p:grpSp>
-        <p:nvGrpSpPr>
-          <p:cNvPr id="38" name="Group 37">
-            <a:extLst>
-              <a:ext uri="{FF2B5EF4-FFF2-40B4-BE49-F238E27FC236}">
-                <a16:creationId xmlns:a16="http://schemas.microsoft.com/office/drawing/2014/main" id="{3B31F9F5-B7A4-F119-CC56-F484F521978E}"/>
-              </a:ext>
-            </a:extLst>
-          </p:cNvPr>
-          <p:cNvGrpSpPr/>
-          <p:nvPr/>
-        </p:nvGrpSpPr>
-        <p:grpSpPr>
-          <a:xfrm>
-            <a:off x="5705203" y="2571750"/>
-            <a:ext cx="3187337" cy="1947672"/>
-            <a:chOff x="5736345" y="2651760"/>
-            <a:chExt cx="3187337" cy="1947672"/>
-          </a:xfrm>
-        </p:grpSpPr>
-        <p:sp>
-          <p:nvSpPr>
-            <p:cNvPr id="32" name="Shape 30"/>
-            <p:cNvSpPr/>
-            <p:nvPr/>
-          </p:nvSpPr>
-          <p:spPr>
-            <a:xfrm>
-              <a:off x="5736345" y="3063240"/>
-              <a:ext cx="3187337" cy="1536192"/>
-            </a:xfrm>
-            <a:prstGeom prst="rect">
-              <a:avLst/>
-            </a:prstGeom>
+            <a:prstDash val="solid"/>
+          </a:ln>
+        </p:spPr>
+      </p:sp>
+      <p:sp>
+        <p:nvSpPr>
+          <p:cNvPr id="32" name="Shape 30"/>
+          <p:cNvSpPr/>
+          <p:nvPr/>
+        </p:nvSpPr>
+        <p:spPr>
+          <a:xfrm>
+            <a:off x="5349240" y="2331720"/>
+            <a:ext cx="3429000" cy="2468880"/>
+          </a:xfrm>
+          <a:prstGeom prst="rect">
+            <a:avLst/>
+          </a:prstGeom>
+          <a:solidFill>
+            <a:srgbClr val="F7F9F8"/>
+          </a:solidFill>
+          <a:ln w="12700">
             <a:solidFill>
-              <a:srgbClr val="F7F9F8"/>
+              <a:srgbClr val="EDF2F0"/>
             </a:solidFill>
-            <a:ln w="12700">
-              <a:solidFill>
-                <a:srgbClr val="EDF2F0"/>
-              </a:solidFill>
-              <a:prstDash val="solid"/>
-            </a:ln>
-          </p:spPr>
-          <p:txBody>
-            <a:bodyPr/>
-            <a:lstStyle/>
-            <a:p>
-              <a:endParaRPr lang="en-US"/>
-            </a:p>
-          </p:txBody>
-        </p:sp>
-        <p:sp>
-          <p:nvSpPr>
-            <p:cNvPr id="33" name="Text 31"/>
-            <p:cNvSpPr/>
-            <p:nvPr/>
-          </p:nvSpPr>
-          <p:spPr>
-            <a:xfrm>
-              <a:off x="5736345" y="2651760"/>
-              <a:ext cx="3063240" cy="274320"/>
-            </a:xfrm>
-            <a:prstGeom prst="rect">
-              <a:avLst/>
-            </a:prstGeom>
-            <a:noFill/>
-            <a:ln/>
-          </p:spPr>
-          <p:txBody>
-            <a:bodyPr wrap="square" lIns="0" tIns="0" rIns="0" bIns="0" rtlCol="0" anchor="ctr"/>
-            <a:lstStyle/>
-            <a:p>
-              <a:pPr marL="0" indent="0">
-                <a:buNone/>
-              </a:pPr>
-              <a:r>
-                <a:rPr lang="en-US" sz="1000" b="1" dirty="0">
-                  <a:solidFill>
-                    <a:srgbClr val="2A7F6F"/>
-                  </a:solidFill>
-                  <a:latin typeface="Poppins" pitchFamily="34" charset="0"/>
-                  <a:ea typeface="Poppins" pitchFamily="34" charset="-122"/>
-                  <a:cs typeface="Poppins" pitchFamily="34" charset="-120"/>
-                </a:rPr>
-                <a:t>Key insight</a:t>
-              </a:r>
-              <a:endParaRPr lang="en-US" sz="1000" dirty="0"/>
-            </a:p>
-          </p:txBody>
-        </p:sp>
-        <p:sp>
-          <p:nvSpPr>
-            <p:cNvPr id="34" name="Text 32"/>
-            <p:cNvSpPr/>
-            <p:nvPr/>
-          </p:nvSpPr>
-          <p:spPr>
-            <a:xfrm>
-              <a:off x="5829300" y="2820924"/>
-              <a:ext cx="3063240" cy="1645920"/>
-            </a:xfrm>
-            <a:prstGeom prst="rect">
-              <a:avLst/>
-            </a:prstGeom>
-            <a:noFill/>
-            <a:ln/>
-          </p:spPr>
-          <p:txBody>
-            <a:bodyPr wrap="square" lIns="0" tIns="0" rIns="0" bIns="0" rtlCol="0" anchor="ctr"/>
-            <a:lstStyle/>
-            <a:p>
-              <a:pPr marL="0" indent="0">
-                <a:buNone/>
-              </a:pPr>
-              <a:r>
-                <a:rPr lang="en-US" sz="1150" dirty="0">
-                  <a:solidFill>
-                    <a:srgbClr val="2C3E35"/>
-                  </a:solidFill>
-                  <a:latin typeface="Poppins" pitchFamily="34" charset="0"/>
-                  <a:ea typeface="Poppins" pitchFamily="34" charset="-122"/>
-                  <a:cs typeface="Poppins" pitchFamily="34" charset="-120"/>
-                </a:rPr>
-                <a:t>Only 2% of Zambians use credit cards — but 95% use mobile money. The payment barrier that stopped e-commerce elsewhere doesn't exist here.</a:t>
-              </a:r>
-              <a:endParaRPr lang="en-US" sz="1150" dirty="0"/>
-            </a:p>
-          </p:txBody>
-        </p:sp>
-      </p:grpSp>
+            <a:prstDash val="solid"/>
+          </a:ln>
+        </p:spPr>
+      </p:sp>
+      <p:sp>
+        <p:nvSpPr>
+          <p:cNvPr id="33" name="Text 31"/>
+          <p:cNvSpPr/>
+          <p:nvPr/>
+        </p:nvSpPr>
+        <p:spPr>
+          <a:xfrm>
+            <a:off x="5532120" y="2468880"/>
+            <a:ext cx="3063240" cy="274320"/>
+          </a:xfrm>
+          <a:prstGeom prst="rect">
+            <a:avLst/>
+          </a:prstGeom>
+          <a:noFill/>
+          <a:ln/>
+        </p:spPr>
+        <p:txBody>
+          <a:bodyPr wrap="square" lIns="0" tIns="0" rIns="0" bIns="0" rtlCol="0" anchor="ctr"/>
+          <a:lstStyle/>
+          <a:p>
+            <a:pPr indent="0" marL="0">
+              <a:buNone/>
+            </a:pPr>
+            <a:r>
+              <a:rPr lang="en-US" sz="1000" b="1" dirty="0">
+                <a:solidFill>
+                  <a:srgbClr val="2A7F6F"/>
+                </a:solidFill>
+                <a:latin typeface="Poppins" pitchFamily="34" charset="0"/>
+                <a:ea typeface="Poppins" pitchFamily="34" charset="-122"/>
+                <a:cs typeface="Poppins" pitchFamily="34" charset="-120"/>
+              </a:rPr>
+              <a:t>Key insight</a:t>
+            </a:r>
+            <a:endParaRPr lang="en-US" sz="1000" dirty="0"/>
+          </a:p>
+        </p:txBody>
+      </p:sp>
+      <p:sp>
+        <p:nvSpPr>
+          <p:cNvPr id="34" name="Text 32"/>
+          <p:cNvSpPr/>
+          <p:nvPr/>
+        </p:nvSpPr>
+        <p:spPr>
+          <a:xfrm>
+            <a:off x="5532120" y="2788920"/>
+            <a:ext cx="3063240" cy="1645920"/>
+          </a:xfrm>
+          <a:prstGeom prst="rect">
+            <a:avLst/>
+          </a:prstGeom>
+          <a:noFill/>
+          <a:ln/>
+        </p:spPr>
+        <p:txBody>
+          <a:bodyPr wrap="square" lIns="0" tIns="0" rIns="0" bIns="0" rtlCol="0" anchor="ctr"/>
+          <a:lstStyle/>
+          <a:p>
+            <a:pPr indent="0" marL="0">
+              <a:buNone/>
+            </a:pPr>
+            <a:r>
+              <a:rPr lang="en-US" sz="1150" dirty="0">
+                <a:solidFill>
+                  <a:srgbClr val="2C3E35"/>
+                </a:solidFill>
+                <a:latin typeface="Poppins" pitchFamily="34" charset="0"/>
+                <a:ea typeface="Poppins" pitchFamily="34" charset="-122"/>
+                <a:cs typeface="Poppins" pitchFamily="34" charset="-120"/>
+              </a:rPr>
+              <a:t>Only 2% of Zambians use credit cards — but 95% use mobile money. The payment barrier that stopped e-commerce elsewhere doesn't exist here.</a:t>
+            </a:r>
+            <a:endParaRPr lang="en-US" sz="1150" dirty="0"/>
+          </a:p>
+        </p:txBody>
+      </p:sp>
     </p:spTree>
   </p:cSld>
   <p:clrMapOvr>
@@ -5614,7 +5522,6 @@
         <a:solidFill>
           <a:srgbClr val="FFFFFF"/>
         </a:solidFill>
-        <a:effectLst/>
       </p:bgPr>
     </p:bg>
     <p:spTree>
@@ -5652,7 +5559,7 @@
           <a:bodyPr wrap="square" lIns="0" tIns="0" rIns="0" bIns="0" rtlCol="0" anchor="ctr"/>
           <a:lstStyle/>
           <a:p>
-            <a:pPr marL="0" indent="0">
+            <a:pPr indent="0" marL="0">
               <a:buNone/>
             </a:pPr>
             <a:r>
@@ -5672,7 +5579,7 @@
       </p:sp>
       <p:graphicFrame>
         <p:nvGraphicFramePr>
-          <p:cNvPr id="3" name="Chart 0"/>
+          <p:cNvPr id="3" name="Chart 0" descr=""/>
           <p:cNvGraphicFramePr/>
           <p:nvPr/>
         </p:nvGraphicFramePr>
@@ -5680,9 +5587,9 @@
           <a:off x="548640" y="960120"/>
           <a:ext cx="5303520" cy="3291840"/>
         </p:xfrm>
-        <a:graphic>
+        <a:graphic xmlns:a="http://schemas.openxmlformats.org/drawingml/2006/main">
           <a:graphicData uri="http://schemas.openxmlformats.org/drawingml/2006/chart">
-            <c:chart xmlns:c="http://schemas.openxmlformats.org/drawingml/2006/chart" xmlns:r="http://schemas.openxmlformats.org/officeDocument/2006/relationships" r:id="rId3"/>
+            <c:chart xmlns:c="http://schemas.openxmlformats.org/drawingml/2006/chart" r:id="rId1"/>
           </a:graphicData>
         </a:graphic>
       </p:graphicFrame>
@@ -5710,13 +5617,6 @@
             <a:prstDash val="solid"/>
           </a:ln>
         </p:spPr>
-        <p:txBody>
-          <a:bodyPr/>
-          <a:lstStyle/>
-          <a:p>
-            <a:endParaRPr lang="en-US"/>
-          </a:p>
-        </p:txBody>
       </p:sp>
       <p:sp>
         <p:nvSpPr>
@@ -5739,7 +5639,7 @@
           <a:bodyPr wrap="square" lIns="0" tIns="0" rIns="0" bIns="0" rtlCol="0" anchor="ctr"/>
           <a:lstStyle/>
           <a:p>
-            <a:pPr marL="0" indent="0">
+            <a:pPr indent="0" marL="0">
               <a:buNone/>
             </a:pPr>
             <a:r>
@@ -5778,7 +5678,7 @@
           <a:bodyPr wrap="square" lIns="0" tIns="0" rIns="0" bIns="0" rtlCol="0" anchor="ctr"/>
           <a:lstStyle/>
           <a:p>
-            <a:pPr marL="0" indent="0">
+            <a:pPr indent="0" marL="0">
               <a:buNone/>
             </a:pPr>
             <a:r>
@@ -5820,13 +5720,6 @@
             <a:prstDash val="solid"/>
           </a:ln>
         </p:spPr>
-        <p:txBody>
-          <a:bodyPr/>
-          <a:lstStyle/>
-          <a:p>
-            <a:endParaRPr lang="en-US"/>
-          </a:p>
-        </p:txBody>
       </p:sp>
       <p:sp>
         <p:nvSpPr>
@@ -5849,7 +5742,7 @@
           <a:bodyPr wrap="square" lIns="0" tIns="0" rIns="0" bIns="0" rtlCol="0" anchor="ctr"/>
           <a:lstStyle/>
           <a:p>
-            <a:pPr marL="0" indent="0">
+            <a:pPr indent="0" marL="0">
               <a:buNone/>
             </a:pPr>
             <a:r>
@@ -5888,7 +5781,7 @@
           <a:bodyPr wrap="square" lIns="0" tIns="0" rIns="0" bIns="0" rtlCol="0" anchor="ctr"/>
           <a:lstStyle/>
           <a:p>
-            <a:pPr marL="0" indent="0">
+            <a:pPr indent="0" marL="0">
               <a:buNone/>
             </a:pPr>
             <a:r>
@@ -5930,13 +5823,6 @@
             <a:prstDash val="solid"/>
           </a:ln>
         </p:spPr>
-        <p:txBody>
-          <a:bodyPr/>
-          <a:lstStyle/>
-          <a:p>
-            <a:endParaRPr lang="en-US"/>
-          </a:p>
-        </p:txBody>
       </p:sp>
       <p:sp>
         <p:nvSpPr>
@@ -5959,7 +5845,7 @@
           <a:bodyPr wrap="square" lIns="0" tIns="0" rIns="0" bIns="0" rtlCol="0" anchor="ctr"/>
           <a:lstStyle/>
           <a:p>
-            <a:pPr marL="0" indent="0">
+            <a:pPr indent="0" marL="0">
               <a:buNone/>
             </a:pPr>
             <a:r>
@@ -5998,7 +5884,7 @@
           <a:bodyPr wrap="square" lIns="0" tIns="0" rIns="0" bIns="0" rtlCol="0" anchor="ctr"/>
           <a:lstStyle/>
           <a:p>
-            <a:pPr marL="0" indent="0">
+            <a:pPr indent="0" marL="0">
               <a:buNone/>
             </a:pPr>
             <a:r>
@@ -6037,7 +5923,7 @@
           <a:bodyPr wrap="square" lIns="0" tIns="0" rIns="0" bIns="0" rtlCol="0" anchor="ctr"/>
           <a:lstStyle/>
           <a:p>
-            <a:pPr marL="0" indent="0">
+            <a:pPr indent="0" marL="0">
               <a:buNone/>
             </a:pPr>
             <a:r>
@@ -6071,7 +5957,6 @@
         <a:solidFill>
           <a:srgbClr val="FFFFFF"/>
         </a:solidFill>
-        <a:effectLst/>
       </p:bgPr>
     </p:bg>
     <p:spTree>
@@ -6109,7 +5994,7 @@
           <a:bodyPr wrap="square" lIns="0" tIns="0" rIns="0" bIns="0" rtlCol="0" anchor="ctr"/>
           <a:lstStyle/>
           <a:p>
-            <a:pPr marL="0" indent="0">
+            <a:pPr indent="0" marL="0">
               <a:buNone/>
             </a:pPr>
             <a:r>
@@ -6148,7 +6033,7 @@
           <a:bodyPr wrap="square" lIns="0" tIns="0" rIns="0" bIns="0" rtlCol="0" anchor="ctr"/>
           <a:lstStyle/>
           <a:p>
-            <a:pPr marL="0" indent="0">
+            <a:pPr indent="0" marL="0">
               <a:buNone/>
             </a:pPr>
             <a:r>
@@ -6190,13 +6075,6 @@
             <a:prstDash val="solid"/>
           </a:ln>
         </p:spPr>
-        <p:txBody>
-          <a:bodyPr/>
-          <a:lstStyle/>
-          <a:p>
-            <a:endParaRPr lang="en-US"/>
-          </a:p>
-        </p:txBody>
       </p:sp>
       <p:sp>
         <p:nvSpPr>
@@ -6222,13 +6100,6 @@
             <a:prstDash val="solid"/>
           </a:ln>
         </p:spPr>
-        <p:txBody>
-          <a:bodyPr/>
-          <a:lstStyle/>
-          <a:p>
-            <a:endParaRPr lang="en-US"/>
-          </a:p>
-        </p:txBody>
       </p:sp>
       <p:sp>
         <p:nvSpPr>
@@ -6251,7 +6122,7 @@
           <a:bodyPr wrap="square" lIns="0" tIns="0" rIns="0" bIns="0" rtlCol="0" anchor="ctr"/>
           <a:lstStyle/>
           <a:p>
-            <a:pPr marL="0" indent="0">
+            <a:pPr indent="0" marL="0">
               <a:buNone/>
             </a:pPr>
             <a:r>
@@ -6290,7 +6161,7 @@
           <a:bodyPr wrap="square" lIns="0" tIns="0" rIns="0" bIns="0" rtlCol="0" anchor="ctr"/>
           <a:lstStyle/>
           <a:p>
-            <a:pPr marL="0" indent="0">
+            <a:pPr indent="0" marL="0">
               <a:buNone/>
             </a:pPr>
             <a:r>
@@ -6332,13 +6203,6 @@
             <a:prstDash val="solid"/>
           </a:ln>
         </p:spPr>
-        <p:txBody>
-          <a:bodyPr/>
-          <a:lstStyle/>
-          <a:p>
-            <a:endParaRPr lang="en-US"/>
-          </a:p>
-        </p:txBody>
       </p:sp>
       <p:sp>
         <p:nvSpPr>
@@ -6361,7 +6225,7 @@
           <a:bodyPr wrap="square" lIns="0" tIns="0" rIns="0" bIns="0" rtlCol="0" anchor="ctr"/>
           <a:lstStyle/>
           <a:p>
-            <a:pPr marL="0" indent="0">
+            <a:pPr indent="0" marL="0">
               <a:buNone/>
             </a:pPr>
             <a:r>
@@ -6403,13 +6267,6 @@
             <a:prstDash val="solid"/>
           </a:ln>
         </p:spPr>
-        <p:txBody>
-          <a:bodyPr/>
-          <a:lstStyle/>
-          <a:p>
-            <a:endParaRPr lang="en-US"/>
-          </a:p>
-        </p:txBody>
       </p:sp>
       <p:sp>
         <p:nvSpPr>
@@ -6435,13 +6292,6 @@
             <a:prstDash val="solid"/>
           </a:ln>
         </p:spPr>
-        <p:txBody>
-          <a:bodyPr/>
-          <a:lstStyle/>
-          <a:p>
-            <a:endParaRPr lang="en-US"/>
-          </a:p>
-        </p:txBody>
       </p:sp>
       <p:sp>
         <p:nvSpPr>
@@ -6464,7 +6314,7 @@
           <a:bodyPr wrap="square" lIns="0" tIns="0" rIns="0" bIns="0" rtlCol="0" anchor="ctr"/>
           <a:lstStyle/>
           <a:p>
-            <a:pPr marL="0" indent="0">
+            <a:pPr indent="0" marL="0">
               <a:buNone/>
             </a:pPr>
             <a:r>
@@ -6503,7 +6353,7 @@
           <a:bodyPr wrap="square" lIns="0" tIns="0" rIns="0" bIns="0" rtlCol="0" anchor="ctr"/>
           <a:lstStyle/>
           <a:p>
-            <a:pPr marL="0" indent="0">
+            <a:pPr indent="0" marL="0">
               <a:buNone/>
             </a:pPr>
             <a:r>
@@ -6545,13 +6395,6 @@
             <a:prstDash val="solid"/>
           </a:ln>
         </p:spPr>
-        <p:txBody>
-          <a:bodyPr/>
-          <a:lstStyle/>
-          <a:p>
-            <a:endParaRPr lang="en-US"/>
-          </a:p>
-        </p:txBody>
       </p:sp>
       <p:sp>
         <p:nvSpPr>
@@ -6574,7 +6417,7 @@
           <a:bodyPr wrap="square" lIns="0" tIns="0" rIns="0" bIns="0" rtlCol="0" anchor="ctr"/>
           <a:lstStyle/>
           <a:p>
-            <a:pPr marL="0" indent="0">
+            <a:pPr indent="0" marL="0">
               <a:buNone/>
             </a:pPr>
             <a:r>
@@ -6616,13 +6459,6 @@
             <a:prstDash val="solid"/>
           </a:ln>
         </p:spPr>
-        <p:txBody>
-          <a:bodyPr/>
-          <a:lstStyle/>
-          <a:p>
-            <a:endParaRPr lang="en-US"/>
-          </a:p>
-        </p:txBody>
       </p:sp>
       <p:sp>
         <p:nvSpPr>
@@ -6648,13 +6484,6 @@
             <a:prstDash val="solid"/>
           </a:ln>
         </p:spPr>
-        <p:txBody>
-          <a:bodyPr/>
-          <a:lstStyle/>
-          <a:p>
-            <a:endParaRPr lang="en-US"/>
-          </a:p>
-        </p:txBody>
       </p:sp>
       <p:sp>
         <p:nvSpPr>
@@ -6677,7 +6506,7 @@
           <a:bodyPr wrap="square" lIns="0" tIns="0" rIns="0" bIns="0" rtlCol="0" anchor="ctr"/>
           <a:lstStyle/>
           <a:p>
-            <a:pPr marL="0" indent="0">
+            <a:pPr indent="0" marL="0">
               <a:buNone/>
             </a:pPr>
             <a:r>
@@ -6716,7 +6545,7 @@
           <a:bodyPr wrap="square" lIns="0" tIns="0" rIns="0" bIns="0" rtlCol="0" anchor="ctr"/>
           <a:lstStyle/>
           <a:p>
-            <a:pPr marL="0" indent="0">
+            <a:pPr indent="0" marL="0">
               <a:buNone/>
             </a:pPr>
             <a:r>
@@ -6758,13 +6587,6 @@
             <a:prstDash val="solid"/>
           </a:ln>
         </p:spPr>
-        <p:txBody>
-          <a:bodyPr/>
-          <a:lstStyle/>
-          <a:p>
-            <a:endParaRPr lang="en-US"/>
-          </a:p>
-        </p:txBody>
       </p:sp>
       <p:sp>
         <p:nvSpPr>
@@ -6787,7 +6609,7 @@
           <a:bodyPr wrap="square" lIns="0" tIns="0" rIns="0" bIns="0" rtlCol="0" anchor="ctr"/>
           <a:lstStyle/>
           <a:p>
-            <a:pPr marL="0" indent="0">
+            <a:pPr indent="0" marL="0">
               <a:buNone/>
             </a:pPr>
             <a:r>
@@ -6829,13 +6651,6 @@
             <a:prstDash val="solid"/>
           </a:ln>
         </p:spPr>
-        <p:txBody>
-          <a:bodyPr/>
-          <a:lstStyle/>
-          <a:p>
-            <a:endParaRPr lang="en-US"/>
-          </a:p>
-        </p:txBody>
       </p:sp>
       <p:sp>
         <p:nvSpPr>
@@ -6861,13 +6676,6 @@
             <a:prstDash val="solid"/>
           </a:ln>
         </p:spPr>
-        <p:txBody>
-          <a:bodyPr/>
-          <a:lstStyle/>
-          <a:p>
-            <a:endParaRPr lang="en-US"/>
-          </a:p>
-        </p:txBody>
       </p:sp>
       <p:sp>
         <p:nvSpPr>
@@ -6890,7 +6698,7 @@
           <a:bodyPr wrap="square" lIns="0" tIns="0" rIns="0" bIns="0" rtlCol="0" anchor="ctr"/>
           <a:lstStyle/>
           <a:p>
-            <a:pPr marL="0" indent="0">
+            <a:pPr indent="0" marL="0">
               <a:buNone/>
             </a:pPr>
             <a:r>
@@ -6929,7 +6737,7 @@
           <a:bodyPr wrap="square" lIns="0" tIns="0" rIns="0" bIns="0" rtlCol="0" anchor="ctr"/>
           <a:lstStyle/>
           <a:p>
-            <a:pPr marL="0" indent="0">
+            <a:pPr indent="0" marL="0">
               <a:buNone/>
             </a:pPr>
             <a:r>
@@ -6971,13 +6779,6 @@
             <a:prstDash val="solid"/>
           </a:ln>
         </p:spPr>
-        <p:txBody>
-          <a:bodyPr/>
-          <a:lstStyle/>
-          <a:p>
-            <a:endParaRPr lang="en-US"/>
-          </a:p>
-        </p:txBody>
       </p:sp>
       <p:sp>
         <p:nvSpPr>
@@ -7000,7 +6801,7 @@
           <a:bodyPr wrap="square" lIns="0" tIns="0" rIns="0" bIns="0" rtlCol="0" anchor="ctr"/>
           <a:lstStyle/>
           <a:p>
-            <a:pPr marL="0" indent="0">
+            <a:pPr indent="0" marL="0">
               <a:buNone/>
             </a:pPr>
             <a:r>
@@ -7034,7 +6835,6 @@
         <a:solidFill>
           <a:srgbClr val="1C2B36"/>
         </a:solidFill>
-        <a:effectLst/>
       </p:bgPr>
     </p:bg>
     <p:spTree>
@@ -7079,13 +6879,6 @@
             <a:prstDash val="solid"/>
           </a:ln>
         </p:spPr>
-        <p:txBody>
-          <a:bodyPr/>
-          <a:lstStyle/>
-          <a:p>
-            <a:endParaRPr lang="en-US"/>
-          </a:p>
-        </p:txBody>
       </p:sp>
       <p:sp>
         <p:nvSpPr>
@@ -7108,7 +6901,7 @@
           <a:bodyPr wrap="square" lIns="0" tIns="0" rIns="0" bIns="0" rtlCol="0" anchor="ctr"/>
           <a:lstStyle/>
           <a:p>
-            <a:pPr marL="0" indent="0">
+            <a:pPr indent="0" marL="0">
               <a:buNone/>
             </a:pPr>
             <a:r>
@@ -7147,7 +6940,7 @@
           <a:bodyPr wrap="square" lIns="0" tIns="0" rIns="0" bIns="0" rtlCol="0" anchor="ctr"/>
           <a:lstStyle/>
           <a:p>
-            <a:pPr marL="0" indent="0">
+            <a:pPr indent="0" marL="0">
               <a:buNone/>
             </a:pPr>
             <a:r>
@@ -7193,13 +6986,6 @@
             <a:prstDash val="solid"/>
           </a:ln>
         </p:spPr>
-        <p:txBody>
-          <a:bodyPr/>
-          <a:lstStyle/>
-          <a:p>
-            <a:endParaRPr lang="en-US"/>
-          </a:p>
-        </p:txBody>
       </p:sp>
       <p:sp>
         <p:nvSpPr>
@@ -7222,7 +7008,7 @@
           <a:bodyPr wrap="square" lIns="0" tIns="0" rIns="0" bIns="0" rtlCol="0" anchor="ctr"/>
           <a:lstStyle/>
           <a:p>
-            <a:pPr marL="0" indent="0">
+            <a:pPr indent="0" marL="0">
               <a:buNone/>
             </a:pPr>
             <a:r>
@@ -7264,13 +7050,6 @@
             <a:prstDash val="solid"/>
           </a:ln>
         </p:spPr>
-        <p:txBody>
-          <a:bodyPr/>
-          <a:lstStyle/>
-          <a:p>
-            <a:endParaRPr lang="en-US"/>
-          </a:p>
-        </p:txBody>
       </p:sp>
       <p:sp>
         <p:nvSpPr>
@@ -7293,7 +7072,7 @@
           <a:bodyPr wrap="square" lIns="0" tIns="0" rIns="0" bIns="0" rtlCol="0" anchor="ctr"/>
           <a:lstStyle/>
           <a:p>
-            <a:pPr marL="0" indent="0">
+            <a:pPr indent="0" marL="0">
               <a:buNone/>
             </a:pPr>
             <a:r>
@@ -7332,7 +7111,7 @@
           <a:bodyPr wrap="square" lIns="0" tIns="0" rIns="0" bIns="0" rtlCol="0" anchor="ctr"/>
           <a:lstStyle/>
           <a:p>
-            <a:pPr marL="0" indent="0">
+            <a:pPr indent="0" marL="0">
               <a:buNone/>
             </a:pPr>
             <a:r>
@@ -7371,7 +7150,7 @@
           <a:bodyPr wrap="square" lIns="0" tIns="0" rIns="0" bIns="0" rtlCol="0" anchor="ctr"/>
           <a:lstStyle/>
           <a:p>
-            <a:pPr marL="0" indent="0">
+            <a:pPr indent="0" marL="0">
               <a:buNone/>
             </a:pPr>
             <a:r>
@@ -7413,13 +7192,6 @@
             <a:prstDash val="solid"/>
           </a:ln>
         </p:spPr>
-        <p:txBody>
-          <a:bodyPr/>
-          <a:lstStyle/>
-          <a:p>
-            <a:endParaRPr lang="en-US"/>
-          </a:p>
-        </p:txBody>
       </p:sp>
       <p:sp>
         <p:nvSpPr>
@@ -7442,7 +7214,7 @@
           <a:bodyPr wrap="square" lIns="0" tIns="0" rIns="0" bIns="0" rtlCol="0" anchor="ctr"/>
           <a:lstStyle/>
           <a:p>
-            <a:pPr marL="0" indent="0">
+            <a:pPr indent="0" marL="0">
               <a:buNone/>
             </a:pPr>
             <a:r>
@@ -7481,7 +7253,7 @@
           <a:bodyPr wrap="square" lIns="0" tIns="0" rIns="0" bIns="0" rtlCol="0" anchor="ctr"/>
           <a:lstStyle/>
           <a:p>
-            <a:pPr marL="0" indent="0">
+            <a:pPr indent="0" marL="0">
               <a:buNone/>
             </a:pPr>
             <a:r>
@@ -7520,7 +7292,7 @@
           <a:bodyPr wrap="square" lIns="0" tIns="0" rIns="0" bIns="0" rtlCol="0" anchor="ctr"/>
           <a:lstStyle/>
           <a:p>
-            <a:pPr marL="0" indent="0">
+            <a:pPr indent="0" marL="0">
               <a:buNone/>
             </a:pPr>
             <a:r>
@@ -7562,13 +7334,6 @@
             <a:prstDash val="solid"/>
           </a:ln>
         </p:spPr>
-        <p:txBody>
-          <a:bodyPr/>
-          <a:lstStyle/>
-          <a:p>
-            <a:endParaRPr lang="en-US"/>
-          </a:p>
-        </p:txBody>
       </p:sp>
       <p:sp>
         <p:nvSpPr>
@@ -7591,7 +7356,7 @@
           <a:bodyPr wrap="square" lIns="0" tIns="0" rIns="0" bIns="0" rtlCol="0" anchor="ctr"/>
           <a:lstStyle/>
           <a:p>
-            <a:pPr marL="0" indent="0">
+            <a:pPr indent="0" marL="0">
               <a:buNone/>
             </a:pPr>
             <a:r>
@@ -7630,7 +7395,7 @@
           <a:bodyPr wrap="square" lIns="0" tIns="0" rIns="0" bIns="0" rtlCol="0" anchor="ctr"/>
           <a:lstStyle/>
           <a:p>
-            <a:pPr marL="0" indent="0">
+            <a:pPr indent="0" marL="0">
               <a:buNone/>
             </a:pPr>
             <a:r>
@@ -7669,7 +7434,7 @@
           <a:bodyPr wrap="square" lIns="0" tIns="0" rIns="0" bIns="0" rtlCol="0" anchor="ctr"/>
           <a:lstStyle/>
           <a:p>
-            <a:pPr marL="0" indent="0">
+            <a:pPr indent="0" marL="0">
               <a:buNone/>
             </a:pPr>
             <a:r>
@@ -7711,13 +7476,6 @@
             <a:prstDash val="solid"/>
           </a:ln>
         </p:spPr>
-        <p:txBody>
-          <a:bodyPr/>
-          <a:lstStyle/>
-          <a:p>
-            <a:endParaRPr lang="en-US"/>
-          </a:p>
-        </p:txBody>
       </p:sp>
       <p:sp>
         <p:nvSpPr>
@@ -7740,7 +7498,7 @@
           <a:bodyPr wrap="square" lIns="0" tIns="0" rIns="0" bIns="0" rtlCol="0" anchor="ctr"/>
           <a:lstStyle/>
           <a:p>
-            <a:pPr marL="0" indent="0">
+            <a:pPr indent="0" marL="0">
               <a:buNone/>
             </a:pPr>
             <a:r>
@@ -7779,7 +7537,7 @@
           <a:bodyPr wrap="square" lIns="0" tIns="0" rIns="0" bIns="0" rtlCol="0" anchor="ctr"/>
           <a:lstStyle/>
           <a:p>
-            <a:pPr marL="0" indent="0">
+            <a:pPr indent="0" marL="0">
               <a:buNone/>
             </a:pPr>
             <a:r>
@@ -7818,7 +7576,7 @@
           <a:bodyPr wrap="square" lIns="0" tIns="0" rIns="0" bIns="0" rtlCol="0" anchor="ctr"/>
           <a:lstStyle/>
           <a:p>
-            <a:pPr marL="0" indent="0">
+            <a:pPr indent="0" marL="0">
               <a:buNone/>
             </a:pPr>
             <a:r>
@@ -7860,13 +7618,6 @@
             <a:prstDash val="solid"/>
           </a:ln>
         </p:spPr>
-        <p:txBody>
-          <a:bodyPr/>
-          <a:lstStyle/>
-          <a:p>
-            <a:endParaRPr lang="en-US"/>
-          </a:p>
-        </p:txBody>
       </p:sp>
       <p:sp>
         <p:nvSpPr>
@@ -7889,7 +7640,7 @@
           <a:bodyPr wrap="square" lIns="0" tIns="0" rIns="0" bIns="0" rtlCol="0" anchor="ctr"/>
           <a:lstStyle/>
           <a:p>
-            <a:pPr marL="0" indent="0">
+            <a:pPr indent="0" marL="0">
               <a:buNone/>
             </a:pPr>
             <a:r>
@@ -7928,7 +7679,7 @@
           <a:bodyPr wrap="square" lIns="0" tIns="0" rIns="0" bIns="0" rtlCol="0" anchor="ctr"/>
           <a:lstStyle/>
           <a:p>
-            <a:pPr marL="0" indent="0">
+            <a:pPr indent="0" marL="0">
               <a:buNone/>
             </a:pPr>
             <a:r>
@@ -7967,7 +7718,7 @@
           <a:bodyPr wrap="square" lIns="0" tIns="0" rIns="0" bIns="0" rtlCol="0" anchor="ctr"/>
           <a:lstStyle/>
           <a:p>
-            <a:pPr marL="0" indent="0">
+            <a:pPr indent="0" marL="0">
               <a:buNone/>
             </a:pPr>
             <a:r>
@@ -8009,13 +7760,6 @@
             <a:prstDash val="solid"/>
           </a:ln>
         </p:spPr>
-        <p:txBody>
-          <a:bodyPr/>
-          <a:lstStyle/>
-          <a:p>
-            <a:endParaRPr lang="en-US"/>
-          </a:p>
-        </p:txBody>
       </p:sp>
       <p:sp>
         <p:nvSpPr>
@@ -8038,7 +7782,7 @@
           <a:bodyPr wrap="square" lIns="0" tIns="0" rIns="0" bIns="0" rtlCol="0" anchor="ctr"/>
           <a:lstStyle/>
           <a:p>
-            <a:pPr marL="0" indent="0">
+            <a:pPr indent="0" marL="0">
               <a:buNone/>
             </a:pPr>
             <a:r>
@@ -8077,7 +7821,7 @@
           <a:bodyPr wrap="square" lIns="0" tIns="0" rIns="0" bIns="0" rtlCol="0" anchor="ctr"/>
           <a:lstStyle/>
           <a:p>
-            <a:pPr marL="0" indent="0">
+            <a:pPr indent="0" marL="0">
               <a:buNone/>
             </a:pPr>
             <a:r>
@@ -8116,7 +7860,7 @@
           <a:bodyPr wrap="square" lIns="0" tIns="0" rIns="0" bIns="0" rtlCol="0" anchor="ctr"/>
           <a:lstStyle/>
           <a:p>
-            <a:pPr marL="0" indent="0">
+            <a:pPr indent="0" marL="0">
               <a:buNone/>
             </a:pPr>
             <a:r>
@@ -8150,7 +7894,6 @@
         <a:solidFill>
           <a:srgbClr val="1C2B36"/>
         </a:solidFill>
-        <a:effectLst/>
       </p:bgPr>
     </p:bg>
     <p:spTree>
@@ -8195,13 +7938,6 @@
             <a:prstDash val="solid"/>
           </a:ln>
         </p:spPr>
-        <p:txBody>
-          <a:bodyPr/>
-          <a:lstStyle/>
-          <a:p>
-            <a:endParaRPr lang="en-US"/>
-          </a:p>
-        </p:txBody>
       </p:sp>
       <p:sp>
         <p:nvSpPr>
@@ -8224,7 +7960,7 @@
           <a:bodyPr wrap="square" lIns="0" tIns="0" rIns="0" bIns="0" rtlCol="0" anchor="ctr"/>
           <a:lstStyle/>
           <a:p>
-            <a:pPr marL="0" indent="0">
+            <a:pPr indent="0" marL="0">
               <a:buNone/>
             </a:pPr>
             <a:r>
@@ -8263,7 +7999,7 @@
           <a:bodyPr wrap="square" lIns="0" tIns="0" rIns="0" bIns="0" rtlCol="0" anchor="ctr"/>
           <a:lstStyle/>
           <a:p>
-            <a:pPr marL="0" indent="0">
+            <a:pPr indent="0" marL="0">
               <a:buNone/>
             </a:pPr>
             <a:r>
@@ -8280,7 +8016,7 @@
             <a:endParaRPr lang="en-US" sz="1400" dirty="0"/>
           </a:p>
           <a:p>
-            <a:pPr marL="0" indent="0">
+            <a:pPr indent="0" marL="0">
               <a:buNone/>
             </a:pPr>
             <a:r>
@@ -8297,7 +8033,7 @@
             <a:endParaRPr lang="en-US" sz="1400" dirty="0"/>
           </a:p>
           <a:p>
-            <a:pPr marL="0" indent="0">
+            <a:pPr indent="0" marL="0">
               <a:buNone/>
             </a:pPr>
             <a:r>
@@ -8343,13 +8079,6 @@
             <a:prstDash val="solid"/>
           </a:ln>
         </p:spPr>
-        <p:txBody>
-          <a:bodyPr/>
-          <a:lstStyle/>
-          <a:p>
-            <a:endParaRPr lang="en-US"/>
-          </a:p>
-        </p:txBody>
       </p:sp>
       <p:sp>
         <p:nvSpPr>
@@ -8372,7 +8101,7 @@
           <a:bodyPr wrap="square" lIns="0" tIns="0" rIns="0" bIns="0" rtlCol="0" anchor="ctr"/>
           <a:lstStyle/>
           <a:p>
-            <a:pPr marL="0" indent="0">
+            <a:pPr indent="0" marL="0">
               <a:buNone/>
             </a:pPr>
             <a:r>
@@ -8691,319 +8420,4 @@
     </a:ext>
   </a:extLst>
 </a:theme>
-</file>
-
-<file path=ppt/theme/theme2.xml><?xml version="1.0" encoding="utf-8"?>
-<a:theme xmlns:a="http://schemas.openxmlformats.org/drawingml/2006/main" name="Office Theme">
-  <a:themeElements>
-    <a:clrScheme name="Office">
-      <a:dk1>
-        <a:sysClr val="windowText" lastClr="000000"/>
-      </a:dk1>
-      <a:lt1>
-        <a:sysClr val="window" lastClr="FFFFFF"/>
-      </a:lt1>
-      <a:dk2>
-        <a:srgbClr val="0E2841"/>
-      </a:dk2>
-      <a:lt2>
-        <a:srgbClr val="E8E8E8"/>
-      </a:lt2>
-      <a:accent1>
-        <a:srgbClr val="156082"/>
-      </a:accent1>
-      <a:accent2>
-        <a:srgbClr val="E97132"/>
-      </a:accent2>
-      <a:accent3>
-        <a:srgbClr val="196B24"/>
-      </a:accent3>
-      <a:accent4>
-        <a:srgbClr val="0F9ED5"/>
-      </a:accent4>
-      <a:accent5>
-        <a:srgbClr val="A02B93"/>
-      </a:accent5>
-      <a:accent6>
-        <a:srgbClr val="4EA72E"/>
-      </a:accent6>
-      <a:hlink>
-        <a:srgbClr val="467886"/>
-      </a:hlink>
-      <a:folHlink>
-        <a:srgbClr val="96607D"/>
-      </a:folHlink>
-    </a:clrScheme>
-    <a:fontScheme name="Office">
-      <a:majorFont>
-        <a:latin typeface="Aptos Display" panose="02110004020202020204"/>
-        <a:ea typeface=""/>
-        <a:cs typeface=""/>
-        <a:font script="Jpan" typeface="游ゴシック Light"/>
-        <a:font script="Hang" typeface="맑은 고딕"/>
-        <a:font script="Hans" typeface="等线 Light"/>
-        <a:font script="Hant" typeface="新細明體"/>
-        <a:font script="Arab" typeface="Times New Roman"/>
-        <a:font script="Hebr" typeface="Times New Roman"/>
-        <a:font script="Thai" typeface="Angsana New"/>
-        <a:font script="Ethi" typeface="Nyala"/>
-        <a:font script="Beng" typeface="Vrinda"/>
-        <a:font script="Gujr" typeface="Shruti"/>
-        <a:font script="Khmr" typeface="MoolBoran"/>
-        <a:font script="Knda" typeface="Tunga"/>
-        <a:font script="Guru" typeface="Raavi"/>
-        <a:font script="Cans" typeface="Euphemia"/>
-        <a:font script="Cher" typeface="Plantagenet Cherokee"/>
-        <a:font script="Yiii" typeface="Microsoft Yi Baiti"/>
-        <a:font script="Tibt" typeface="Microsoft Himalaya"/>
-        <a:font script="Thaa" typeface="MV Boli"/>
-        <a:font script="Deva" typeface="Mangal"/>
-        <a:font script="Telu" typeface="Gautami"/>
-        <a:font script="Taml" typeface="Latha"/>
-        <a:font script="Syrc" typeface="Estrangelo Edessa"/>
-        <a:font script="Orya" typeface="Kalinga"/>
-        <a:font script="Mlym" typeface="Kartika"/>
-        <a:font script="Laoo" typeface="DokChampa"/>
-        <a:font script="Sinh" typeface="Iskoola Pota"/>
-        <a:font script="Mong" typeface="Mongolian Baiti"/>
-        <a:font script="Viet" typeface="Times New Roman"/>
-        <a:font script="Uigh" typeface="Microsoft Uighur"/>
-        <a:font script="Geor" typeface="Sylfaen"/>
-        <a:font script="Armn" typeface="Arial"/>
-        <a:font script="Bugi" typeface="Leelawadee UI"/>
-        <a:font script="Bopo" typeface="Microsoft JhengHei"/>
-        <a:font script="Java" typeface="Javanese Text"/>
-        <a:font script="Lisu" typeface="Segoe UI"/>
-        <a:font script="Mymr" typeface="Myanmar Text"/>
-        <a:font script="Nkoo" typeface="Ebrima"/>
-        <a:font script="Olck" typeface="Nirmala UI"/>
-        <a:font script="Osma" typeface="Ebrima"/>
-        <a:font script="Phag" typeface="Phagspa"/>
-        <a:font script="Syrn" typeface="Estrangelo Edessa"/>
-        <a:font script="Syrj" typeface="Estrangelo Edessa"/>
-        <a:font script="Syre" typeface="Estrangelo Edessa"/>
-        <a:font script="Sora" typeface="Nirmala UI"/>
-        <a:font script="Tale" typeface="Microsoft Tai Le"/>
-        <a:font script="Talu" typeface="Microsoft New Tai Lue"/>
-        <a:font script="Tfng" typeface="Ebrima"/>
-      </a:majorFont>
-      <a:minorFont>
-        <a:latin typeface="Aptos" panose="02110004020202020204"/>
-        <a:ea typeface=""/>
-        <a:cs typeface=""/>
-        <a:font script="Jpan" typeface="游ゴシック"/>
-        <a:font script="Hang" typeface="맑은 고딕"/>
-        <a:font script="Hans" typeface="等线"/>
-        <a:font script="Hant" typeface="新細明體"/>
-        <a:font script="Arab" typeface="Arial"/>
-        <a:font script="Hebr" typeface="Arial"/>
-        <a:font script="Thai" typeface="Cordia New"/>
-        <a:font script="Ethi" typeface="Nyala"/>
-        <a:font script="Beng" typeface="Vrinda"/>
-        <a:font script="Gujr" typeface="Shruti"/>
-        <a:font script="Khmr" typeface="DaunPenh"/>
-        <a:font script="Knda" typeface="Tunga"/>
-        <a:font script="Guru" typeface="Raavi"/>
-        <a:font script="Cans" typeface="Euphemia"/>
-        <a:font script="Cher" typeface="Plantagenet Cherokee"/>
-        <a:font script="Yiii" typeface="Microsoft Yi Baiti"/>
-        <a:font script="Tibt" typeface="Microsoft Himalaya"/>
-        <a:font script="Thaa" typeface="MV Boli"/>
-        <a:font script="Deva" typeface="Mangal"/>
-        <a:font script="Telu" typeface="Gautami"/>
-        <a:font script="Taml" typeface="Latha"/>
-        <a:font script="Syrc" typeface="Estrangelo Edessa"/>
-        <a:font script="Orya" typeface="Kalinga"/>
-        <a:font script="Mlym" typeface="Kartika"/>
-        <a:font script="Laoo" typeface="DokChampa"/>
-        <a:font script="Sinh" typeface="Iskoola Pota"/>
-        <a:font script="Mong" typeface="Mongolian Baiti"/>
-        <a:font script="Viet" typeface="Arial"/>
-        <a:font script="Uigh" typeface="Microsoft Uighur"/>
-        <a:font script="Geor" typeface="Sylfaen"/>
-        <a:font script="Armn" typeface="Arial"/>
-        <a:font script="Bugi" typeface="Leelawadee UI"/>
-        <a:font script="Bopo" typeface="Microsoft JhengHei"/>
-        <a:font script="Java" typeface="Javanese Text"/>
-        <a:font script="Lisu" typeface="Segoe UI"/>
-        <a:font script="Mymr" typeface="Myanmar Text"/>
-        <a:font script="Nkoo" typeface="Ebrima"/>
-        <a:font script="Olck" typeface="Nirmala UI"/>
-        <a:font script="Osma" typeface="Ebrima"/>
-        <a:font script="Phag" typeface="Phagspa"/>
-        <a:font script="Syrn" typeface="Estrangelo Edessa"/>
-        <a:font script="Syrj" typeface="Estrangelo Edessa"/>
-        <a:font script="Syre" typeface="Estrangelo Edessa"/>
-        <a:font script="Sora" typeface="Nirmala UI"/>
-        <a:font script="Tale" typeface="Microsoft Tai Le"/>
-        <a:font script="Talu" typeface="Microsoft New Tai Lue"/>
-        <a:font script="Tfng" typeface="Ebrima"/>
-      </a:minorFont>
-    </a:fontScheme>
-    <a:fmtScheme name="Office">
-      <a:fillStyleLst>
-        <a:solidFill>
-          <a:schemeClr val="phClr"/>
-        </a:solidFill>
-        <a:gradFill rotWithShape="1">
-          <a:gsLst>
-            <a:gs pos="0">
-              <a:schemeClr val="phClr">
-                <a:lumMod val="110000"/>
-                <a:satMod val="105000"/>
-                <a:tint val="67000"/>
-              </a:schemeClr>
-            </a:gs>
-            <a:gs pos="50000">
-              <a:schemeClr val="phClr">
-                <a:lumMod val="105000"/>
-                <a:satMod val="103000"/>
-                <a:tint val="73000"/>
-              </a:schemeClr>
-            </a:gs>
-            <a:gs pos="100000">
-              <a:schemeClr val="phClr">
-                <a:lumMod val="105000"/>
-                <a:satMod val="109000"/>
-                <a:tint val="81000"/>
-              </a:schemeClr>
-            </a:gs>
-          </a:gsLst>
-          <a:lin ang="5400000" scaled="0"/>
-        </a:gradFill>
-        <a:gradFill rotWithShape="1">
-          <a:gsLst>
-            <a:gs pos="0">
-              <a:schemeClr val="phClr">
-                <a:satMod val="103000"/>
-                <a:lumMod val="102000"/>
-                <a:tint val="94000"/>
-              </a:schemeClr>
-            </a:gs>
-            <a:gs pos="50000">
-              <a:schemeClr val="phClr">
-                <a:satMod val="110000"/>
-                <a:lumMod val="100000"/>
-                <a:shade val="100000"/>
-              </a:schemeClr>
-            </a:gs>
-            <a:gs pos="100000">
-              <a:schemeClr val="phClr">
-                <a:lumMod val="99000"/>
-                <a:satMod val="120000"/>
-                <a:shade val="78000"/>
-              </a:schemeClr>
-            </a:gs>
-          </a:gsLst>
-          <a:lin ang="5400000" scaled="0"/>
-        </a:gradFill>
-      </a:fillStyleLst>
-      <a:lnStyleLst>
-        <a:ln w="12700" cap="flat" cmpd="sng" algn="ctr">
-          <a:solidFill>
-            <a:schemeClr val="phClr"/>
-          </a:solidFill>
-          <a:prstDash val="solid"/>
-          <a:miter lim="800000"/>
-        </a:ln>
-        <a:ln w="19050" cap="flat" cmpd="sng" algn="ctr">
-          <a:solidFill>
-            <a:schemeClr val="phClr"/>
-          </a:solidFill>
-          <a:prstDash val="solid"/>
-          <a:miter lim="800000"/>
-        </a:ln>
-        <a:ln w="25400" cap="flat" cmpd="sng" algn="ctr">
-          <a:solidFill>
-            <a:schemeClr val="phClr"/>
-          </a:solidFill>
-          <a:prstDash val="solid"/>
-          <a:miter lim="800000"/>
-        </a:ln>
-      </a:lnStyleLst>
-      <a:effectStyleLst>
-        <a:effectStyle>
-          <a:effectLst/>
-        </a:effectStyle>
-        <a:effectStyle>
-          <a:effectLst/>
-        </a:effectStyle>
-        <a:effectStyle>
-          <a:effectLst>
-            <a:outerShdw blurRad="57150" dist="19050" dir="5400000" algn="ctr" rotWithShape="0">
-              <a:srgbClr val="000000">
-                <a:alpha val="63000"/>
-              </a:srgbClr>
-            </a:outerShdw>
-          </a:effectLst>
-        </a:effectStyle>
-      </a:effectStyleLst>
-      <a:bgFillStyleLst>
-        <a:solidFill>
-          <a:schemeClr val="phClr"/>
-        </a:solidFill>
-        <a:solidFill>
-          <a:schemeClr val="phClr">
-            <a:tint val="95000"/>
-            <a:satMod val="170000"/>
-          </a:schemeClr>
-        </a:solidFill>
-        <a:gradFill rotWithShape="1">
-          <a:gsLst>
-            <a:gs pos="0">
-              <a:schemeClr val="phClr">
-                <a:tint val="93000"/>
-                <a:satMod val="150000"/>
-                <a:shade val="98000"/>
-                <a:lumMod val="102000"/>
-              </a:schemeClr>
-            </a:gs>
-            <a:gs pos="50000">
-              <a:schemeClr val="phClr">
-                <a:tint val="98000"/>
-                <a:satMod val="130000"/>
-                <a:shade val="90000"/>
-                <a:lumMod val="103000"/>
-              </a:schemeClr>
-            </a:gs>
-            <a:gs pos="100000">
-              <a:schemeClr val="phClr">
-                <a:shade val="63000"/>
-                <a:satMod val="120000"/>
-              </a:schemeClr>
-            </a:gs>
-          </a:gsLst>
-          <a:lin ang="5400000" scaled="0"/>
-        </a:gradFill>
-      </a:bgFillStyleLst>
-    </a:fmtScheme>
-  </a:themeElements>
-  <a:objectDefaults>
-    <a:lnDef>
-      <a:spPr/>
-      <a:bodyPr/>
-      <a:lstStyle/>
-      <a:style>
-        <a:lnRef idx="2">
-          <a:schemeClr val="accent1"/>
-        </a:lnRef>
-        <a:fillRef idx="0">
-          <a:schemeClr val="accent1"/>
-        </a:fillRef>
-        <a:effectRef idx="1">
-          <a:schemeClr val="accent1"/>
-        </a:effectRef>
-        <a:fontRef idx="minor">
-          <a:schemeClr val="tx1"/>
-        </a:fontRef>
-      </a:style>
-    </a:lnDef>
-  </a:objectDefaults>
-  <a:extraClrSchemeLst/>
-  <a:extLst>
-    <a:ext uri="{05A4C25C-085E-4340-85A3-A5531E510DB2}">
-      <thm15:themeFamily xmlns:thm15="http://schemas.microsoft.com/office/thememl/2012/main" name="Office Theme" id="{2E142A2C-CD16-42D6-873A-C26D2A0506FA}" vid="{1BDDFF52-6CD6-40A5-AB3C-68EB2F1E4D0A}"/>
-    </a:ext>
-  </a:extLst>
-</a:theme>
 </file>
</xml_diff>

<commit_message>
Update zambia_retail_v2.pptx with new content
</commit_message>
<xml_diff>
--- a/zambia_retail_v2.pptx
+++ b/zambia_retail_v2.pptx
@@ -4,6 +4,9 @@
   <p:sldMasterIdLst>
     <p:sldMasterId id="2147483648" r:id="rId1"/>
   </p:sldMasterIdLst>
+  <p:notesMasterIdLst>
+    <p:notesMasterId r:id="rId11"/>
+  </p:notesMasterIdLst>
   <p:sldIdLst>
     <p:sldId id="256" r:id="rId2"/>
     <p:sldId id="257" r:id="rId3"/>
@@ -15,10 +18,7 @@
     <p:sldId id="263" r:id="rId9"/>
     <p:sldId id="264" r:id="rId10"/>
   </p:sldIdLst>
-  <p:notesMasterIdLst>
-    <p:notesMasterId r:id="rId11"/>
-  </p:notesMasterIdLst>
-  <p:sldSz cx="9144000" cy="5143500"/>
+  <p:sldSz cx="9144000" cy="5143500" type="screen16x9"/>
   <p:notesSz cx="5143500" cy="9144000"/>
   <p:defaultTextStyle>
     <a:lvl1pPr marL="0" algn="l" defTabSz="914400" rtl="0" eaLnBrk="1" latinLnBrk="0" hangingPunct="1">
@@ -112,13 +112,20 @@
       </a:defRPr>
     </a:lvl9pPr>
   </p:defaultTextStyle>
+  <p:extLst>
+    <p:ext uri="{EFAFB233-063F-42B5-8137-9DF3F51BA10A}">
+      <p15:sldGuideLst xmlns:p15="http://schemas.microsoft.com/office/powerpoint/2012/main"/>
+    </p:ext>
+  </p:extLst>
 </p:presentation>
 </file>
 
 <file path=ppt/charts/chart1.xml><?xml version="1.0" encoding="utf-8"?>
-<c:chartSpace xmlns:c="http://schemas.openxmlformats.org/drawingml/2006/chart" xmlns:a="http://schemas.openxmlformats.org/drawingml/2006/main" xmlns:r="http://schemas.openxmlformats.org/officeDocument/2006/relationships">
+<c:chartSpace xmlns:c="http://schemas.openxmlformats.org/drawingml/2006/chart" xmlns:a="http://schemas.openxmlformats.org/drawingml/2006/main" xmlns:r="http://schemas.openxmlformats.org/officeDocument/2006/relationships" xmlns:c16r2="http://schemas.microsoft.com/office/drawing/2015/06/chart">
   <c:date1904 val="0"/>
+  <c:lang val="en-US"/>
   <c:roundedCorners val="0"/>
+  <c:style val="2"/>
   <c:chart>
     <c:title>
       <c:tx>
@@ -135,7 +142,7 @@
               </a:defRPr>
             </a:pPr>
             <a:r>
-              <a:rPr sz="1000" b="0" i="0" u="none" strike="noStrike">
+              <a:rPr lang="en-US" sz="1000" b="0" i="0" u="none" strike="noStrike">
                 <a:solidFill>
                   <a:srgbClr val="8A9BA8"/>
                 </a:solidFill>
@@ -146,7 +153,6 @@
           </a:p>
         </c:rich>
       </c:tx>
-      <c:layout/>
       <c:overlay val="0"/>
     </c:title>
     <c:autoTitleDeleted val="0"/>
@@ -177,30 +183,6 @@
             <a:effectLst/>
           </c:spPr>
           <c:invertIfNegative val="0"/>
-          <c:dLbls>
-            <c:numFmt formatCode="#,##0" sourceLinked="0"/>
-            <c:txPr>
-              <a:bodyPr/>
-              <a:lstStyle/>
-              <a:p>
-                <a:pPr>
-                  <a:defRPr b="0" i="0" strike="noStrike" sz="900" u="none">
-                    <a:solidFill>
-                      <a:srgbClr val="1C2B36"/>
-                    </a:solidFill>
-                    <a:latin typeface="Arial"/>
-                  </a:defRPr>
-                </a:pPr>
-              </a:p>
-            </c:txPr>
-            <c:showLegendKey val="0"/>
-            <c:showVal val="1"/>
-            <c:showCatName val="0"/>
-            <c:showSerName val="0"/>
-            <c:showPercent val="0"/>
-            <c:showBubbleSize val="0"/>
-            <c:showLeaderLines val="0"/>
-          </c:dLbls>
           <c:dPt>
             <c:idx val="0"/>
             <c:invertIfNegative val="0"/>
@@ -211,6 +193,11 @@
               </a:solidFill>
               <a:effectLst/>
             </c:spPr>
+            <c:extLst>
+              <c:ext xmlns:c16="http://schemas.microsoft.com/office/drawing/2014/chart" uri="{C3380CC4-5D6E-409C-BE32-E72D297353CC}">
+                <c16:uniqueId val="{00000001-DC78-484F-BB28-2D9EB75ABBFE}"/>
+              </c:ext>
+            </c:extLst>
           </c:dPt>
           <c:dPt>
             <c:idx val="1"/>
@@ -222,6 +209,11 @@
               </a:solidFill>
               <a:effectLst/>
             </c:spPr>
+            <c:extLst>
+              <c:ext xmlns:c16="http://schemas.microsoft.com/office/drawing/2014/chart" uri="{C3380CC4-5D6E-409C-BE32-E72D297353CC}">
+                <c16:uniqueId val="{00000003-DC78-484F-BB28-2D9EB75ABBFE}"/>
+              </c:ext>
+            </c:extLst>
           </c:dPt>
           <c:dPt>
             <c:idx val="2"/>
@@ -233,6 +225,11 @@
               </a:solidFill>
               <a:effectLst/>
             </c:spPr>
+            <c:extLst>
+              <c:ext xmlns:c16="http://schemas.microsoft.com/office/drawing/2014/chart" uri="{C3380CC4-5D6E-409C-BE32-E72D297353CC}">
+                <c16:uniqueId val="{00000005-DC78-484F-BB28-2D9EB75ABBFE}"/>
+              </c:ext>
+            </c:extLst>
           </c:dPt>
           <c:dPt>
             <c:idx val="3"/>
@@ -244,6 +241,11 @@
               </a:solidFill>
               <a:effectLst/>
             </c:spPr>
+            <c:extLst>
+              <c:ext xmlns:c16="http://schemas.microsoft.com/office/drawing/2014/chart" uri="{C3380CC4-5D6E-409C-BE32-E72D297353CC}">
+                <c16:uniqueId val="{00000007-DC78-484F-BB28-2D9EB75ABBFE}"/>
+              </c:ext>
+            </c:extLst>
           </c:dPt>
           <c:dPt>
             <c:idx val="4"/>
@@ -255,6 +257,11 @@
               </a:solidFill>
               <a:effectLst/>
             </c:spPr>
+            <c:extLst>
+              <c:ext xmlns:c16="http://schemas.microsoft.com/office/drawing/2014/chart" uri="{C3380CC4-5D6E-409C-BE32-E72D297353CC}">
+                <c16:uniqueId val="{00000009-DC78-484F-BB28-2D9EB75ABBFE}"/>
+              </c:ext>
+            </c:extLst>
           </c:dPt>
           <c:dPt>
             <c:idx val="5"/>
@@ -266,6 +273,11 @@
               </a:solidFill>
               <a:effectLst/>
             </c:spPr>
+            <c:extLst>
+              <c:ext xmlns:c16="http://schemas.microsoft.com/office/drawing/2014/chart" uri="{C3380CC4-5D6E-409C-BE32-E72D297353CC}">
+                <c16:uniqueId val="{0000000B-DC78-484F-BB28-2D9EB75ABBFE}"/>
+              </c:ext>
+            </c:extLst>
           </c:dPt>
           <c:dPt>
             <c:idx val="6"/>
@@ -277,37 +289,77 @@
               </a:solidFill>
               <a:effectLst/>
             </c:spPr>
+            <c:extLst>
+              <c:ext xmlns:c16="http://schemas.microsoft.com/office/drawing/2014/chart" uri="{C3380CC4-5D6E-409C-BE32-E72D297353CC}">
+                <c16:uniqueId val="{0000000D-DC78-484F-BB28-2D9EB75ABBFE}"/>
+              </c:ext>
+            </c:extLst>
           </c:dPt>
+          <c:dLbls>
+            <c:numFmt formatCode="#,##0" sourceLinked="0"/>
+            <c:spPr>
+              <a:noFill/>
+              <a:ln>
+                <a:noFill/>
+              </a:ln>
+              <a:effectLst/>
+            </c:spPr>
+            <c:txPr>
+              <a:bodyPr/>
+              <a:lstStyle/>
+              <a:p>
+                <a:pPr>
+                  <a:defRPr sz="900" b="0" i="0" u="none" strike="noStrike">
+                    <a:solidFill>
+                      <a:srgbClr val="1C2B36"/>
+                    </a:solidFill>
+                    <a:latin typeface="Arial"/>
+                  </a:defRPr>
+                </a:pPr>
+                <a:endParaRPr lang="en-US"/>
+              </a:p>
+            </c:txPr>
+            <c:showLegendKey val="0"/>
+            <c:showVal val="1"/>
+            <c:showCatName val="0"/>
+            <c:showSerName val="0"/>
+            <c:showPercent val="0"/>
+            <c:showBubbleSize val="0"/>
+            <c:showLeaderLines val="0"/>
+            <c:extLst>
+              <c:ext xmlns:c15="http://schemas.microsoft.com/office/drawing/2012/chart" uri="{CE6537A1-D6FC-4f65-9D91-7224C49458BB}">
+                <c15:showLeaderLines val="0"/>
+              </c:ext>
+            </c:extLst>
+          </c:dLbls>
           <c:cat>
-            <c:multiLvlStrRef>
+            <c:strRef>
               <c:f>Sheet1!$A$2:$A$8</c:f>
-              <c:multiLvlStrCache>
+              <c:strCache>
                 <c:ptCount val="7"/>
-                <c:lvl>
-                  <c:pt idx="0">
-                    <c:v>2023</c:v>
-                  </c:pt>
-                  <c:pt idx="1">
-                    <c:v>2024</c:v>
-                  </c:pt>
-                  <c:pt idx="2">
-                    <c:v>2025</c:v>
-                  </c:pt>
-                  <c:pt idx="3">
-                    <c:v>2026e</c:v>
-                  </c:pt>
-                  <c:pt idx="4">
-                    <c:v>2027e</c:v>
-                  </c:pt>
-                  <c:pt idx="5">
-                    <c:v>2028e</c:v>
-                  </c:pt>
-                  <c:pt idx="6">
-                    <c:v>2029e</c:v>
-                  </c:pt>
-                </c:lvl>
-              </c:multiLvlStrCache>
-            </c:multiLvlStrRef>
+                <c:pt idx="0">
+                  <c:v>2023</c:v>
+                </c:pt>
+                <c:pt idx="1">
+                  <c:v>2024</c:v>
+                </c:pt>
+                <c:pt idx="2">
+                  <c:v>2025</c:v>
+                </c:pt>
+                <c:pt idx="3">
+                  <c:v>2026e</c:v>
+                </c:pt>
+                <c:pt idx="4">
+                  <c:v>2027e</c:v>
+                </c:pt>
+                <c:pt idx="5">
+                  <c:v>2028e</c:v>
+                </c:pt>
+                <c:pt idx="6">
+                  <c:v>2029e</c:v>
+                </c:pt>
+              </c:strCache>
+            </c:strRef>
           </c:cat>
           <c:val>
             <c:numRef>
@@ -339,36 +391,23 @@
               </c:numCache>
             </c:numRef>
           </c:val>
+          <c:extLst>
+            <c:ext xmlns:c16="http://schemas.microsoft.com/office/drawing/2014/chart" uri="{C3380CC4-5D6E-409C-BE32-E72D297353CC}">
+              <c16:uniqueId val="{0000000E-DC78-484F-BB28-2D9EB75ABBFE}"/>
+            </c:ext>
+          </c:extLst>
         </c:ser>
         <c:dLbls>
-          <c:numFmt formatCode="#,##0" sourceLinked="0"/>
-          <c:txPr>
-            <a:bodyPr/>
-            <a:lstStyle/>
-            <a:p>
-              <a:pPr>
-                <a:defRPr b="0" i="0" strike="noStrike" sz="900" u="none">
-                  <a:solidFill>
-                    <a:srgbClr val="1C2B36"/>
-                  </a:solidFill>
-                  <a:latin typeface="Arial"/>
-                </a:defRPr>
-              </a:pPr>
-            </a:p>
-          </c:txPr>
           <c:showLegendKey val="0"/>
           <c:showVal val="1"/>
           <c:showCatName val="0"/>
           <c:showSerName val="0"/>
           <c:showPercent val="0"/>
           <c:showBubbleSize val="0"/>
-          <c:showLeaderLines val="0"/>
         </c:dLbls>
         <c:gapWidth val="150"/>
-        <c:overlap val="0"/>
         <c:axId val="2094734554"/>
         <c:axId val="2094734552"/>
-        <c:axId val="2094734556"/>
       </c:barChart>
       <c:catAx>
         <c:axId val="2094734554"/>
@@ -409,6 +448,7 @@
         <c:crosses val="autoZero"/>
         <c:auto val="1"/>
         <c:lblAlgn val="ctr"/>
+        <c:lblOffset val="100"/>
         <c:noMultiLvlLbl val="1"/>
       </c:catAx>
       <c:valAx>
@@ -471,6 +511,7 @@
     </c:plotArea>
     <c:plotVisOnly val="1"/>
     <c:dispBlanksAs val="span"/>
+    <c:showDLblsOverMax val="1"/>
   </c:chart>
   <c:spPr>
     <a:solidFill>
@@ -509,234 +550,10 @@
           <a:chExt cx="0" cy="0"/>
         </a:xfrm>
       </p:grpSpPr>
-      <p:sp>
-        <p:nvSpPr>
-          <p:cNvPr id="2" name="Header Placeholder 1"/>
-          <p:cNvSpPr>
-            <a:spLocks noGrp="1"/>
-          </p:cNvSpPr>
-          <p:nvPr>
-            <p:ph type="hdr" sz="quarter"/>
-          </p:nvPr>
-        </p:nvSpPr>
-        <p:spPr>
-          <a:xfrm>
-            <a:off x="0" y="0"/>
-            <a:ext cx="2971800" cy="458788"/>
-          </a:xfrm>
-          <a:prstGeom prst="rect">
-            <a:avLst/>
-          </a:prstGeom>
-        </p:spPr>
-        <p:txBody>
-          <a:bodyPr vert="horz" lIns="91440" tIns="45720" rIns="91440" bIns="45720" rtlCol="0"/>
-          <a:lstStyle>
-            <a:lvl1pPr algn="l">
-              <a:defRPr sz="1200"/>
-            </a:lvl1pPr>
-          </a:lstStyle>
-          <a:p>
-            <a:endParaRPr lang="en-US"/>
-          </a:p>
-        </p:txBody>
-      </p:sp>
-      <p:sp>
-        <p:nvSpPr>
-          <p:cNvPr id="3" name="Date Placeholder 2"/>
-          <p:cNvSpPr>
-            <a:spLocks noGrp="1"/>
-          </p:cNvSpPr>
-          <p:nvPr>
-            <p:ph type="dt" idx="1"/>
-          </p:nvPr>
-        </p:nvSpPr>
-        <p:spPr>
-          <a:xfrm>
-            <a:off x="3884613" y="0"/>
-            <a:ext cx="2971800" cy="458788"/>
-          </a:xfrm>
-          <a:prstGeom prst="rect">
-            <a:avLst/>
-          </a:prstGeom>
-        </p:spPr>
-        <p:txBody>
-          <a:bodyPr vert="horz" lIns="91440" tIns="45720" rIns="91440" bIns="45720" rtlCol="0"/>
-          <a:lstStyle>
-            <a:lvl1pPr algn="r">
-              <a:defRPr sz="1200"/>
-            </a:lvl1pPr>
-          </a:lstStyle>
-          <a:p>
-            <a:fld id="{5282F153-3F37-0F45-9E97-73ACFA13230C}" type="datetimeFigureOut">
-              <a:rPr lang="en-US"/>
-              <a:t>7/23/19</a:t>
-            </a:fld>
-            <a:endParaRPr lang="en-US"/>
-          </a:p>
-        </p:txBody>
-      </p:sp>
-      <p:sp>
-        <p:nvSpPr>
-          <p:cNvPr id="4" name="Slide Image Placeholder 3"/>
-          <p:cNvSpPr>
-            <a:spLocks noGrp="1" noRot="1" noChangeAspect="1"/>
-          </p:cNvSpPr>
-          <p:nvPr>
-            <p:ph type="sldImg" idx="2"/>
-          </p:nvPr>
-        </p:nvSpPr>
-        <p:spPr>
-          <a:xfrm>
-            <a:off x="685800" y="1143000"/>
-            <a:ext cx="5486400" cy="3086100"/>
-          </a:xfrm>
-          <a:prstGeom prst="rect">
-            <a:avLst/>
-          </a:prstGeom>
-          <a:noFill/>
-          <a:ln w="12700">
-            <a:solidFill>
-              <a:prstClr val="black"/>
-            </a:solidFill>
-          </a:ln>
-        </p:spPr>
-        <p:txBody>
-          <a:bodyPr vert="horz" lIns="91440" tIns="45720" rIns="91440" bIns="45720" rtlCol="0" anchor="ctr"/>
-          <a:lstStyle/>
-          <a:p>
-            <a:endParaRPr lang="en-US"/>
-          </a:p>
-        </p:txBody>
-      </p:sp>
-      <p:sp>
-        <p:nvSpPr>
-          <p:cNvPr id="5" name="Notes Placeholder 4"/>
-          <p:cNvSpPr>
-            <a:spLocks noGrp="1"/>
-          </p:cNvSpPr>
-          <p:nvPr>
-            <p:ph type="body" sz="quarter" idx="3"/>
-          </p:nvPr>
-        </p:nvSpPr>
-        <p:spPr>
-          <a:xfrm>
-            <a:off x="685800" y="4400550"/>
-            <a:ext cx="5486400" cy="3600450"/>
-          </a:xfrm>
-          <a:prstGeom prst="rect">
-            <a:avLst/>
-          </a:prstGeom>
-        </p:spPr>
-        <p:txBody>
-          <a:bodyPr vert="horz" lIns="91440" tIns="45720" rIns="91440" bIns="45720" rtlCol="0"/>
-          <a:lstStyle/>
-          <a:p>
-            <a:pPr lvl="0"/>
-            <a:r>
-              <a:rPr lang="en-US"/>
-              <a:t>Click to edit Master text styles</a:t>
-            </a:r>
-          </a:p>
-          <a:p>
-            <a:pPr lvl="1"/>
-            <a:r>
-              <a:rPr lang="en-US"/>
-              <a:t>Second level</a:t>
-            </a:r>
-          </a:p>
-          <a:p>
-            <a:pPr lvl="2"/>
-            <a:r>
-              <a:rPr lang="en-US"/>
-              <a:t>Third level</a:t>
-            </a:r>
-          </a:p>
-          <a:p>
-            <a:pPr lvl="3"/>
-            <a:r>
-              <a:rPr lang="en-US"/>
-              <a:t>Fourth level</a:t>
-            </a:r>
-          </a:p>
-          <a:p>
-            <a:pPr lvl="4"/>
-            <a:r>
-              <a:rPr lang="en-US"/>
-              <a:t>Fifth level</a:t>
-            </a:r>
-          </a:p>
-        </p:txBody>
-      </p:sp>
-      <p:sp>
-        <p:nvSpPr>
-          <p:cNvPr id="6" name="Footer Placeholder 5"/>
-          <p:cNvSpPr>
-            <a:spLocks noGrp="1"/>
-          </p:cNvSpPr>
-          <p:nvPr>
-            <p:ph type="ftr" sz="quarter" idx="4"/>
-          </p:nvPr>
-        </p:nvSpPr>
-        <p:spPr>
-          <a:xfrm>
-            <a:off x="0" y="8685213"/>
-            <a:ext cx="2971800" cy="458787"/>
-          </a:xfrm>
-          <a:prstGeom prst="rect">
-            <a:avLst/>
-          </a:prstGeom>
-        </p:spPr>
-        <p:txBody>
-          <a:bodyPr vert="horz" lIns="91440" tIns="45720" rIns="91440" bIns="45720" rtlCol="0" anchor="b"/>
-          <a:lstStyle>
-            <a:lvl1pPr algn="l">
-              <a:defRPr sz="1200"/>
-            </a:lvl1pPr>
-          </a:lstStyle>
-          <a:p>
-            <a:endParaRPr lang="en-US"/>
-          </a:p>
-        </p:txBody>
-      </p:sp>
-      <p:sp>
-        <p:nvSpPr>
-          <p:cNvPr id="7" name="Slide Number Placeholder 6"/>
-          <p:cNvSpPr>
-            <a:spLocks noGrp="1"/>
-          </p:cNvSpPr>
-          <p:nvPr>
-            <p:ph type="sldNum" sz="quarter" idx="5"/>
-          </p:nvPr>
-        </p:nvSpPr>
-        <p:spPr>
-          <a:xfrm>
-            <a:off x="3884613" y="8685213"/>
-            <a:ext cx="2971800" cy="458787"/>
-          </a:xfrm>
-          <a:prstGeom prst="rect">
-            <a:avLst/>
-          </a:prstGeom>
-        </p:spPr>
-        <p:txBody>
-          <a:bodyPr vert="horz" lIns="91440" tIns="45720" rIns="91440" bIns="45720" rtlCol="0" anchor="b"/>
-          <a:lstStyle>
-            <a:lvl1pPr algn="r">
-              <a:defRPr sz="1200"/>
-            </a:lvl1pPr>
-          </a:lstStyle>
-          <a:p>
-            <a:fld id="{CE5E9CC1-C706-0F49-92D6-E571CC5EEA8F}" type="slidenum">
-              <a:rPr lang="en-US"/>
-              <a:t>‹#›</a:t>
-            </a:fld>
-            <a:endParaRPr lang="en-US"/>
-          </a:p>
-        </p:txBody>
-      </p:sp>
     </p:spTree>
     <p:extLst>
       <p:ext uri="{BB962C8B-B14F-4D97-AF65-F5344CB8AC3E}">
-        <p14:creationId xmlns:p14="http://schemas.microsoft.com/office/powerpoint/2010/main" val="1024086991"/>
+        <p14:creationId xmlns:p14="http://schemas.microsoft.com/office/powerpoint/2010/main" val="302130326"/>
       </p:ext>
     </p:extLst>
   </p:cSld>
@@ -880,10 +697,6 @@
           <a:bodyPr/>
           <a:lstStyle/>
           <a:p>
-            <a:r>
-              <a:rPr lang="en-US" dirty="0"/>
-              <a:t/>
-            </a:r>
             <a:endParaRPr lang="en-US" dirty="0"/>
           </a:p>
         </p:txBody>
@@ -968,10 +781,6 @@
           <a:bodyPr/>
           <a:lstStyle/>
           <a:p>
-            <a:r>
-              <a:rPr lang="en-US" dirty="0"/>
-              <a:t/>
-            </a:r>
             <a:endParaRPr lang="en-US" dirty="0"/>
           </a:p>
         </p:txBody>
@@ -1056,10 +865,6 @@
           <a:bodyPr/>
           <a:lstStyle/>
           <a:p>
-            <a:r>
-              <a:rPr lang="en-US" dirty="0"/>
-              <a:t/>
-            </a:r>
             <a:endParaRPr lang="en-US" dirty="0"/>
           </a:p>
         </p:txBody>
@@ -1144,10 +949,6 @@
           <a:bodyPr/>
           <a:lstStyle/>
           <a:p>
-            <a:r>
-              <a:rPr lang="en-US" dirty="0"/>
-              <a:t/>
-            </a:r>
             <a:endParaRPr lang="en-US" dirty="0"/>
           </a:p>
         </p:txBody>
@@ -1232,10 +1033,6 @@
           <a:bodyPr/>
           <a:lstStyle/>
           <a:p>
-            <a:r>
-              <a:rPr lang="en-US" dirty="0"/>
-              <a:t/>
-            </a:r>
             <a:endParaRPr lang="en-US" dirty="0"/>
           </a:p>
         </p:txBody>
@@ -1320,10 +1117,6 @@
           <a:bodyPr/>
           <a:lstStyle/>
           <a:p>
-            <a:r>
-              <a:rPr lang="en-US" dirty="0"/>
-              <a:t/>
-            </a:r>
             <a:endParaRPr lang="en-US" dirty="0"/>
           </a:p>
         </p:txBody>
@@ -1408,10 +1201,6 @@
           <a:bodyPr/>
           <a:lstStyle/>
           <a:p>
-            <a:r>
-              <a:rPr lang="en-US" dirty="0"/>
-              <a:t/>
-            </a:r>
             <a:endParaRPr lang="en-US" dirty="0"/>
           </a:p>
         </p:txBody>
@@ -1496,10 +1285,6 @@
           <a:bodyPr/>
           <a:lstStyle/>
           <a:p>
-            <a:r>
-              <a:rPr lang="en-US" dirty="0"/>
-              <a:t/>
-            </a:r>
             <a:endParaRPr lang="en-US" dirty="0"/>
           </a:p>
         </p:txBody>
@@ -1584,10 +1369,6 @@
           <a:bodyPr/>
           <a:lstStyle/>
           <a:p>
-            <a:r>
-              <a:rPr lang="en-US" dirty="0"/>
-              <a:t/>
-            </a:r>
             <a:endParaRPr lang="en-US" dirty="0"/>
           </a:p>
         </p:txBody>
@@ -1661,6 +1442,11 @@
 <file path=ppt/slideMasters/slideMaster1.xml><?xml version="1.0" encoding="utf-8"?>
 <p:sldMaster xmlns:a="http://schemas.openxmlformats.org/drawingml/2006/main" xmlns:r="http://schemas.openxmlformats.org/officeDocument/2006/relationships" xmlns:p="http://schemas.openxmlformats.org/presentationml/2006/main">
   <p:cSld>
+    <p:bg>
+      <p:bgRef idx="1001">
+        <a:schemeClr val="bg1"/>
+      </p:bgRef>
+    </p:bg>
     <p:spTree>
       <p:nvGrpSpPr>
         <p:cNvPr id="1" name=""/>
@@ -1943,6 +1729,7 @@
         <a:solidFill>
           <a:srgbClr val="1C2B36"/>
         </a:solidFill>
+        <a:effectLst/>
       </p:bgPr>
     </p:bg>
     <p:spTree>
@@ -1987,6 +1774,13 @@
             <a:prstDash val="solid"/>
           </a:ln>
         </p:spPr>
+        <p:txBody>
+          <a:bodyPr/>
+          <a:lstStyle/>
+          <a:p>
+            <a:endParaRPr lang="en-US"/>
+          </a:p>
+        </p:txBody>
       </p:sp>
       <p:sp>
         <p:nvSpPr>
@@ -2016,6 +1810,13 @@
             <a:prstDash val="solid"/>
           </a:ln>
         </p:spPr>
+        <p:txBody>
+          <a:bodyPr/>
+          <a:lstStyle/>
+          <a:p>
+            <a:endParaRPr lang="en-US"/>
+          </a:p>
+        </p:txBody>
       </p:sp>
       <p:sp>
         <p:nvSpPr>
@@ -2038,11 +1839,11 @@
           <a:bodyPr wrap="square" lIns="0" tIns="0" rIns="0" bIns="0" rtlCol="0" anchor="ctr"/>
           <a:lstStyle/>
           <a:p>
-            <a:pPr indent="0" marL="0">
-              <a:buNone/>
-            </a:pPr>
-            <a:r>
-              <a:rPr lang="en-US" sz="1000" spc="400" kern="0" dirty="0">
+            <a:pPr marL="0" indent="0">
+              <a:buNone/>
+            </a:pPr>
+            <a:r>
+              <a:rPr lang="en-US" sz="1000" kern="0" spc="400" dirty="0">
                 <a:solidFill>
                   <a:srgbClr val="8A9BA8"/>
                 </a:solidFill>
@@ -2077,7 +1878,7 @@
           <a:bodyPr wrap="square" lIns="0" tIns="0" rIns="0" bIns="0" rtlCol="0" anchor="ctr"/>
           <a:lstStyle/>
           <a:p>
-            <a:pPr indent="0" marL="0">
+            <a:pPr marL="0" indent="0">
               <a:buNone/>
             </a:pPr>
             <a:r>
@@ -2094,7 +1895,7 @@
             <a:endParaRPr lang="en-US" sz="4400" dirty="0"/>
           </a:p>
           <a:p>
-            <a:pPr indent="0" marL="0">
+            <a:pPr marL="0" indent="0">
               <a:buNone/>
             </a:pPr>
             <a:r>
@@ -2133,7 +1934,7 @@
           <a:bodyPr wrap="square" lIns="0" tIns="0" rIns="0" bIns="0" rtlCol="0" anchor="ctr"/>
           <a:lstStyle/>
           <a:p>
-            <a:pPr indent="0" marL="0">
+            <a:pPr marL="0" indent="0">
               <a:buNone/>
             </a:pPr>
             <a:r>
@@ -2179,6 +1980,13 @@
             <a:prstDash val="solid"/>
           </a:ln>
         </p:spPr>
+        <p:txBody>
+          <a:bodyPr/>
+          <a:lstStyle/>
+          <a:p>
+            <a:endParaRPr lang="en-US"/>
+          </a:p>
+        </p:txBody>
       </p:sp>
       <p:sp>
         <p:nvSpPr>
@@ -2201,7 +2009,7 @@
           <a:bodyPr wrap="square" lIns="0" tIns="0" rIns="0" bIns="0" rtlCol="0" anchor="ctr"/>
           <a:lstStyle/>
           <a:p>
-            <a:pPr indent="0" marL="0">
+            <a:pPr marL="0" indent="0">
               <a:buNone/>
             </a:pPr>
             <a:r>
@@ -2235,6 +2043,7 @@
         <a:solidFill>
           <a:srgbClr val="FFFFFF"/>
         </a:solidFill>
+        <a:effectLst/>
       </p:bgPr>
     </p:bg>
     <p:spTree>
@@ -2272,7 +2081,7 @@
           <a:bodyPr wrap="square" lIns="0" tIns="0" rIns="0" bIns="0" rtlCol="0" anchor="ctr"/>
           <a:lstStyle/>
           <a:p>
-            <a:pPr indent="0" marL="0">
+            <a:pPr marL="0" indent="0">
               <a:buNone/>
             </a:pPr>
             <a:r>
@@ -2314,6 +2123,13 @@
             <a:prstDash val="solid"/>
           </a:ln>
         </p:spPr>
+        <p:txBody>
+          <a:bodyPr/>
+          <a:lstStyle/>
+          <a:p>
+            <a:endParaRPr lang="en-US"/>
+          </a:p>
+        </p:txBody>
       </p:sp>
       <p:sp>
         <p:nvSpPr>
@@ -2336,7 +2152,7 @@
           <a:bodyPr wrap="square" lIns="0" tIns="0" rIns="0" bIns="0" rtlCol="0" anchor="ctr"/>
           <a:lstStyle/>
           <a:p>
-            <a:pPr indent="0" marL="0">
+            <a:pPr marL="0" indent="0">
               <a:buNone/>
             </a:pPr>
             <a:r>
@@ -2375,7 +2191,7 @@
           <a:bodyPr wrap="square" lIns="0" tIns="0" rIns="0" bIns="0" rtlCol="0" anchor="ctr"/>
           <a:lstStyle/>
           <a:p>
-            <a:pPr indent="0" marL="0">
+            <a:pPr marL="0" indent="0">
               <a:buNone/>
             </a:pPr>
             <a:r>
@@ -2417,6 +2233,13 @@
             <a:prstDash val="solid"/>
           </a:ln>
         </p:spPr>
+        <p:txBody>
+          <a:bodyPr/>
+          <a:lstStyle/>
+          <a:p>
+            <a:endParaRPr lang="en-US"/>
+          </a:p>
+        </p:txBody>
       </p:sp>
       <p:sp>
         <p:nvSpPr>
@@ -2439,7 +2262,7 @@
           <a:bodyPr wrap="square" lIns="0" tIns="0" rIns="0" bIns="0" rtlCol="0" anchor="ctr"/>
           <a:lstStyle/>
           <a:p>
-            <a:pPr indent="0" marL="0">
+            <a:pPr marL="0" indent="0">
               <a:buNone/>
             </a:pPr>
             <a:r>
@@ -2478,7 +2301,7 @@
           <a:bodyPr wrap="square" lIns="0" tIns="0" rIns="0" bIns="0" rtlCol="0" anchor="ctr"/>
           <a:lstStyle/>
           <a:p>
-            <a:pPr indent="0" marL="0">
+            <a:pPr marL="0" indent="0">
               <a:buNone/>
             </a:pPr>
             <a:r>
@@ -2520,6 +2343,13 @@
             <a:prstDash val="solid"/>
           </a:ln>
         </p:spPr>
+        <p:txBody>
+          <a:bodyPr/>
+          <a:lstStyle/>
+          <a:p>
+            <a:endParaRPr lang="en-US"/>
+          </a:p>
+        </p:txBody>
       </p:sp>
       <p:sp>
         <p:nvSpPr>
@@ -2542,7 +2372,7 @@
           <a:bodyPr wrap="square" lIns="0" tIns="0" rIns="0" bIns="0" rtlCol="0" anchor="ctr"/>
           <a:lstStyle/>
           <a:p>
-            <a:pPr indent="0" marL="0">
+            <a:pPr marL="0" indent="0">
               <a:buNone/>
             </a:pPr>
             <a:r>
@@ -2581,7 +2411,7 @@
           <a:bodyPr wrap="square" lIns="0" tIns="0" rIns="0" bIns="0" rtlCol="0" anchor="ctr"/>
           <a:lstStyle/>
           <a:p>
-            <a:pPr indent="0" marL="0">
+            <a:pPr marL="0" indent="0">
               <a:buNone/>
             </a:pPr>
             <a:r>
@@ -2623,6 +2453,13 @@
             <a:prstDash val="solid"/>
           </a:ln>
         </p:spPr>
+        <p:txBody>
+          <a:bodyPr/>
+          <a:lstStyle/>
+          <a:p>
+            <a:endParaRPr lang="en-US"/>
+          </a:p>
+        </p:txBody>
       </p:sp>
       <p:sp>
         <p:nvSpPr>
@@ -2645,7 +2482,7 @@
           <a:bodyPr wrap="square" lIns="0" tIns="0" rIns="0" bIns="0" rtlCol="0" anchor="ctr"/>
           <a:lstStyle/>
           <a:p>
-            <a:pPr indent="0" marL="0">
+            <a:pPr marL="0" indent="0">
               <a:buNone/>
             </a:pPr>
             <a:r>
@@ -2684,7 +2521,7 @@
           <a:bodyPr wrap="square" lIns="0" tIns="0" rIns="0" bIns="0" rtlCol="0" anchor="ctr"/>
           <a:lstStyle/>
           <a:p>
-            <a:pPr indent="0" marL="0">
+            <a:pPr marL="0" indent="0">
               <a:buNone/>
             </a:pPr>
             <a:r>
@@ -2726,6 +2563,13 @@
             <a:prstDash val="solid"/>
           </a:ln>
         </p:spPr>
+        <p:txBody>
+          <a:bodyPr/>
+          <a:lstStyle/>
+          <a:p>
+            <a:endParaRPr lang="en-US"/>
+          </a:p>
+        </p:txBody>
       </p:sp>
       <p:sp>
         <p:nvSpPr>
@@ -2748,7 +2592,7 @@
           <a:bodyPr wrap="square" lIns="0" tIns="0" rIns="0" bIns="0" rtlCol="0" anchor="ctr"/>
           <a:lstStyle/>
           <a:p>
-            <a:pPr indent="0" marL="0">
+            <a:pPr marL="0" indent="0">
               <a:buNone/>
             </a:pPr>
             <a:r>
@@ -2787,7 +2631,7 @@
           <a:bodyPr wrap="square" lIns="0" tIns="0" rIns="0" bIns="0" rtlCol="0" anchor="ctr"/>
           <a:lstStyle/>
           <a:p>
-            <a:pPr indent="0" marL="0">
+            <a:pPr marL="0" indent="0">
               <a:buNone/>
             </a:pPr>
             <a:r>
@@ -2829,6 +2673,13 @@
             <a:prstDash val="solid"/>
           </a:ln>
         </p:spPr>
+        <p:txBody>
+          <a:bodyPr/>
+          <a:lstStyle/>
+          <a:p>
+            <a:endParaRPr lang="en-US"/>
+          </a:p>
+        </p:txBody>
       </p:sp>
       <p:sp>
         <p:nvSpPr>
@@ -2851,7 +2702,7 @@
           <a:bodyPr wrap="square" lIns="0" tIns="0" rIns="0" bIns="0" rtlCol="0" anchor="ctr"/>
           <a:lstStyle/>
           <a:p>
-            <a:pPr indent="0" marL="0">
+            <a:pPr marL="0" indent="0">
               <a:buNone/>
             </a:pPr>
             <a:r>
@@ -2890,7 +2741,7 @@
           <a:bodyPr wrap="square" lIns="0" tIns="0" rIns="0" bIns="0" rtlCol="0" anchor="ctr"/>
           <a:lstStyle/>
           <a:p>
-            <a:pPr indent="0" marL="0">
+            <a:pPr marL="0" indent="0">
               <a:buNone/>
             </a:pPr>
             <a:r>
@@ -2924,6 +2775,7 @@
         <a:solidFill>
           <a:srgbClr val="FFFFFF"/>
         </a:solidFill>
+        <a:effectLst/>
       </p:bgPr>
     </p:bg>
     <p:spTree>
@@ -2961,7 +2813,7 @@
           <a:bodyPr wrap="square" lIns="0" tIns="0" rIns="0" bIns="0" rtlCol="0" anchor="ctr"/>
           <a:lstStyle/>
           <a:p>
-            <a:pPr indent="0" marL="0">
+            <a:pPr marL="0" indent="0">
               <a:buNone/>
             </a:pPr>
             <a:r>
@@ -3003,6 +2855,13 @@
             <a:prstDash val="solid"/>
           </a:ln>
         </p:spPr>
+        <p:txBody>
+          <a:bodyPr/>
+          <a:lstStyle/>
+          <a:p>
+            <a:endParaRPr lang="en-US"/>
+          </a:p>
+        </p:txBody>
       </p:sp>
       <p:sp>
         <p:nvSpPr>
@@ -3025,7 +2884,7 @@
           <a:bodyPr wrap="square" lIns="0" tIns="0" rIns="0" bIns="0" rtlCol="0" anchor="ctr"/>
           <a:lstStyle/>
           <a:p>
-            <a:pPr indent="0" marL="0">
+            <a:pPr marL="0" indent="0">
               <a:buNone/>
             </a:pPr>
             <a:r>
@@ -3067,6 +2926,13 @@
             <a:prstDash val="solid"/>
           </a:ln>
         </p:spPr>
+        <p:txBody>
+          <a:bodyPr/>
+          <a:lstStyle/>
+          <a:p>
+            <a:endParaRPr lang="en-US"/>
+          </a:p>
+        </p:txBody>
       </p:sp>
       <p:sp>
         <p:nvSpPr>
@@ -3092,6 +2958,13 @@
             <a:prstDash val="solid"/>
           </a:ln>
         </p:spPr>
+        <p:txBody>
+          <a:bodyPr/>
+          <a:lstStyle/>
+          <a:p>
+            <a:endParaRPr lang="en-US"/>
+          </a:p>
+        </p:txBody>
       </p:sp>
       <p:sp>
         <p:nvSpPr>
@@ -3114,7 +2987,7 @@
           <a:bodyPr wrap="square" lIns="0" tIns="0" rIns="0" bIns="0" rtlCol="0" anchor="ctr"/>
           <a:lstStyle/>
           <a:p>
-            <a:pPr indent="0" marL="0">
+            <a:pPr marL="0" indent="0">
               <a:buNone/>
             </a:pPr>
             <a:r>
@@ -3153,7 +3026,7 @@
           <a:bodyPr wrap="square" lIns="0" tIns="0" rIns="0" bIns="0" rtlCol="0" anchor="ctr"/>
           <a:lstStyle/>
           <a:p>
-            <a:pPr indent="0" marL="0">
+            <a:pPr marL="0" indent="0">
               <a:buNone/>
             </a:pPr>
             <a:r>
@@ -3195,6 +3068,13 @@
             <a:prstDash val="solid"/>
           </a:ln>
         </p:spPr>
+        <p:txBody>
+          <a:bodyPr/>
+          <a:lstStyle/>
+          <a:p>
+            <a:endParaRPr lang="en-US"/>
+          </a:p>
+        </p:txBody>
       </p:sp>
       <p:sp>
         <p:nvSpPr>
@@ -3220,6 +3100,13 @@
             <a:prstDash val="solid"/>
           </a:ln>
         </p:spPr>
+        <p:txBody>
+          <a:bodyPr/>
+          <a:lstStyle/>
+          <a:p>
+            <a:endParaRPr lang="en-US"/>
+          </a:p>
+        </p:txBody>
       </p:sp>
       <p:sp>
         <p:nvSpPr>
@@ -3242,7 +3129,7 @@
           <a:bodyPr wrap="square" lIns="0" tIns="0" rIns="0" bIns="0" rtlCol="0" anchor="ctr"/>
           <a:lstStyle/>
           <a:p>
-            <a:pPr indent="0" marL="0">
+            <a:pPr marL="0" indent="0">
               <a:buNone/>
             </a:pPr>
             <a:r>
@@ -3281,7 +3168,7 @@
           <a:bodyPr wrap="square" lIns="0" tIns="0" rIns="0" bIns="0" rtlCol="0" anchor="ctr"/>
           <a:lstStyle/>
           <a:p>
-            <a:pPr indent="0" marL="0">
+            <a:pPr marL="0" indent="0">
               <a:buNone/>
             </a:pPr>
             <a:r>
@@ -3323,6 +3210,13 @@
             <a:prstDash val="solid"/>
           </a:ln>
         </p:spPr>
+        <p:txBody>
+          <a:bodyPr/>
+          <a:lstStyle/>
+          <a:p>
+            <a:endParaRPr lang="en-US"/>
+          </a:p>
+        </p:txBody>
       </p:sp>
       <p:sp>
         <p:nvSpPr>
@@ -3348,6 +3242,13 @@
             <a:prstDash val="solid"/>
           </a:ln>
         </p:spPr>
+        <p:txBody>
+          <a:bodyPr/>
+          <a:lstStyle/>
+          <a:p>
+            <a:endParaRPr lang="en-US"/>
+          </a:p>
+        </p:txBody>
       </p:sp>
       <p:sp>
         <p:nvSpPr>
@@ -3370,7 +3271,7 @@
           <a:bodyPr wrap="square" lIns="0" tIns="0" rIns="0" bIns="0" rtlCol="0" anchor="ctr"/>
           <a:lstStyle/>
           <a:p>
-            <a:pPr indent="0" marL="0">
+            <a:pPr marL="0" indent="0">
               <a:buNone/>
             </a:pPr>
             <a:r>
@@ -3409,7 +3310,7 @@
           <a:bodyPr wrap="square" lIns="0" tIns="0" rIns="0" bIns="0" rtlCol="0" anchor="ctr"/>
           <a:lstStyle/>
           <a:p>
-            <a:pPr indent="0" marL="0">
+            <a:pPr marL="0" indent="0">
               <a:buNone/>
             </a:pPr>
             <a:r>
@@ -3421,7 +3322,7 @@
                 <a:ea typeface="Poppins" pitchFamily="34" charset="-122"/>
                 <a:cs typeface="Poppins" pitchFamily="34" charset="-120"/>
               </a:rPr>
-              <a:t>Platforms like Jumia</a:t>
+              <a:t>Platforms like Amazon</a:t>
             </a:r>
             <a:endParaRPr lang="en-US" sz="1100" dirty="0"/>
           </a:p>
@@ -3451,6 +3352,13 @@
             <a:prstDash val="solid"/>
           </a:ln>
         </p:spPr>
+        <p:txBody>
+          <a:bodyPr/>
+          <a:lstStyle/>
+          <a:p>
+            <a:endParaRPr lang="en-US"/>
+          </a:p>
+        </p:txBody>
       </p:sp>
       <p:sp>
         <p:nvSpPr>
@@ -3476,6 +3384,13 @@
             <a:prstDash val="solid"/>
           </a:ln>
         </p:spPr>
+        <p:txBody>
+          <a:bodyPr/>
+          <a:lstStyle/>
+          <a:p>
+            <a:endParaRPr lang="en-US"/>
+          </a:p>
+        </p:txBody>
       </p:sp>
       <p:sp>
         <p:nvSpPr>
@@ -3498,7 +3413,7 @@
           <a:bodyPr wrap="square" lIns="0" tIns="0" rIns="0" bIns="0" rtlCol="0" anchor="ctr"/>
           <a:lstStyle/>
           <a:p>
-            <a:pPr indent="0" marL="0">
+            <a:pPr marL="0" indent="0">
               <a:buNone/>
             </a:pPr>
             <a:r>
@@ -3537,7 +3452,7 @@
           <a:bodyPr wrap="square" lIns="0" tIns="0" rIns="0" bIns="0" rtlCol="0" anchor="ctr"/>
           <a:lstStyle/>
           <a:p>
-            <a:pPr indent="0" marL="0">
+            <a:pPr marL="0" indent="0">
               <a:buNone/>
             </a:pPr>
             <a:r>
@@ -3571,6 +3486,7 @@
         <a:solidFill>
           <a:srgbClr val="FFFFFF"/>
         </a:solidFill>
+        <a:effectLst/>
       </p:bgPr>
     </p:bg>
     <p:spTree>
@@ -3608,7 +3524,7 @@
           <a:bodyPr wrap="square" lIns="0" tIns="0" rIns="0" bIns="0" rtlCol="0" anchor="ctr"/>
           <a:lstStyle/>
           <a:p>
-            <a:pPr indent="0" marL="0">
+            <a:pPr marL="0" indent="0">
               <a:buNone/>
             </a:pPr>
             <a:r>
@@ -3650,6 +3566,13 @@
             <a:prstDash val="solid"/>
           </a:ln>
         </p:spPr>
+        <p:txBody>
+          <a:bodyPr/>
+          <a:lstStyle/>
+          <a:p>
+            <a:endParaRPr lang="en-US"/>
+          </a:p>
+        </p:txBody>
       </p:sp>
       <p:sp>
         <p:nvSpPr>
@@ -3672,7 +3595,7 @@
           <a:bodyPr wrap="square" lIns="0" tIns="0" rIns="0" bIns="0" rtlCol="0" anchor="ctr"/>
           <a:lstStyle/>
           <a:p>
-            <a:pPr algn="ctr" indent="0" marL="0">
+            <a:pPr marL="0" indent="0" algn="ctr">
               <a:buNone/>
             </a:pPr>
             <a:r>
@@ -3711,7 +3634,7 @@
           <a:bodyPr wrap="square" lIns="0" tIns="0" rIns="0" bIns="0" rtlCol="0" anchor="ctr"/>
           <a:lstStyle/>
           <a:p>
-            <a:pPr algn="ctr" indent="0" marL="0">
+            <a:pPr marL="0" indent="0" algn="ctr">
               <a:buNone/>
             </a:pPr>
             <a:r>
@@ -3753,6 +3676,13 @@
             <a:prstDash val="solid"/>
           </a:ln>
         </p:spPr>
+        <p:txBody>
+          <a:bodyPr/>
+          <a:lstStyle/>
+          <a:p>
+            <a:endParaRPr lang="en-US"/>
+          </a:p>
+        </p:txBody>
       </p:sp>
       <p:sp>
         <p:nvSpPr>
@@ -3775,7 +3705,7 @@
           <a:bodyPr wrap="square" lIns="0" tIns="0" rIns="0" bIns="0" rtlCol="0" anchor="ctr"/>
           <a:lstStyle/>
           <a:p>
-            <a:pPr algn="ctr" indent="0" marL="0">
+            <a:pPr marL="0" indent="0" algn="ctr">
               <a:buNone/>
             </a:pPr>
             <a:r>
@@ -3814,7 +3744,7 @@
           <a:bodyPr wrap="square" lIns="0" tIns="0" rIns="0" bIns="0" rtlCol="0" anchor="ctr"/>
           <a:lstStyle/>
           <a:p>
-            <a:pPr algn="ctr" indent="0" marL="0">
+            <a:pPr marL="0" indent="0" algn="ctr">
               <a:buNone/>
             </a:pPr>
             <a:r>
@@ -3856,6 +3786,13 @@
             <a:prstDash val="solid"/>
           </a:ln>
         </p:spPr>
+        <p:txBody>
+          <a:bodyPr/>
+          <a:lstStyle/>
+          <a:p>
+            <a:endParaRPr lang="en-US"/>
+          </a:p>
+        </p:txBody>
       </p:sp>
       <p:sp>
         <p:nvSpPr>
@@ -3878,7 +3815,7 @@
           <a:bodyPr wrap="square" lIns="0" tIns="0" rIns="0" bIns="0" rtlCol="0" anchor="ctr"/>
           <a:lstStyle/>
           <a:p>
-            <a:pPr algn="ctr" indent="0" marL="0">
+            <a:pPr marL="0" indent="0" algn="ctr">
               <a:buNone/>
             </a:pPr>
             <a:r>
@@ -3917,7 +3854,7 @@
           <a:bodyPr wrap="square" lIns="0" tIns="0" rIns="0" bIns="0" rtlCol="0" anchor="ctr"/>
           <a:lstStyle/>
           <a:p>
-            <a:pPr algn="ctr" indent="0" marL="0">
+            <a:pPr marL="0" indent="0" algn="ctr">
               <a:buNone/>
             </a:pPr>
             <a:r>
@@ -3959,6 +3896,13 @@
             <a:prstDash val="solid"/>
           </a:ln>
         </p:spPr>
+        <p:txBody>
+          <a:bodyPr/>
+          <a:lstStyle/>
+          <a:p>
+            <a:endParaRPr lang="en-US"/>
+          </a:p>
+        </p:txBody>
       </p:sp>
       <p:sp>
         <p:nvSpPr>
@@ -3981,7 +3925,7 @@
           <a:bodyPr wrap="square" lIns="0" tIns="0" rIns="0" bIns="0" rtlCol="0" anchor="ctr"/>
           <a:lstStyle/>
           <a:p>
-            <a:pPr indent="0" marL="0">
+            <a:pPr marL="0" indent="0">
               <a:buNone/>
             </a:pPr>
             <a:r>
@@ -4020,7 +3964,7 @@
           <a:bodyPr wrap="square" lIns="0" tIns="0" rIns="0" bIns="0" rtlCol="0" anchor="ctr"/>
           <a:lstStyle/>
           <a:p>
-            <a:pPr indent="0" marL="0">
+            <a:pPr marL="0" indent="0">
               <a:buNone/>
             </a:pPr>
             <a:r>
@@ -4059,7 +4003,7 @@
           <a:bodyPr wrap="square" lIns="0" tIns="0" rIns="0" bIns="0" rtlCol="0" anchor="ctr"/>
           <a:lstStyle/>
           <a:p>
-            <a:pPr indent="0" marL="0">
+            <a:pPr marL="0" indent="0">
               <a:buNone/>
             </a:pPr>
             <a:r>
@@ -4101,6 +4045,13 @@
             <a:prstDash val="solid"/>
           </a:ln>
         </p:spPr>
+        <p:txBody>
+          <a:bodyPr/>
+          <a:lstStyle/>
+          <a:p>
+            <a:endParaRPr lang="en-US"/>
+          </a:p>
+        </p:txBody>
       </p:sp>
       <p:sp>
         <p:nvSpPr>
@@ -4123,7 +4074,7 @@
           <a:bodyPr wrap="square" lIns="0" tIns="0" rIns="0" bIns="0" rtlCol="0" anchor="ctr"/>
           <a:lstStyle/>
           <a:p>
-            <a:pPr indent="0" marL="0">
+            <a:pPr marL="0" indent="0">
               <a:buNone/>
             </a:pPr>
             <a:r>
@@ -4162,7 +4113,7 @@
           <a:bodyPr wrap="square" lIns="0" tIns="0" rIns="0" bIns="0" rtlCol="0" anchor="ctr"/>
           <a:lstStyle/>
           <a:p>
-            <a:pPr indent="0" marL="0">
+            <a:pPr marL="0" indent="0">
               <a:buNone/>
             </a:pPr>
             <a:r>
@@ -4201,7 +4152,7 @@
           <a:bodyPr wrap="square" lIns="0" tIns="0" rIns="0" bIns="0" rtlCol="0" anchor="ctr"/>
           <a:lstStyle/>
           <a:p>
-            <a:pPr indent="0" marL="0">
+            <a:pPr marL="0" indent="0">
               <a:buNone/>
             </a:pPr>
             <a:r>
@@ -4243,6 +4194,13 @@
             <a:prstDash val="solid"/>
           </a:ln>
         </p:spPr>
+        <p:txBody>
+          <a:bodyPr/>
+          <a:lstStyle/>
+          <a:p>
+            <a:endParaRPr lang="en-US"/>
+          </a:p>
+        </p:txBody>
       </p:sp>
       <p:sp>
         <p:nvSpPr>
@@ -4265,7 +4223,7 @@
           <a:bodyPr wrap="square" lIns="0" tIns="0" rIns="0" bIns="0" rtlCol="0" anchor="ctr"/>
           <a:lstStyle/>
           <a:p>
-            <a:pPr indent="0" marL="0">
+            <a:pPr marL="0" indent="0">
               <a:buNone/>
             </a:pPr>
             <a:r>
@@ -4304,7 +4262,7 @@
           <a:bodyPr wrap="square" lIns="0" tIns="0" rIns="0" bIns="0" rtlCol="0" anchor="ctr"/>
           <a:lstStyle/>
           <a:p>
-            <a:pPr indent="0" marL="0">
+            <a:pPr marL="0" indent="0">
               <a:buNone/>
             </a:pPr>
             <a:r>
@@ -4343,7 +4301,7 @@
           <a:bodyPr wrap="square" lIns="0" tIns="0" rIns="0" bIns="0" rtlCol="0" anchor="ctr"/>
           <a:lstStyle/>
           <a:p>
-            <a:pPr indent="0" marL="0">
+            <a:pPr marL="0" indent="0">
               <a:buNone/>
             </a:pPr>
             <a:r>
@@ -4377,6 +4335,7 @@
         <a:solidFill>
           <a:srgbClr val="FFFFFF"/>
         </a:solidFill>
+        <a:effectLst/>
       </p:bgPr>
     </p:bg>
     <p:spTree>
@@ -4414,7 +4373,7 @@
           <a:bodyPr wrap="square" lIns="0" tIns="0" rIns="0" bIns="0" rtlCol="0" anchor="ctr"/>
           <a:lstStyle/>
           <a:p>
-            <a:pPr indent="0" marL="0">
+            <a:pPr marL="0" indent="0">
               <a:buNone/>
             </a:pPr>
             <a:r>
@@ -4456,6 +4415,13 @@
             <a:prstDash val="solid"/>
           </a:ln>
         </p:spPr>
+        <p:txBody>
+          <a:bodyPr/>
+          <a:lstStyle/>
+          <a:p>
+            <a:endParaRPr lang="en-US"/>
+          </a:p>
+        </p:txBody>
       </p:sp>
       <p:sp>
         <p:nvSpPr>
@@ -4478,7 +4444,7 @@
           <a:bodyPr wrap="square" lIns="0" tIns="0" rIns="0" bIns="0" rtlCol="0" anchor="ctr"/>
           <a:lstStyle/>
           <a:p>
-            <a:pPr algn="ctr" indent="0" marL="0">
+            <a:pPr marL="0" indent="0" algn="ctr">
               <a:buNone/>
             </a:pPr>
             <a:r>
@@ -4517,7 +4483,7 @@
           <a:bodyPr wrap="square" lIns="0" tIns="0" rIns="0" bIns="0" rtlCol="0" anchor="ctr"/>
           <a:lstStyle/>
           <a:p>
-            <a:pPr algn="ctr" indent="0" marL="0">
+            <a:pPr marL="0" indent="0" algn="ctr">
               <a:buNone/>
             </a:pPr>
             <a:r>
@@ -4559,6 +4525,13 @@
             <a:prstDash val="solid"/>
           </a:ln>
         </p:spPr>
+        <p:txBody>
+          <a:bodyPr/>
+          <a:lstStyle/>
+          <a:p>
+            <a:endParaRPr lang="en-US"/>
+          </a:p>
+        </p:txBody>
       </p:sp>
       <p:sp>
         <p:nvSpPr>
@@ -4581,7 +4554,7 @@
           <a:bodyPr wrap="square" lIns="0" tIns="0" rIns="0" bIns="0" rtlCol="0" anchor="ctr"/>
           <a:lstStyle/>
           <a:p>
-            <a:pPr algn="ctr" indent="0" marL="0">
+            <a:pPr marL="0" indent="0" algn="ctr">
               <a:buNone/>
             </a:pPr>
             <a:r>
@@ -4620,7 +4593,7 @@
           <a:bodyPr wrap="square" lIns="0" tIns="0" rIns="0" bIns="0" rtlCol="0" anchor="ctr"/>
           <a:lstStyle/>
           <a:p>
-            <a:pPr algn="ctr" indent="0" marL="0">
+            <a:pPr marL="0" indent="0" algn="ctr">
               <a:buNone/>
             </a:pPr>
             <a:r>
@@ -4662,6 +4635,13 @@
             <a:prstDash val="solid"/>
           </a:ln>
         </p:spPr>
+        <p:txBody>
+          <a:bodyPr/>
+          <a:lstStyle/>
+          <a:p>
+            <a:endParaRPr lang="en-US"/>
+          </a:p>
+        </p:txBody>
       </p:sp>
       <p:sp>
         <p:nvSpPr>
@@ -4684,7 +4664,7 @@
           <a:bodyPr wrap="square" lIns="0" tIns="0" rIns="0" bIns="0" rtlCol="0" anchor="ctr"/>
           <a:lstStyle/>
           <a:p>
-            <a:pPr algn="ctr" indent="0" marL="0">
+            <a:pPr marL="0" indent="0" algn="ctr">
               <a:buNone/>
             </a:pPr>
             <a:r>
@@ -4723,7 +4703,7 @@
           <a:bodyPr wrap="square" lIns="0" tIns="0" rIns="0" bIns="0" rtlCol="0" anchor="ctr"/>
           <a:lstStyle/>
           <a:p>
-            <a:pPr algn="ctr" indent="0" marL="0">
+            <a:pPr marL="0" indent="0" algn="ctr">
               <a:buNone/>
             </a:pPr>
             <a:r>
@@ -4765,6 +4745,13 @@
             <a:prstDash val="solid"/>
           </a:ln>
         </p:spPr>
+        <p:txBody>
+          <a:bodyPr/>
+          <a:lstStyle/>
+          <a:p>
+            <a:endParaRPr lang="en-US"/>
+          </a:p>
+        </p:txBody>
       </p:sp>
       <p:sp>
         <p:nvSpPr>
@@ -4787,7 +4774,7 @@
           <a:bodyPr wrap="square" lIns="0" tIns="0" rIns="0" bIns="0" rtlCol="0" anchor="ctr"/>
           <a:lstStyle/>
           <a:p>
-            <a:pPr algn="ctr" indent="0" marL="0">
+            <a:pPr marL="0" indent="0" algn="ctr">
               <a:buNone/>
             </a:pPr>
             <a:r>
@@ -4826,7 +4813,7 @@
           <a:bodyPr wrap="square" lIns="0" tIns="0" rIns="0" bIns="0" rtlCol="0" anchor="ctr"/>
           <a:lstStyle/>
           <a:p>
-            <a:pPr algn="ctr" indent="0" marL="0">
+            <a:pPr marL="0" indent="0" algn="ctr">
               <a:buNone/>
             </a:pPr>
             <a:r>
@@ -4852,7 +4839,7 @@
         </p:nvSpPr>
         <p:spPr>
           <a:xfrm>
-            <a:off x="548640" y="2377440"/>
+            <a:off x="548640" y="2522765"/>
             <a:ext cx="4572000" cy="320040"/>
           </a:xfrm>
           <a:prstGeom prst="rect">
@@ -4865,7 +4852,7 @@
           <a:bodyPr wrap="square" lIns="0" tIns="0" rIns="0" bIns="0" rtlCol="0" anchor="ctr"/>
           <a:lstStyle/>
           <a:p>
-            <a:pPr indent="0" marL="0">
+            <a:pPr marL="0" indent="0">
               <a:buNone/>
             </a:pPr>
             <a:r>
@@ -4883,629 +4870,734 @@
           </a:p>
         </p:txBody>
       </p:sp>
-      <p:sp>
-        <p:nvSpPr>
-          <p:cNvPr id="16" name="Text 14"/>
-          <p:cNvSpPr/>
-          <p:nvPr/>
-        </p:nvSpPr>
-        <p:spPr>
-          <a:xfrm>
-            <a:off x="548640" y="2834640"/>
-            <a:ext cx="2286000" cy="256032"/>
-          </a:xfrm>
-          <a:prstGeom prst="rect">
-            <a:avLst/>
-          </a:prstGeom>
-          <a:noFill/>
-          <a:ln/>
-        </p:spPr>
-        <p:txBody>
-          <a:bodyPr wrap="square" lIns="0" tIns="0" rIns="0" bIns="0" rtlCol="0" anchor="ctr"/>
-          <a:lstStyle/>
-          <a:p>
-            <a:pPr indent="0" marL="0">
-              <a:buNone/>
-            </a:pPr>
-            <a:r>
-              <a:rPr lang="en-US" sz="1000" dirty="0">
-                <a:solidFill>
-                  <a:srgbClr val="2C3E35"/>
-                </a:solidFill>
-                <a:latin typeface="Poppins" pitchFamily="34" charset="0"/>
-                <a:ea typeface="Poppins" pitchFamily="34" charset="-122"/>
-                <a:cs typeface="Poppins" pitchFamily="34" charset="-120"/>
-              </a:rPr>
-              <a:t>Mobile money users</a:t>
-            </a:r>
-            <a:endParaRPr lang="en-US" sz="1000" dirty="0"/>
-          </a:p>
-        </p:txBody>
-      </p:sp>
-      <p:sp>
-        <p:nvSpPr>
-          <p:cNvPr id="17" name="Text 15"/>
-          <p:cNvSpPr/>
-          <p:nvPr/>
-        </p:nvSpPr>
-        <p:spPr>
-          <a:xfrm>
-            <a:off x="8229600" y="2834640"/>
-            <a:ext cx="502920" cy="256032"/>
-          </a:xfrm>
-          <a:prstGeom prst="rect">
-            <a:avLst/>
-          </a:prstGeom>
-          <a:noFill/>
-          <a:ln/>
-        </p:spPr>
-        <p:txBody>
-          <a:bodyPr wrap="square" lIns="0" tIns="0" rIns="0" bIns="0" rtlCol="0" anchor="ctr"/>
-          <a:lstStyle/>
-          <a:p>
-            <a:pPr algn="r" indent="0" marL="0">
-              <a:buNone/>
-            </a:pPr>
-            <a:r>
-              <a:rPr lang="en-US" sz="1000" b="1" dirty="0">
-                <a:solidFill>
-                  <a:srgbClr val="2A7F6F"/>
-                </a:solidFill>
-                <a:latin typeface="Poppins" pitchFamily="34" charset="0"/>
-                <a:ea typeface="Poppins" pitchFamily="34" charset="-122"/>
-                <a:cs typeface="Poppins" pitchFamily="34" charset="-120"/>
-              </a:rPr>
-              <a:t>95%</a:t>
-            </a:r>
-            <a:endParaRPr lang="en-US" sz="1000" dirty="0"/>
-          </a:p>
-        </p:txBody>
-      </p:sp>
-      <p:sp>
-        <p:nvSpPr>
-          <p:cNvPr id="18" name="Shape 16"/>
-          <p:cNvSpPr/>
-          <p:nvPr/>
-        </p:nvSpPr>
-        <p:spPr>
-          <a:xfrm>
-            <a:off x="2926080" y="2880360"/>
-            <a:ext cx="5349240" cy="128016"/>
-          </a:xfrm>
-          <a:prstGeom prst="rect">
-            <a:avLst/>
-          </a:prstGeom>
-          <a:solidFill>
-            <a:srgbClr val="EDF2F0"/>
-          </a:solidFill>
-          <a:ln w="12700">
+      <p:grpSp>
+        <p:nvGrpSpPr>
+          <p:cNvPr id="36" name="Group 35">
+            <a:extLst>
+              <a:ext uri="{FF2B5EF4-FFF2-40B4-BE49-F238E27FC236}">
+                <a16:creationId xmlns:a16="http://schemas.microsoft.com/office/drawing/2014/main" id="{910519FF-A8C6-9DA0-F68E-BDFF4A18C4D3}"/>
+              </a:ext>
+            </a:extLst>
+          </p:cNvPr>
+          <p:cNvGrpSpPr/>
+          <p:nvPr/>
+        </p:nvGrpSpPr>
+        <p:grpSpPr>
+          <a:xfrm>
+            <a:off x="548639" y="2983230"/>
+            <a:ext cx="4807131" cy="1536192"/>
+            <a:chOff x="548640" y="2834640"/>
+            <a:chExt cx="8183880" cy="1792224"/>
+          </a:xfrm>
+        </p:grpSpPr>
+        <p:sp>
+          <p:nvSpPr>
+            <p:cNvPr id="16" name="Text 14"/>
+            <p:cNvSpPr/>
+            <p:nvPr/>
+          </p:nvSpPr>
+          <p:spPr>
+            <a:xfrm>
+              <a:off x="548640" y="2834640"/>
+              <a:ext cx="2286000" cy="256032"/>
+            </a:xfrm>
+            <a:prstGeom prst="rect">
+              <a:avLst/>
+            </a:prstGeom>
+            <a:noFill/>
+            <a:ln/>
+          </p:spPr>
+          <p:txBody>
+            <a:bodyPr wrap="square" lIns="0" tIns="0" rIns="0" bIns="0" rtlCol="0" anchor="ctr"/>
+            <a:lstStyle/>
+            <a:p>
+              <a:pPr marL="0" indent="0">
+                <a:buNone/>
+              </a:pPr>
+              <a:r>
+                <a:rPr lang="en-US" sz="1000" dirty="0">
+                  <a:solidFill>
+                    <a:srgbClr val="2C3E35"/>
+                  </a:solidFill>
+                  <a:latin typeface="Poppins" pitchFamily="34" charset="0"/>
+                  <a:ea typeface="Poppins" pitchFamily="34" charset="-122"/>
+                  <a:cs typeface="Poppins" pitchFamily="34" charset="-120"/>
+                </a:rPr>
+                <a:t>Mobile money users</a:t>
+              </a:r>
+              <a:endParaRPr lang="en-US" sz="1000" dirty="0"/>
+            </a:p>
+          </p:txBody>
+        </p:sp>
+        <p:sp>
+          <p:nvSpPr>
+            <p:cNvPr id="17" name="Text 15"/>
+            <p:cNvSpPr/>
+            <p:nvPr/>
+          </p:nvSpPr>
+          <p:spPr>
+            <a:xfrm>
+              <a:off x="8229600" y="2834640"/>
+              <a:ext cx="502920" cy="256032"/>
+            </a:xfrm>
+            <a:prstGeom prst="rect">
+              <a:avLst/>
+            </a:prstGeom>
+            <a:noFill/>
+            <a:ln/>
+          </p:spPr>
+          <p:txBody>
+            <a:bodyPr wrap="square" lIns="0" tIns="0" rIns="0" bIns="0" rtlCol="0" anchor="ctr"/>
+            <a:lstStyle/>
+            <a:p>
+              <a:pPr marL="0" indent="0" algn="r">
+                <a:buNone/>
+              </a:pPr>
+              <a:r>
+                <a:rPr lang="en-US" sz="1000" b="1" dirty="0">
+                  <a:solidFill>
+                    <a:srgbClr val="2A7F6F"/>
+                  </a:solidFill>
+                  <a:latin typeface="Poppins" pitchFamily="34" charset="0"/>
+                  <a:ea typeface="Poppins" pitchFamily="34" charset="-122"/>
+                  <a:cs typeface="Poppins" pitchFamily="34" charset="-120"/>
+                </a:rPr>
+                <a:t>95%</a:t>
+              </a:r>
+              <a:endParaRPr lang="en-US" sz="1000" dirty="0"/>
+            </a:p>
+          </p:txBody>
+        </p:sp>
+        <p:sp>
+          <p:nvSpPr>
+            <p:cNvPr id="18" name="Shape 16"/>
+            <p:cNvSpPr/>
+            <p:nvPr/>
+          </p:nvSpPr>
+          <p:spPr>
+            <a:xfrm>
+              <a:off x="2926080" y="2880360"/>
+              <a:ext cx="5349240" cy="128016"/>
+            </a:xfrm>
+            <a:prstGeom prst="rect">
+              <a:avLst/>
+            </a:prstGeom>
             <a:solidFill>
               <a:srgbClr val="EDF2F0"/>
             </a:solidFill>
-            <a:prstDash val="solid"/>
-          </a:ln>
-        </p:spPr>
-      </p:sp>
-      <p:sp>
-        <p:nvSpPr>
-          <p:cNvPr id="19" name="Shape 17"/>
-          <p:cNvSpPr/>
-          <p:nvPr/>
-        </p:nvSpPr>
-        <p:spPr>
-          <a:xfrm>
-            <a:off x="2926080" y="2880360"/>
-            <a:ext cx="5081778" cy="128016"/>
-          </a:xfrm>
-          <a:prstGeom prst="rect">
-            <a:avLst/>
-          </a:prstGeom>
-          <a:solidFill>
-            <a:srgbClr val="2A7F6F"/>
-          </a:solidFill>
-          <a:ln w="12700">
+            <a:ln w="12700">
+              <a:solidFill>
+                <a:srgbClr val="EDF2F0"/>
+              </a:solidFill>
+              <a:prstDash val="solid"/>
+            </a:ln>
+          </p:spPr>
+          <p:txBody>
+            <a:bodyPr/>
+            <a:lstStyle/>
+            <a:p>
+              <a:endParaRPr lang="en-US"/>
+            </a:p>
+          </p:txBody>
+        </p:sp>
+        <p:sp>
+          <p:nvSpPr>
+            <p:cNvPr id="19" name="Shape 17"/>
+            <p:cNvSpPr/>
+            <p:nvPr/>
+          </p:nvSpPr>
+          <p:spPr>
+            <a:xfrm>
+              <a:off x="2926080" y="2880360"/>
+              <a:ext cx="5081778" cy="128016"/>
+            </a:xfrm>
+            <a:prstGeom prst="rect">
+              <a:avLst/>
+            </a:prstGeom>
             <a:solidFill>
               <a:srgbClr val="2A7F6F"/>
             </a:solidFill>
-            <a:prstDash val="solid"/>
-          </a:ln>
-        </p:spPr>
-      </p:sp>
-      <p:sp>
-        <p:nvSpPr>
-          <p:cNvPr id="20" name="Text 18"/>
-          <p:cNvSpPr/>
-          <p:nvPr/>
-        </p:nvSpPr>
-        <p:spPr>
-          <a:xfrm>
-            <a:off x="548640" y="3346704"/>
-            <a:ext cx="2286000" cy="256032"/>
-          </a:xfrm>
-          <a:prstGeom prst="rect">
-            <a:avLst/>
-          </a:prstGeom>
-          <a:noFill/>
-          <a:ln/>
-        </p:spPr>
-        <p:txBody>
-          <a:bodyPr wrap="square" lIns="0" tIns="0" rIns="0" bIns="0" rtlCol="0" anchor="ctr"/>
-          <a:lstStyle/>
-          <a:p>
-            <a:pPr indent="0" marL="0">
-              <a:buNone/>
-            </a:pPr>
-            <a:r>
-              <a:rPr lang="en-US" sz="1000" dirty="0">
-                <a:solidFill>
-                  <a:srgbClr val="2C3E35"/>
-                </a:solidFill>
-                <a:latin typeface="Poppins" pitchFamily="34" charset="0"/>
-                <a:ea typeface="Poppins" pitchFamily="34" charset="-122"/>
-                <a:cs typeface="Poppins" pitchFamily="34" charset="-120"/>
-              </a:rPr>
-              <a:t>Mobile coverage</a:t>
-            </a:r>
-            <a:endParaRPr lang="en-US" sz="1000" dirty="0"/>
-          </a:p>
-        </p:txBody>
-      </p:sp>
-      <p:sp>
-        <p:nvSpPr>
-          <p:cNvPr id="21" name="Text 19"/>
-          <p:cNvSpPr/>
-          <p:nvPr/>
-        </p:nvSpPr>
-        <p:spPr>
-          <a:xfrm>
-            <a:off x="8229600" y="3346704"/>
-            <a:ext cx="502920" cy="256032"/>
-          </a:xfrm>
-          <a:prstGeom prst="rect">
-            <a:avLst/>
-          </a:prstGeom>
-          <a:noFill/>
-          <a:ln/>
-        </p:spPr>
-        <p:txBody>
-          <a:bodyPr wrap="square" lIns="0" tIns="0" rIns="0" bIns="0" rtlCol="0" anchor="ctr"/>
-          <a:lstStyle/>
-          <a:p>
-            <a:pPr algn="r" indent="0" marL="0">
-              <a:buNone/>
-            </a:pPr>
-            <a:r>
-              <a:rPr lang="en-US" sz="1000" b="1" dirty="0">
-                <a:solidFill>
-                  <a:srgbClr val="2A7F6F"/>
-                </a:solidFill>
-                <a:latin typeface="Poppins" pitchFamily="34" charset="0"/>
-                <a:ea typeface="Poppins" pitchFamily="34" charset="-122"/>
-                <a:cs typeface="Poppins" pitchFamily="34" charset="-120"/>
-              </a:rPr>
-              <a:t>92%</a:t>
-            </a:r>
-            <a:endParaRPr lang="en-US" sz="1000" dirty="0"/>
-          </a:p>
-        </p:txBody>
-      </p:sp>
-      <p:sp>
-        <p:nvSpPr>
-          <p:cNvPr id="22" name="Shape 20"/>
-          <p:cNvSpPr/>
-          <p:nvPr/>
-        </p:nvSpPr>
-        <p:spPr>
-          <a:xfrm>
-            <a:off x="2926080" y="3392424"/>
-            <a:ext cx="5349240" cy="128016"/>
-          </a:xfrm>
-          <a:prstGeom prst="rect">
-            <a:avLst/>
-          </a:prstGeom>
-          <a:solidFill>
-            <a:srgbClr val="EDF2F0"/>
-          </a:solidFill>
-          <a:ln w="12700">
+            <a:ln w="12700">
+              <a:solidFill>
+                <a:srgbClr val="2A7F6F"/>
+              </a:solidFill>
+              <a:prstDash val="solid"/>
+            </a:ln>
+          </p:spPr>
+          <p:txBody>
+            <a:bodyPr/>
+            <a:lstStyle/>
+            <a:p>
+              <a:endParaRPr lang="en-US"/>
+            </a:p>
+          </p:txBody>
+        </p:sp>
+        <p:sp>
+          <p:nvSpPr>
+            <p:cNvPr id="20" name="Text 18"/>
+            <p:cNvSpPr/>
+            <p:nvPr/>
+          </p:nvSpPr>
+          <p:spPr>
+            <a:xfrm>
+              <a:off x="548640" y="3346704"/>
+              <a:ext cx="2286000" cy="256032"/>
+            </a:xfrm>
+            <a:prstGeom prst="rect">
+              <a:avLst/>
+            </a:prstGeom>
+            <a:noFill/>
+            <a:ln/>
+          </p:spPr>
+          <p:txBody>
+            <a:bodyPr wrap="square" lIns="0" tIns="0" rIns="0" bIns="0" rtlCol="0" anchor="ctr"/>
+            <a:lstStyle/>
+            <a:p>
+              <a:pPr marL="0" indent="0">
+                <a:buNone/>
+              </a:pPr>
+              <a:r>
+                <a:rPr lang="en-US" sz="1000" dirty="0">
+                  <a:solidFill>
+                    <a:srgbClr val="2C3E35"/>
+                  </a:solidFill>
+                  <a:latin typeface="Poppins" pitchFamily="34" charset="0"/>
+                  <a:ea typeface="Poppins" pitchFamily="34" charset="-122"/>
+                  <a:cs typeface="Poppins" pitchFamily="34" charset="-120"/>
+                </a:rPr>
+                <a:t>Mobile coverage</a:t>
+              </a:r>
+              <a:endParaRPr lang="en-US" sz="1000" dirty="0"/>
+            </a:p>
+          </p:txBody>
+        </p:sp>
+        <p:sp>
+          <p:nvSpPr>
+            <p:cNvPr id="21" name="Text 19"/>
+            <p:cNvSpPr/>
+            <p:nvPr/>
+          </p:nvSpPr>
+          <p:spPr>
+            <a:xfrm>
+              <a:off x="8229600" y="3346704"/>
+              <a:ext cx="502920" cy="256032"/>
+            </a:xfrm>
+            <a:prstGeom prst="rect">
+              <a:avLst/>
+            </a:prstGeom>
+            <a:noFill/>
+            <a:ln/>
+          </p:spPr>
+          <p:txBody>
+            <a:bodyPr wrap="square" lIns="0" tIns="0" rIns="0" bIns="0" rtlCol="0" anchor="ctr"/>
+            <a:lstStyle/>
+            <a:p>
+              <a:pPr marL="0" indent="0" algn="r">
+                <a:buNone/>
+              </a:pPr>
+              <a:r>
+                <a:rPr lang="en-US" sz="1000" b="1" dirty="0">
+                  <a:solidFill>
+                    <a:srgbClr val="2A7F6F"/>
+                  </a:solidFill>
+                  <a:latin typeface="Poppins" pitchFamily="34" charset="0"/>
+                  <a:ea typeface="Poppins" pitchFamily="34" charset="-122"/>
+                  <a:cs typeface="Poppins" pitchFamily="34" charset="-120"/>
+                </a:rPr>
+                <a:t>92%</a:t>
+              </a:r>
+              <a:endParaRPr lang="en-US" sz="1000" dirty="0"/>
+            </a:p>
+          </p:txBody>
+        </p:sp>
+        <p:sp>
+          <p:nvSpPr>
+            <p:cNvPr id="22" name="Shape 20"/>
+            <p:cNvSpPr/>
+            <p:nvPr/>
+          </p:nvSpPr>
+          <p:spPr>
+            <a:xfrm>
+              <a:off x="2926080" y="3392424"/>
+              <a:ext cx="5349240" cy="128016"/>
+            </a:xfrm>
+            <a:prstGeom prst="rect">
+              <a:avLst/>
+            </a:prstGeom>
             <a:solidFill>
               <a:srgbClr val="EDF2F0"/>
             </a:solidFill>
-            <a:prstDash val="solid"/>
-          </a:ln>
-        </p:spPr>
-      </p:sp>
-      <p:sp>
-        <p:nvSpPr>
-          <p:cNvPr id="23" name="Shape 21"/>
-          <p:cNvSpPr/>
-          <p:nvPr/>
-        </p:nvSpPr>
-        <p:spPr>
-          <a:xfrm>
-            <a:off x="2926080" y="3392424"/>
-            <a:ext cx="4921301" cy="128016"/>
-          </a:xfrm>
-          <a:prstGeom prst="rect">
-            <a:avLst/>
-          </a:prstGeom>
-          <a:solidFill>
-            <a:srgbClr val="2A7F6F"/>
-          </a:solidFill>
-          <a:ln w="12700">
+            <a:ln w="12700">
+              <a:solidFill>
+                <a:srgbClr val="EDF2F0"/>
+              </a:solidFill>
+              <a:prstDash val="solid"/>
+            </a:ln>
+          </p:spPr>
+          <p:txBody>
+            <a:bodyPr/>
+            <a:lstStyle/>
+            <a:p>
+              <a:endParaRPr lang="en-US"/>
+            </a:p>
+          </p:txBody>
+        </p:sp>
+        <p:sp>
+          <p:nvSpPr>
+            <p:cNvPr id="23" name="Shape 21"/>
+            <p:cNvSpPr/>
+            <p:nvPr/>
+          </p:nvSpPr>
+          <p:spPr>
+            <a:xfrm>
+              <a:off x="2926080" y="3392424"/>
+              <a:ext cx="4921301" cy="128016"/>
+            </a:xfrm>
+            <a:prstGeom prst="rect">
+              <a:avLst/>
+            </a:prstGeom>
             <a:solidFill>
               <a:srgbClr val="2A7F6F"/>
             </a:solidFill>
-            <a:prstDash val="solid"/>
-          </a:ln>
-        </p:spPr>
-      </p:sp>
-      <p:sp>
-        <p:nvSpPr>
-          <p:cNvPr id="24" name="Text 22"/>
-          <p:cNvSpPr/>
-          <p:nvPr/>
-        </p:nvSpPr>
-        <p:spPr>
-          <a:xfrm>
-            <a:off x="548640" y="3858768"/>
-            <a:ext cx="2286000" cy="256032"/>
-          </a:xfrm>
-          <a:prstGeom prst="rect">
-            <a:avLst/>
-          </a:prstGeom>
-          <a:noFill/>
-          <a:ln/>
-        </p:spPr>
-        <p:txBody>
-          <a:bodyPr wrap="square" lIns="0" tIns="0" rIns="0" bIns="0" rtlCol="0" anchor="ctr"/>
-          <a:lstStyle/>
-          <a:p>
-            <a:pPr indent="0" marL="0">
-              <a:buNone/>
-            </a:pPr>
-            <a:r>
-              <a:rPr lang="en-US" sz="1000" dirty="0">
-                <a:solidFill>
-                  <a:srgbClr val="2C3E35"/>
-                </a:solidFill>
-                <a:latin typeface="Poppins" pitchFamily="34" charset="0"/>
-                <a:ea typeface="Poppins" pitchFamily="34" charset="-122"/>
-                <a:cs typeface="Poppins" pitchFamily="34" charset="-120"/>
-              </a:rPr>
-              <a:t>Internet users</a:t>
-            </a:r>
-            <a:endParaRPr lang="en-US" sz="1000" dirty="0"/>
-          </a:p>
-        </p:txBody>
-      </p:sp>
-      <p:sp>
-        <p:nvSpPr>
-          <p:cNvPr id="25" name="Text 23"/>
-          <p:cNvSpPr/>
-          <p:nvPr/>
-        </p:nvSpPr>
-        <p:spPr>
-          <a:xfrm>
-            <a:off x="8229600" y="3858768"/>
-            <a:ext cx="502920" cy="256032"/>
-          </a:xfrm>
-          <a:prstGeom prst="rect">
-            <a:avLst/>
-          </a:prstGeom>
-          <a:noFill/>
-          <a:ln/>
-        </p:spPr>
-        <p:txBody>
-          <a:bodyPr wrap="square" lIns="0" tIns="0" rIns="0" bIns="0" rtlCol="0" anchor="ctr"/>
-          <a:lstStyle/>
-          <a:p>
-            <a:pPr algn="r" indent="0" marL="0">
-              <a:buNone/>
-            </a:pPr>
-            <a:r>
-              <a:rPr lang="en-US" sz="1000" b="1" dirty="0">
-                <a:solidFill>
-                  <a:srgbClr val="2A7F6F"/>
-                </a:solidFill>
-                <a:latin typeface="Poppins" pitchFamily="34" charset="0"/>
-                <a:ea typeface="Poppins" pitchFamily="34" charset="-122"/>
-                <a:cs typeface="Poppins" pitchFamily="34" charset="-120"/>
-              </a:rPr>
-              <a:t>33%</a:t>
-            </a:r>
-            <a:endParaRPr lang="en-US" sz="1000" dirty="0"/>
-          </a:p>
-        </p:txBody>
-      </p:sp>
-      <p:sp>
-        <p:nvSpPr>
-          <p:cNvPr id="26" name="Shape 24"/>
-          <p:cNvSpPr/>
-          <p:nvPr/>
-        </p:nvSpPr>
-        <p:spPr>
-          <a:xfrm>
-            <a:off x="2926080" y="3904488"/>
-            <a:ext cx="5349240" cy="128016"/>
-          </a:xfrm>
-          <a:prstGeom prst="rect">
-            <a:avLst/>
-          </a:prstGeom>
-          <a:solidFill>
-            <a:srgbClr val="EDF2F0"/>
-          </a:solidFill>
-          <a:ln w="12700">
+            <a:ln w="12700">
+              <a:solidFill>
+                <a:srgbClr val="2A7F6F"/>
+              </a:solidFill>
+              <a:prstDash val="solid"/>
+            </a:ln>
+          </p:spPr>
+          <p:txBody>
+            <a:bodyPr/>
+            <a:lstStyle/>
+            <a:p>
+              <a:endParaRPr lang="en-US"/>
+            </a:p>
+          </p:txBody>
+        </p:sp>
+        <p:sp>
+          <p:nvSpPr>
+            <p:cNvPr id="24" name="Text 22"/>
+            <p:cNvSpPr/>
+            <p:nvPr/>
+          </p:nvSpPr>
+          <p:spPr>
+            <a:xfrm>
+              <a:off x="548640" y="3858768"/>
+              <a:ext cx="2286000" cy="256032"/>
+            </a:xfrm>
+            <a:prstGeom prst="rect">
+              <a:avLst/>
+            </a:prstGeom>
+            <a:noFill/>
+            <a:ln/>
+          </p:spPr>
+          <p:txBody>
+            <a:bodyPr wrap="square" lIns="0" tIns="0" rIns="0" bIns="0" rtlCol="0" anchor="ctr"/>
+            <a:lstStyle/>
+            <a:p>
+              <a:pPr marL="0" indent="0">
+                <a:buNone/>
+              </a:pPr>
+              <a:r>
+                <a:rPr lang="en-US" sz="1000" dirty="0">
+                  <a:solidFill>
+                    <a:srgbClr val="2C3E35"/>
+                  </a:solidFill>
+                  <a:latin typeface="Poppins" pitchFamily="34" charset="0"/>
+                  <a:ea typeface="Poppins" pitchFamily="34" charset="-122"/>
+                  <a:cs typeface="Poppins" pitchFamily="34" charset="-120"/>
+                </a:rPr>
+                <a:t>Internet users</a:t>
+              </a:r>
+              <a:endParaRPr lang="en-US" sz="1000" dirty="0"/>
+            </a:p>
+          </p:txBody>
+        </p:sp>
+        <p:sp>
+          <p:nvSpPr>
+            <p:cNvPr id="25" name="Text 23"/>
+            <p:cNvSpPr/>
+            <p:nvPr/>
+          </p:nvSpPr>
+          <p:spPr>
+            <a:xfrm>
+              <a:off x="8229600" y="3858768"/>
+              <a:ext cx="502920" cy="256032"/>
+            </a:xfrm>
+            <a:prstGeom prst="rect">
+              <a:avLst/>
+            </a:prstGeom>
+            <a:noFill/>
+            <a:ln/>
+          </p:spPr>
+          <p:txBody>
+            <a:bodyPr wrap="square" lIns="0" tIns="0" rIns="0" bIns="0" rtlCol="0" anchor="ctr"/>
+            <a:lstStyle/>
+            <a:p>
+              <a:pPr marL="0" indent="0" algn="r">
+                <a:buNone/>
+              </a:pPr>
+              <a:r>
+                <a:rPr lang="en-US" sz="1000" b="1" dirty="0">
+                  <a:solidFill>
+                    <a:srgbClr val="2A7F6F"/>
+                  </a:solidFill>
+                  <a:latin typeface="Poppins" pitchFamily="34" charset="0"/>
+                  <a:ea typeface="Poppins" pitchFamily="34" charset="-122"/>
+                  <a:cs typeface="Poppins" pitchFamily="34" charset="-120"/>
+                </a:rPr>
+                <a:t>33%</a:t>
+              </a:r>
+              <a:endParaRPr lang="en-US" sz="1000" dirty="0"/>
+            </a:p>
+          </p:txBody>
+        </p:sp>
+        <p:sp>
+          <p:nvSpPr>
+            <p:cNvPr id="26" name="Shape 24"/>
+            <p:cNvSpPr/>
+            <p:nvPr/>
+          </p:nvSpPr>
+          <p:spPr>
+            <a:xfrm>
+              <a:off x="2926080" y="3904488"/>
+              <a:ext cx="5349240" cy="128016"/>
+            </a:xfrm>
+            <a:prstGeom prst="rect">
+              <a:avLst/>
+            </a:prstGeom>
             <a:solidFill>
               <a:srgbClr val="EDF2F0"/>
             </a:solidFill>
-            <a:prstDash val="solid"/>
-          </a:ln>
-        </p:spPr>
-      </p:sp>
-      <p:sp>
-        <p:nvSpPr>
-          <p:cNvPr id="27" name="Shape 25"/>
-          <p:cNvSpPr/>
-          <p:nvPr/>
-        </p:nvSpPr>
-        <p:spPr>
-          <a:xfrm>
-            <a:off x="2926080" y="3904488"/>
-            <a:ext cx="1765249" cy="128016"/>
-          </a:xfrm>
-          <a:prstGeom prst="rect">
-            <a:avLst/>
-          </a:prstGeom>
-          <a:solidFill>
-            <a:srgbClr val="2A7F6F">
-              <a:alpha val="60000"/>
-            </a:srgbClr>
-          </a:solidFill>
-          <a:ln w="12700">
+            <a:ln w="12700">
+              <a:solidFill>
+                <a:srgbClr val="EDF2F0"/>
+              </a:solidFill>
+              <a:prstDash val="solid"/>
+            </a:ln>
+          </p:spPr>
+          <p:txBody>
+            <a:bodyPr/>
+            <a:lstStyle/>
+            <a:p>
+              <a:endParaRPr lang="en-US"/>
+            </a:p>
+          </p:txBody>
+        </p:sp>
+        <p:sp>
+          <p:nvSpPr>
+            <p:cNvPr id="27" name="Shape 25"/>
+            <p:cNvSpPr/>
+            <p:nvPr/>
+          </p:nvSpPr>
+          <p:spPr>
+            <a:xfrm>
+              <a:off x="2926080" y="3904488"/>
+              <a:ext cx="1765249" cy="128016"/>
+            </a:xfrm>
+            <a:prstGeom prst="rect">
+              <a:avLst/>
+            </a:prstGeom>
             <a:solidFill>
               <a:srgbClr val="2A7F6F">
                 <a:alpha val="60000"/>
               </a:srgbClr>
             </a:solidFill>
-            <a:prstDash val="solid"/>
-          </a:ln>
-        </p:spPr>
-      </p:sp>
-      <p:sp>
-        <p:nvSpPr>
-          <p:cNvPr id="28" name="Text 26"/>
-          <p:cNvSpPr/>
-          <p:nvPr/>
-        </p:nvSpPr>
-        <p:spPr>
-          <a:xfrm>
-            <a:off x="548640" y="4370832"/>
-            <a:ext cx="2286000" cy="256032"/>
-          </a:xfrm>
-          <a:prstGeom prst="rect">
-            <a:avLst/>
-          </a:prstGeom>
-          <a:noFill/>
-          <a:ln/>
-        </p:spPr>
-        <p:txBody>
-          <a:bodyPr wrap="square" lIns="0" tIns="0" rIns="0" bIns="0" rtlCol="0" anchor="ctr"/>
-          <a:lstStyle/>
-          <a:p>
-            <a:pPr indent="0" marL="0">
-              <a:buNone/>
-            </a:pPr>
-            <a:r>
-              <a:rPr lang="en-US" sz="1000" dirty="0">
-                <a:solidFill>
-                  <a:srgbClr val="2C3E35"/>
-                </a:solidFill>
-                <a:latin typeface="Poppins" pitchFamily="34" charset="0"/>
-                <a:ea typeface="Poppins" pitchFamily="34" charset="-122"/>
-                <a:cs typeface="Poppins" pitchFamily="34" charset="-120"/>
-              </a:rPr>
-              <a:t>Bank account holders</a:t>
-            </a:r>
-            <a:endParaRPr lang="en-US" sz="1000" dirty="0"/>
-          </a:p>
-        </p:txBody>
-      </p:sp>
-      <p:sp>
-        <p:nvSpPr>
-          <p:cNvPr id="29" name="Text 27"/>
-          <p:cNvSpPr/>
-          <p:nvPr/>
-        </p:nvSpPr>
-        <p:spPr>
-          <a:xfrm>
-            <a:off x="8229600" y="4370832"/>
-            <a:ext cx="502920" cy="256032"/>
-          </a:xfrm>
-          <a:prstGeom prst="rect">
-            <a:avLst/>
-          </a:prstGeom>
-          <a:noFill/>
-          <a:ln/>
-        </p:spPr>
-        <p:txBody>
-          <a:bodyPr wrap="square" lIns="0" tIns="0" rIns="0" bIns="0" rtlCol="0" anchor="ctr"/>
-          <a:lstStyle/>
-          <a:p>
-            <a:pPr algn="r" indent="0" marL="0">
-              <a:buNone/>
-            </a:pPr>
-            <a:r>
-              <a:rPr lang="en-US" sz="1000" b="1" dirty="0">
-                <a:solidFill>
-                  <a:srgbClr val="2A7F6F"/>
-                </a:solidFill>
-                <a:latin typeface="Poppins" pitchFamily="34" charset="0"/>
-                <a:ea typeface="Poppins" pitchFamily="34" charset="-122"/>
-                <a:cs typeface="Poppins" pitchFamily="34" charset="-120"/>
-              </a:rPr>
-              <a:t>23%</a:t>
-            </a:r>
-            <a:endParaRPr lang="en-US" sz="1000" dirty="0"/>
-          </a:p>
-        </p:txBody>
-      </p:sp>
-      <p:sp>
-        <p:nvSpPr>
-          <p:cNvPr id="30" name="Shape 28"/>
-          <p:cNvSpPr/>
-          <p:nvPr/>
-        </p:nvSpPr>
-        <p:spPr>
-          <a:xfrm>
-            <a:off x="2926080" y="4416552"/>
-            <a:ext cx="5349240" cy="128016"/>
-          </a:xfrm>
-          <a:prstGeom prst="rect">
-            <a:avLst/>
-          </a:prstGeom>
-          <a:solidFill>
-            <a:srgbClr val="EDF2F0"/>
-          </a:solidFill>
-          <a:ln w="12700">
+            <a:ln w="12700">
+              <a:solidFill>
+                <a:srgbClr val="2A7F6F">
+                  <a:alpha val="60000"/>
+                </a:srgbClr>
+              </a:solidFill>
+              <a:prstDash val="solid"/>
+            </a:ln>
+          </p:spPr>
+          <p:txBody>
+            <a:bodyPr/>
+            <a:lstStyle/>
+            <a:p>
+              <a:endParaRPr lang="en-US"/>
+            </a:p>
+          </p:txBody>
+        </p:sp>
+        <p:sp>
+          <p:nvSpPr>
+            <p:cNvPr id="28" name="Text 26"/>
+            <p:cNvSpPr/>
+            <p:nvPr/>
+          </p:nvSpPr>
+          <p:spPr>
+            <a:xfrm>
+              <a:off x="548640" y="4370832"/>
+              <a:ext cx="2286000" cy="256032"/>
+            </a:xfrm>
+            <a:prstGeom prst="rect">
+              <a:avLst/>
+            </a:prstGeom>
+            <a:noFill/>
+            <a:ln/>
+          </p:spPr>
+          <p:txBody>
+            <a:bodyPr wrap="square" lIns="0" tIns="0" rIns="0" bIns="0" rtlCol="0" anchor="ctr"/>
+            <a:lstStyle/>
+            <a:p>
+              <a:pPr marL="0" indent="0">
+                <a:buNone/>
+              </a:pPr>
+              <a:r>
+                <a:rPr lang="en-US" sz="1000" dirty="0">
+                  <a:solidFill>
+                    <a:srgbClr val="2C3E35"/>
+                  </a:solidFill>
+                  <a:latin typeface="Poppins" pitchFamily="34" charset="0"/>
+                  <a:ea typeface="Poppins" pitchFamily="34" charset="-122"/>
+                  <a:cs typeface="Poppins" pitchFamily="34" charset="-120"/>
+                </a:rPr>
+                <a:t>Bank account holders</a:t>
+              </a:r>
+              <a:endParaRPr lang="en-US" sz="1000" dirty="0"/>
+            </a:p>
+          </p:txBody>
+        </p:sp>
+        <p:sp>
+          <p:nvSpPr>
+            <p:cNvPr id="29" name="Text 27"/>
+            <p:cNvSpPr/>
+            <p:nvPr/>
+          </p:nvSpPr>
+          <p:spPr>
+            <a:xfrm>
+              <a:off x="8229600" y="4370832"/>
+              <a:ext cx="502920" cy="256032"/>
+            </a:xfrm>
+            <a:prstGeom prst="rect">
+              <a:avLst/>
+            </a:prstGeom>
+            <a:noFill/>
+            <a:ln/>
+          </p:spPr>
+          <p:txBody>
+            <a:bodyPr wrap="square" lIns="0" tIns="0" rIns="0" bIns="0" rtlCol="0" anchor="ctr"/>
+            <a:lstStyle/>
+            <a:p>
+              <a:pPr marL="0" indent="0" algn="r">
+                <a:buNone/>
+              </a:pPr>
+              <a:r>
+                <a:rPr lang="en-US" sz="1000" b="1" dirty="0">
+                  <a:solidFill>
+                    <a:srgbClr val="2A7F6F"/>
+                  </a:solidFill>
+                  <a:latin typeface="Poppins" pitchFamily="34" charset="0"/>
+                  <a:ea typeface="Poppins" pitchFamily="34" charset="-122"/>
+                  <a:cs typeface="Poppins" pitchFamily="34" charset="-120"/>
+                </a:rPr>
+                <a:t>23%</a:t>
+              </a:r>
+              <a:endParaRPr lang="en-US" sz="1000" dirty="0"/>
+            </a:p>
+          </p:txBody>
+        </p:sp>
+        <p:sp>
+          <p:nvSpPr>
+            <p:cNvPr id="30" name="Shape 28"/>
+            <p:cNvSpPr/>
+            <p:nvPr/>
+          </p:nvSpPr>
+          <p:spPr>
+            <a:xfrm>
+              <a:off x="2926080" y="4416552"/>
+              <a:ext cx="5349240" cy="128016"/>
+            </a:xfrm>
+            <a:prstGeom prst="rect">
+              <a:avLst/>
+            </a:prstGeom>
             <a:solidFill>
               <a:srgbClr val="EDF2F0"/>
             </a:solidFill>
-            <a:prstDash val="solid"/>
-          </a:ln>
-        </p:spPr>
-      </p:sp>
-      <p:sp>
-        <p:nvSpPr>
-          <p:cNvPr id="31" name="Shape 29"/>
-          <p:cNvSpPr/>
-          <p:nvPr/>
-        </p:nvSpPr>
-        <p:spPr>
-          <a:xfrm>
-            <a:off x="2926080" y="4416552"/>
-            <a:ext cx="1230325" cy="128016"/>
-          </a:xfrm>
-          <a:prstGeom prst="rect">
-            <a:avLst/>
-          </a:prstGeom>
-          <a:solidFill>
-            <a:srgbClr val="2A7F6F">
-              <a:alpha val="60000"/>
-            </a:srgbClr>
-          </a:solidFill>
-          <a:ln w="12700">
+            <a:ln w="12700">
+              <a:solidFill>
+                <a:srgbClr val="EDF2F0"/>
+              </a:solidFill>
+              <a:prstDash val="solid"/>
+            </a:ln>
+          </p:spPr>
+          <p:txBody>
+            <a:bodyPr/>
+            <a:lstStyle/>
+            <a:p>
+              <a:endParaRPr lang="en-US"/>
+            </a:p>
+          </p:txBody>
+        </p:sp>
+        <p:sp>
+          <p:nvSpPr>
+            <p:cNvPr id="31" name="Shape 29"/>
+            <p:cNvSpPr/>
+            <p:nvPr/>
+          </p:nvSpPr>
+          <p:spPr>
+            <a:xfrm>
+              <a:off x="2926080" y="4416552"/>
+              <a:ext cx="1230325" cy="128016"/>
+            </a:xfrm>
+            <a:prstGeom prst="rect">
+              <a:avLst/>
+            </a:prstGeom>
             <a:solidFill>
               <a:srgbClr val="2A7F6F">
                 <a:alpha val="60000"/>
               </a:srgbClr>
             </a:solidFill>
-            <a:prstDash val="solid"/>
-          </a:ln>
-        </p:spPr>
-      </p:sp>
-      <p:sp>
-        <p:nvSpPr>
-          <p:cNvPr id="32" name="Shape 30"/>
-          <p:cNvSpPr/>
-          <p:nvPr/>
-        </p:nvSpPr>
-        <p:spPr>
-          <a:xfrm>
-            <a:off x="5349240" y="2331720"/>
-            <a:ext cx="3429000" cy="2468880"/>
-          </a:xfrm>
-          <a:prstGeom prst="rect">
-            <a:avLst/>
-          </a:prstGeom>
-          <a:solidFill>
-            <a:srgbClr val="F7F9F8"/>
-          </a:solidFill>
-          <a:ln w="12700">
+            <a:ln w="12700">
+              <a:solidFill>
+                <a:srgbClr val="2A7F6F">
+                  <a:alpha val="60000"/>
+                </a:srgbClr>
+              </a:solidFill>
+              <a:prstDash val="solid"/>
+            </a:ln>
+          </p:spPr>
+          <p:txBody>
+            <a:bodyPr/>
+            <a:lstStyle/>
+            <a:p>
+              <a:endParaRPr lang="en-US"/>
+            </a:p>
+          </p:txBody>
+        </p:sp>
+      </p:grpSp>
+      <p:grpSp>
+        <p:nvGrpSpPr>
+          <p:cNvPr id="38" name="Group 37">
+            <a:extLst>
+              <a:ext uri="{FF2B5EF4-FFF2-40B4-BE49-F238E27FC236}">
+                <a16:creationId xmlns:a16="http://schemas.microsoft.com/office/drawing/2014/main" id="{3B31F9F5-B7A4-F119-CC56-F484F521978E}"/>
+              </a:ext>
+            </a:extLst>
+          </p:cNvPr>
+          <p:cNvGrpSpPr/>
+          <p:nvPr/>
+        </p:nvGrpSpPr>
+        <p:grpSpPr>
+          <a:xfrm>
+            <a:off x="5705203" y="2571750"/>
+            <a:ext cx="3187337" cy="1947672"/>
+            <a:chOff x="5736345" y="2651760"/>
+            <a:chExt cx="3187337" cy="1947672"/>
+          </a:xfrm>
+        </p:grpSpPr>
+        <p:sp>
+          <p:nvSpPr>
+            <p:cNvPr id="32" name="Shape 30"/>
+            <p:cNvSpPr/>
+            <p:nvPr/>
+          </p:nvSpPr>
+          <p:spPr>
+            <a:xfrm>
+              <a:off x="5736345" y="3063240"/>
+              <a:ext cx="3187337" cy="1536192"/>
+            </a:xfrm>
+            <a:prstGeom prst="rect">
+              <a:avLst/>
+            </a:prstGeom>
             <a:solidFill>
-              <a:srgbClr val="EDF2F0"/>
+              <a:srgbClr val="F7F9F8"/>
             </a:solidFill>
-            <a:prstDash val="solid"/>
-          </a:ln>
-        </p:spPr>
-      </p:sp>
-      <p:sp>
-        <p:nvSpPr>
-          <p:cNvPr id="33" name="Text 31"/>
-          <p:cNvSpPr/>
-          <p:nvPr/>
-        </p:nvSpPr>
-        <p:spPr>
-          <a:xfrm>
-            <a:off x="5532120" y="2468880"/>
-            <a:ext cx="3063240" cy="274320"/>
-          </a:xfrm>
-          <a:prstGeom prst="rect">
-            <a:avLst/>
-          </a:prstGeom>
-          <a:noFill/>
-          <a:ln/>
-        </p:spPr>
-        <p:txBody>
-          <a:bodyPr wrap="square" lIns="0" tIns="0" rIns="0" bIns="0" rtlCol="0" anchor="ctr"/>
-          <a:lstStyle/>
-          <a:p>
-            <a:pPr indent="0" marL="0">
-              <a:buNone/>
-            </a:pPr>
-            <a:r>
-              <a:rPr lang="en-US" sz="1000" b="1" dirty="0">
-                <a:solidFill>
-                  <a:srgbClr val="2A7F6F"/>
-                </a:solidFill>
-                <a:latin typeface="Poppins" pitchFamily="34" charset="0"/>
-                <a:ea typeface="Poppins" pitchFamily="34" charset="-122"/>
-                <a:cs typeface="Poppins" pitchFamily="34" charset="-120"/>
-              </a:rPr>
-              <a:t>Key insight</a:t>
-            </a:r>
-            <a:endParaRPr lang="en-US" sz="1000" dirty="0"/>
-          </a:p>
-        </p:txBody>
-      </p:sp>
-      <p:sp>
-        <p:nvSpPr>
-          <p:cNvPr id="34" name="Text 32"/>
-          <p:cNvSpPr/>
-          <p:nvPr/>
-        </p:nvSpPr>
-        <p:spPr>
-          <a:xfrm>
-            <a:off x="5532120" y="2788920"/>
-            <a:ext cx="3063240" cy="1645920"/>
-          </a:xfrm>
-          <a:prstGeom prst="rect">
-            <a:avLst/>
-          </a:prstGeom>
-          <a:noFill/>
-          <a:ln/>
-        </p:spPr>
-        <p:txBody>
-          <a:bodyPr wrap="square" lIns="0" tIns="0" rIns="0" bIns="0" rtlCol="0" anchor="ctr"/>
-          <a:lstStyle/>
-          <a:p>
-            <a:pPr indent="0" marL="0">
-              <a:buNone/>
-            </a:pPr>
-            <a:r>
-              <a:rPr lang="en-US" sz="1150" dirty="0">
-                <a:solidFill>
-                  <a:srgbClr val="2C3E35"/>
-                </a:solidFill>
-                <a:latin typeface="Poppins" pitchFamily="34" charset="0"/>
-                <a:ea typeface="Poppins" pitchFamily="34" charset="-122"/>
-                <a:cs typeface="Poppins" pitchFamily="34" charset="-120"/>
-              </a:rPr>
-              <a:t>Only 2% of Zambians use credit cards — but 95% use mobile money. The payment barrier that stopped e-commerce elsewhere doesn't exist here.</a:t>
-            </a:r>
-            <a:endParaRPr lang="en-US" sz="1150" dirty="0"/>
-          </a:p>
-        </p:txBody>
-      </p:sp>
+            <a:ln w="12700">
+              <a:solidFill>
+                <a:srgbClr val="EDF2F0"/>
+              </a:solidFill>
+              <a:prstDash val="solid"/>
+            </a:ln>
+          </p:spPr>
+          <p:txBody>
+            <a:bodyPr/>
+            <a:lstStyle/>
+            <a:p>
+              <a:endParaRPr lang="en-US"/>
+            </a:p>
+          </p:txBody>
+        </p:sp>
+        <p:sp>
+          <p:nvSpPr>
+            <p:cNvPr id="33" name="Text 31"/>
+            <p:cNvSpPr/>
+            <p:nvPr/>
+          </p:nvSpPr>
+          <p:spPr>
+            <a:xfrm>
+              <a:off x="5736345" y="2651760"/>
+              <a:ext cx="3063240" cy="274320"/>
+            </a:xfrm>
+            <a:prstGeom prst="rect">
+              <a:avLst/>
+            </a:prstGeom>
+            <a:noFill/>
+            <a:ln/>
+          </p:spPr>
+          <p:txBody>
+            <a:bodyPr wrap="square" lIns="0" tIns="0" rIns="0" bIns="0" rtlCol="0" anchor="ctr"/>
+            <a:lstStyle/>
+            <a:p>
+              <a:pPr marL="0" indent="0">
+                <a:buNone/>
+              </a:pPr>
+              <a:r>
+                <a:rPr lang="en-US" sz="1000" b="1" dirty="0">
+                  <a:solidFill>
+                    <a:srgbClr val="2A7F6F"/>
+                  </a:solidFill>
+                  <a:latin typeface="Poppins" pitchFamily="34" charset="0"/>
+                  <a:ea typeface="Poppins" pitchFamily="34" charset="-122"/>
+                  <a:cs typeface="Poppins" pitchFamily="34" charset="-120"/>
+                </a:rPr>
+                <a:t>Key insight</a:t>
+              </a:r>
+              <a:endParaRPr lang="en-US" sz="1000" dirty="0"/>
+            </a:p>
+          </p:txBody>
+        </p:sp>
+        <p:sp>
+          <p:nvSpPr>
+            <p:cNvPr id="34" name="Text 32"/>
+            <p:cNvSpPr/>
+            <p:nvPr/>
+          </p:nvSpPr>
+          <p:spPr>
+            <a:xfrm>
+              <a:off x="5829300" y="2820924"/>
+              <a:ext cx="3063240" cy="1645920"/>
+            </a:xfrm>
+            <a:prstGeom prst="rect">
+              <a:avLst/>
+            </a:prstGeom>
+            <a:noFill/>
+            <a:ln/>
+          </p:spPr>
+          <p:txBody>
+            <a:bodyPr wrap="square" lIns="0" tIns="0" rIns="0" bIns="0" rtlCol="0" anchor="ctr"/>
+            <a:lstStyle/>
+            <a:p>
+              <a:pPr marL="0" indent="0">
+                <a:buNone/>
+              </a:pPr>
+              <a:r>
+                <a:rPr lang="en-US" sz="1150" dirty="0">
+                  <a:solidFill>
+                    <a:srgbClr val="2C3E35"/>
+                  </a:solidFill>
+                  <a:latin typeface="Poppins" pitchFamily="34" charset="0"/>
+                  <a:ea typeface="Poppins" pitchFamily="34" charset="-122"/>
+                  <a:cs typeface="Poppins" pitchFamily="34" charset="-120"/>
+                </a:rPr>
+                <a:t>Only 2% of Zambians use credit cards — but 95% use mobile money. The payment barrier that stopped e-commerce elsewhere doesn't exist here.</a:t>
+              </a:r>
+              <a:endParaRPr lang="en-US" sz="1150" dirty="0"/>
+            </a:p>
+          </p:txBody>
+        </p:sp>
+      </p:grpSp>
     </p:spTree>
   </p:cSld>
   <p:clrMapOvr>
@@ -5522,6 +5614,7 @@
         <a:solidFill>
           <a:srgbClr val="FFFFFF"/>
         </a:solidFill>
+        <a:effectLst/>
       </p:bgPr>
     </p:bg>
     <p:spTree>
@@ -5559,7 +5652,7 @@
           <a:bodyPr wrap="square" lIns="0" tIns="0" rIns="0" bIns="0" rtlCol="0" anchor="ctr"/>
           <a:lstStyle/>
           <a:p>
-            <a:pPr indent="0" marL="0">
+            <a:pPr marL="0" indent="0">
               <a:buNone/>
             </a:pPr>
             <a:r>
@@ -5579,7 +5672,7 @@
       </p:sp>
       <p:graphicFrame>
         <p:nvGraphicFramePr>
-          <p:cNvPr id="3" name="Chart 0" descr=""/>
+          <p:cNvPr id="3" name="Chart 0"/>
           <p:cNvGraphicFramePr/>
           <p:nvPr/>
         </p:nvGraphicFramePr>
@@ -5587,9 +5680,9 @@
           <a:off x="548640" y="960120"/>
           <a:ext cx="5303520" cy="3291840"/>
         </p:xfrm>
-        <a:graphic xmlns:a="http://schemas.openxmlformats.org/drawingml/2006/main">
+        <a:graphic>
           <a:graphicData uri="http://schemas.openxmlformats.org/drawingml/2006/chart">
-            <c:chart xmlns:c="http://schemas.openxmlformats.org/drawingml/2006/chart" r:id="rId1"/>
+            <c:chart xmlns:c="http://schemas.openxmlformats.org/drawingml/2006/chart" xmlns:r="http://schemas.openxmlformats.org/officeDocument/2006/relationships" r:id="rId3"/>
           </a:graphicData>
         </a:graphic>
       </p:graphicFrame>
@@ -5617,6 +5710,13 @@
             <a:prstDash val="solid"/>
           </a:ln>
         </p:spPr>
+        <p:txBody>
+          <a:bodyPr/>
+          <a:lstStyle/>
+          <a:p>
+            <a:endParaRPr lang="en-US"/>
+          </a:p>
+        </p:txBody>
       </p:sp>
       <p:sp>
         <p:nvSpPr>
@@ -5639,7 +5739,7 @@
           <a:bodyPr wrap="square" lIns="0" tIns="0" rIns="0" bIns="0" rtlCol="0" anchor="ctr"/>
           <a:lstStyle/>
           <a:p>
-            <a:pPr indent="0" marL="0">
+            <a:pPr marL="0" indent="0">
               <a:buNone/>
             </a:pPr>
             <a:r>
@@ -5678,7 +5778,7 @@
           <a:bodyPr wrap="square" lIns="0" tIns="0" rIns="0" bIns="0" rtlCol="0" anchor="ctr"/>
           <a:lstStyle/>
           <a:p>
-            <a:pPr indent="0" marL="0">
+            <a:pPr marL="0" indent="0">
               <a:buNone/>
             </a:pPr>
             <a:r>
@@ -5720,6 +5820,13 @@
             <a:prstDash val="solid"/>
           </a:ln>
         </p:spPr>
+        <p:txBody>
+          <a:bodyPr/>
+          <a:lstStyle/>
+          <a:p>
+            <a:endParaRPr lang="en-US"/>
+          </a:p>
+        </p:txBody>
       </p:sp>
       <p:sp>
         <p:nvSpPr>
@@ -5742,7 +5849,7 @@
           <a:bodyPr wrap="square" lIns="0" tIns="0" rIns="0" bIns="0" rtlCol="0" anchor="ctr"/>
           <a:lstStyle/>
           <a:p>
-            <a:pPr indent="0" marL="0">
+            <a:pPr marL="0" indent="0">
               <a:buNone/>
             </a:pPr>
             <a:r>
@@ -5781,7 +5888,7 @@
           <a:bodyPr wrap="square" lIns="0" tIns="0" rIns="0" bIns="0" rtlCol="0" anchor="ctr"/>
           <a:lstStyle/>
           <a:p>
-            <a:pPr indent="0" marL="0">
+            <a:pPr marL="0" indent="0">
               <a:buNone/>
             </a:pPr>
             <a:r>
@@ -5823,6 +5930,13 @@
             <a:prstDash val="solid"/>
           </a:ln>
         </p:spPr>
+        <p:txBody>
+          <a:bodyPr/>
+          <a:lstStyle/>
+          <a:p>
+            <a:endParaRPr lang="en-US"/>
+          </a:p>
+        </p:txBody>
       </p:sp>
       <p:sp>
         <p:nvSpPr>
@@ -5845,7 +5959,7 @@
           <a:bodyPr wrap="square" lIns="0" tIns="0" rIns="0" bIns="0" rtlCol="0" anchor="ctr"/>
           <a:lstStyle/>
           <a:p>
-            <a:pPr indent="0" marL="0">
+            <a:pPr marL="0" indent="0">
               <a:buNone/>
             </a:pPr>
             <a:r>
@@ -5884,7 +5998,7 @@
           <a:bodyPr wrap="square" lIns="0" tIns="0" rIns="0" bIns="0" rtlCol="0" anchor="ctr"/>
           <a:lstStyle/>
           <a:p>
-            <a:pPr indent="0" marL="0">
+            <a:pPr marL="0" indent="0">
               <a:buNone/>
             </a:pPr>
             <a:r>
@@ -5923,7 +6037,7 @@
           <a:bodyPr wrap="square" lIns="0" tIns="0" rIns="0" bIns="0" rtlCol="0" anchor="ctr"/>
           <a:lstStyle/>
           <a:p>
-            <a:pPr indent="0" marL="0">
+            <a:pPr marL="0" indent="0">
               <a:buNone/>
             </a:pPr>
             <a:r>
@@ -5957,6 +6071,7 @@
         <a:solidFill>
           <a:srgbClr val="FFFFFF"/>
         </a:solidFill>
+        <a:effectLst/>
       </p:bgPr>
     </p:bg>
     <p:spTree>
@@ -5994,7 +6109,7 @@
           <a:bodyPr wrap="square" lIns="0" tIns="0" rIns="0" bIns="0" rtlCol="0" anchor="ctr"/>
           <a:lstStyle/>
           <a:p>
-            <a:pPr indent="0" marL="0">
+            <a:pPr marL="0" indent="0">
               <a:buNone/>
             </a:pPr>
             <a:r>
@@ -6033,7 +6148,7 @@
           <a:bodyPr wrap="square" lIns="0" tIns="0" rIns="0" bIns="0" rtlCol="0" anchor="ctr"/>
           <a:lstStyle/>
           <a:p>
-            <a:pPr indent="0" marL="0">
+            <a:pPr marL="0" indent="0">
               <a:buNone/>
             </a:pPr>
             <a:r>
@@ -6075,6 +6190,13 @@
             <a:prstDash val="solid"/>
           </a:ln>
         </p:spPr>
+        <p:txBody>
+          <a:bodyPr/>
+          <a:lstStyle/>
+          <a:p>
+            <a:endParaRPr lang="en-US"/>
+          </a:p>
+        </p:txBody>
       </p:sp>
       <p:sp>
         <p:nvSpPr>
@@ -6100,6 +6222,13 @@
             <a:prstDash val="solid"/>
           </a:ln>
         </p:spPr>
+        <p:txBody>
+          <a:bodyPr/>
+          <a:lstStyle/>
+          <a:p>
+            <a:endParaRPr lang="en-US"/>
+          </a:p>
+        </p:txBody>
       </p:sp>
       <p:sp>
         <p:nvSpPr>
@@ -6122,7 +6251,7 @@
           <a:bodyPr wrap="square" lIns="0" tIns="0" rIns="0" bIns="0" rtlCol="0" anchor="ctr"/>
           <a:lstStyle/>
           <a:p>
-            <a:pPr indent="0" marL="0">
+            <a:pPr marL="0" indent="0">
               <a:buNone/>
             </a:pPr>
             <a:r>
@@ -6161,7 +6290,7 @@
           <a:bodyPr wrap="square" lIns="0" tIns="0" rIns="0" bIns="0" rtlCol="0" anchor="ctr"/>
           <a:lstStyle/>
           <a:p>
-            <a:pPr indent="0" marL="0">
+            <a:pPr marL="0" indent="0">
               <a:buNone/>
             </a:pPr>
             <a:r>
@@ -6203,6 +6332,13 @@
             <a:prstDash val="solid"/>
           </a:ln>
         </p:spPr>
+        <p:txBody>
+          <a:bodyPr/>
+          <a:lstStyle/>
+          <a:p>
+            <a:endParaRPr lang="en-US"/>
+          </a:p>
+        </p:txBody>
       </p:sp>
       <p:sp>
         <p:nvSpPr>
@@ -6225,7 +6361,7 @@
           <a:bodyPr wrap="square" lIns="0" tIns="0" rIns="0" bIns="0" rtlCol="0" anchor="ctr"/>
           <a:lstStyle/>
           <a:p>
-            <a:pPr indent="0" marL="0">
+            <a:pPr marL="0" indent="0">
               <a:buNone/>
             </a:pPr>
             <a:r>
@@ -6267,6 +6403,13 @@
             <a:prstDash val="solid"/>
           </a:ln>
         </p:spPr>
+        <p:txBody>
+          <a:bodyPr/>
+          <a:lstStyle/>
+          <a:p>
+            <a:endParaRPr lang="en-US"/>
+          </a:p>
+        </p:txBody>
       </p:sp>
       <p:sp>
         <p:nvSpPr>
@@ -6292,6 +6435,13 @@
             <a:prstDash val="solid"/>
           </a:ln>
         </p:spPr>
+        <p:txBody>
+          <a:bodyPr/>
+          <a:lstStyle/>
+          <a:p>
+            <a:endParaRPr lang="en-US"/>
+          </a:p>
+        </p:txBody>
       </p:sp>
       <p:sp>
         <p:nvSpPr>
@@ -6314,7 +6464,7 @@
           <a:bodyPr wrap="square" lIns="0" tIns="0" rIns="0" bIns="0" rtlCol="0" anchor="ctr"/>
           <a:lstStyle/>
           <a:p>
-            <a:pPr indent="0" marL="0">
+            <a:pPr marL="0" indent="0">
               <a:buNone/>
             </a:pPr>
             <a:r>
@@ -6353,7 +6503,7 @@
           <a:bodyPr wrap="square" lIns="0" tIns="0" rIns="0" bIns="0" rtlCol="0" anchor="ctr"/>
           <a:lstStyle/>
           <a:p>
-            <a:pPr indent="0" marL="0">
+            <a:pPr marL="0" indent="0">
               <a:buNone/>
             </a:pPr>
             <a:r>
@@ -6395,6 +6545,13 @@
             <a:prstDash val="solid"/>
           </a:ln>
         </p:spPr>
+        <p:txBody>
+          <a:bodyPr/>
+          <a:lstStyle/>
+          <a:p>
+            <a:endParaRPr lang="en-US"/>
+          </a:p>
+        </p:txBody>
       </p:sp>
       <p:sp>
         <p:nvSpPr>
@@ -6417,7 +6574,7 @@
           <a:bodyPr wrap="square" lIns="0" tIns="0" rIns="0" bIns="0" rtlCol="0" anchor="ctr"/>
           <a:lstStyle/>
           <a:p>
-            <a:pPr indent="0" marL="0">
+            <a:pPr marL="0" indent="0">
               <a:buNone/>
             </a:pPr>
             <a:r>
@@ -6459,6 +6616,13 @@
             <a:prstDash val="solid"/>
           </a:ln>
         </p:spPr>
+        <p:txBody>
+          <a:bodyPr/>
+          <a:lstStyle/>
+          <a:p>
+            <a:endParaRPr lang="en-US"/>
+          </a:p>
+        </p:txBody>
       </p:sp>
       <p:sp>
         <p:nvSpPr>
@@ -6484,6 +6648,13 @@
             <a:prstDash val="solid"/>
           </a:ln>
         </p:spPr>
+        <p:txBody>
+          <a:bodyPr/>
+          <a:lstStyle/>
+          <a:p>
+            <a:endParaRPr lang="en-US"/>
+          </a:p>
+        </p:txBody>
       </p:sp>
       <p:sp>
         <p:nvSpPr>
@@ -6506,7 +6677,7 @@
           <a:bodyPr wrap="square" lIns="0" tIns="0" rIns="0" bIns="0" rtlCol="0" anchor="ctr"/>
           <a:lstStyle/>
           <a:p>
-            <a:pPr indent="0" marL="0">
+            <a:pPr marL="0" indent="0">
               <a:buNone/>
             </a:pPr>
             <a:r>
@@ -6545,7 +6716,7 @@
           <a:bodyPr wrap="square" lIns="0" tIns="0" rIns="0" bIns="0" rtlCol="0" anchor="ctr"/>
           <a:lstStyle/>
           <a:p>
-            <a:pPr indent="0" marL="0">
+            <a:pPr marL="0" indent="0">
               <a:buNone/>
             </a:pPr>
             <a:r>
@@ -6587,6 +6758,13 @@
             <a:prstDash val="solid"/>
           </a:ln>
         </p:spPr>
+        <p:txBody>
+          <a:bodyPr/>
+          <a:lstStyle/>
+          <a:p>
+            <a:endParaRPr lang="en-US"/>
+          </a:p>
+        </p:txBody>
       </p:sp>
       <p:sp>
         <p:nvSpPr>
@@ -6609,7 +6787,7 @@
           <a:bodyPr wrap="square" lIns="0" tIns="0" rIns="0" bIns="0" rtlCol="0" anchor="ctr"/>
           <a:lstStyle/>
           <a:p>
-            <a:pPr indent="0" marL="0">
+            <a:pPr marL="0" indent="0">
               <a:buNone/>
             </a:pPr>
             <a:r>
@@ -6651,6 +6829,13 @@
             <a:prstDash val="solid"/>
           </a:ln>
         </p:spPr>
+        <p:txBody>
+          <a:bodyPr/>
+          <a:lstStyle/>
+          <a:p>
+            <a:endParaRPr lang="en-US"/>
+          </a:p>
+        </p:txBody>
       </p:sp>
       <p:sp>
         <p:nvSpPr>
@@ -6676,6 +6861,13 @@
             <a:prstDash val="solid"/>
           </a:ln>
         </p:spPr>
+        <p:txBody>
+          <a:bodyPr/>
+          <a:lstStyle/>
+          <a:p>
+            <a:endParaRPr lang="en-US"/>
+          </a:p>
+        </p:txBody>
       </p:sp>
       <p:sp>
         <p:nvSpPr>
@@ -6698,7 +6890,7 @@
           <a:bodyPr wrap="square" lIns="0" tIns="0" rIns="0" bIns="0" rtlCol="0" anchor="ctr"/>
           <a:lstStyle/>
           <a:p>
-            <a:pPr indent="0" marL="0">
+            <a:pPr marL="0" indent="0">
               <a:buNone/>
             </a:pPr>
             <a:r>
@@ -6737,7 +6929,7 @@
           <a:bodyPr wrap="square" lIns="0" tIns="0" rIns="0" bIns="0" rtlCol="0" anchor="ctr"/>
           <a:lstStyle/>
           <a:p>
-            <a:pPr indent="0" marL="0">
+            <a:pPr marL="0" indent="0">
               <a:buNone/>
             </a:pPr>
             <a:r>
@@ -6779,6 +6971,13 @@
             <a:prstDash val="solid"/>
           </a:ln>
         </p:spPr>
+        <p:txBody>
+          <a:bodyPr/>
+          <a:lstStyle/>
+          <a:p>
+            <a:endParaRPr lang="en-US"/>
+          </a:p>
+        </p:txBody>
       </p:sp>
       <p:sp>
         <p:nvSpPr>
@@ -6801,7 +7000,7 @@
           <a:bodyPr wrap="square" lIns="0" tIns="0" rIns="0" bIns="0" rtlCol="0" anchor="ctr"/>
           <a:lstStyle/>
           <a:p>
-            <a:pPr indent="0" marL="0">
+            <a:pPr marL="0" indent="0">
               <a:buNone/>
             </a:pPr>
             <a:r>
@@ -6835,6 +7034,7 @@
         <a:solidFill>
           <a:srgbClr val="1C2B36"/>
         </a:solidFill>
+        <a:effectLst/>
       </p:bgPr>
     </p:bg>
     <p:spTree>
@@ -6879,6 +7079,13 @@
             <a:prstDash val="solid"/>
           </a:ln>
         </p:spPr>
+        <p:txBody>
+          <a:bodyPr/>
+          <a:lstStyle/>
+          <a:p>
+            <a:endParaRPr lang="en-US"/>
+          </a:p>
+        </p:txBody>
       </p:sp>
       <p:sp>
         <p:nvSpPr>
@@ -6901,7 +7108,7 @@
           <a:bodyPr wrap="square" lIns="0" tIns="0" rIns="0" bIns="0" rtlCol="0" anchor="ctr"/>
           <a:lstStyle/>
           <a:p>
-            <a:pPr indent="0" marL="0">
+            <a:pPr marL="0" indent="0">
               <a:buNone/>
             </a:pPr>
             <a:r>
@@ -6940,7 +7147,7 @@
           <a:bodyPr wrap="square" lIns="0" tIns="0" rIns="0" bIns="0" rtlCol="0" anchor="ctr"/>
           <a:lstStyle/>
           <a:p>
-            <a:pPr indent="0" marL="0">
+            <a:pPr marL="0" indent="0">
               <a:buNone/>
             </a:pPr>
             <a:r>
@@ -6986,6 +7193,13 @@
             <a:prstDash val="solid"/>
           </a:ln>
         </p:spPr>
+        <p:txBody>
+          <a:bodyPr/>
+          <a:lstStyle/>
+          <a:p>
+            <a:endParaRPr lang="en-US"/>
+          </a:p>
+        </p:txBody>
       </p:sp>
       <p:sp>
         <p:nvSpPr>
@@ -7008,7 +7222,7 @@
           <a:bodyPr wrap="square" lIns="0" tIns="0" rIns="0" bIns="0" rtlCol="0" anchor="ctr"/>
           <a:lstStyle/>
           <a:p>
-            <a:pPr indent="0" marL="0">
+            <a:pPr marL="0" indent="0">
               <a:buNone/>
             </a:pPr>
             <a:r>
@@ -7050,6 +7264,13 @@
             <a:prstDash val="solid"/>
           </a:ln>
         </p:spPr>
+        <p:txBody>
+          <a:bodyPr/>
+          <a:lstStyle/>
+          <a:p>
+            <a:endParaRPr lang="en-US"/>
+          </a:p>
+        </p:txBody>
       </p:sp>
       <p:sp>
         <p:nvSpPr>
@@ -7072,7 +7293,7 @@
           <a:bodyPr wrap="square" lIns="0" tIns="0" rIns="0" bIns="0" rtlCol="0" anchor="ctr"/>
           <a:lstStyle/>
           <a:p>
-            <a:pPr indent="0" marL="0">
+            <a:pPr marL="0" indent="0">
               <a:buNone/>
             </a:pPr>
             <a:r>
@@ -7111,7 +7332,7 @@
           <a:bodyPr wrap="square" lIns="0" tIns="0" rIns="0" bIns="0" rtlCol="0" anchor="ctr"/>
           <a:lstStyle/>
           <a:p>
-            <a:pPr indent="0" marL="0">
+            <a:pPr marL="0" indent="0">
               <a:buNone/>
             </a:pPr>
             <a:r>
@@ -7150,7 +7371,7 @@
           <a:bodyPr wrap="square" lIns="0" tIns="0" rIns="0" bIns="0" rtlCol="0" anchor="ctr"/>
           <a:lstStyle/>
           <a:p>
-            <a:pPr indent="0" marL="0">
+            <a:pPr marL="0" indent="0">
               <a:buNone/>
             </a:pPr>
             <a:r>
@@ -7192,6 +7413,13 @@
             <a:prstDash val="solid"/>
           </a:ln>
         </p:spPr>
+        <p:txBody>
+          <a:bodyPr/>
+          <a:lstStyle/>
+          <a:p>
+            <a:endParaRPr lang="en-US"/>
+          </a:p>
+        </p:txBody>
       </p:sp>
       <p:sp>
         <p:nvSpPr>
@@ -7214,7 +7442,7 @@
           <a:bodyPr wrap="square" lIns="0" tIns="0" rIns="0" bIns="0" rtlCol="0" anchor="ctr"/>
           <a:lstStyle/>
           <a:p>
-            <a:pPr indent="0" marL="0">
+            <a:pPr marL="0" indent="0">
               <a:buNone/>
             </a:pPr>
             <a:r>
@@ -7253,7 +7481,7 @@
           <a:bodyPr wrap="square" lIns="0" tIns="0" rIns="0" bIns="0" rtlCol="0" anchor="ctr"/>
           <a:lstStyle/>
           <a:p>
-            <a:pPr indent="0" marL="0">
+            <a:pPr marL="0" indent="0">
               <a:buNone/>
             </a:pPr>
             <a:r>
@@ -7292,7 +7520,7 @@
           <a:bodyPr wrap="square" lIns="0" tIns="0" rIns="0" bIns="0" rtlCol="0" anchor="ctr"/>
           <a:lstStyle/>
           <a:p>
-            <a:pPr indent="0" marL="0">
+            <a:pPr marL="0" indent="0">
               <a:buNone/>
             </a:pPr>
             <a:r>
@@ -7334,6 +7562,13 @@
             <a:prstDash val="solid"/>
           </a:ln>
         </p:spPr>
+        <p:txBody>
+          <a:bodyPr/>
+          <a:lstStyle/>
+          <a:p>
+            <a:endParaRPr lang="en-US"/>
+          </a:p>
+        </p:txBody>
       </p:sp>
       <p:sp>
         <p:nvSpPr>
@@ -7356,7 +7591,7 @@
           <a:bodyPr wrap="square" lIns="0" tIns="0" rIns="0" bIns="0" rtlCol="0" anchor="ctr"/>
           <a:lstStyle/>
           <a:p>
-            <a:pPr indent="0" marL="0">
+            <a:pPr marL="0" indent="0">
               <a:buNone/>
             </a:pPr>
             <a:r>
@@ -7395,7 +7630,7 @@
           <a:bodyPr wrap="square" lIns="0" tIns="0" rIns="0" bIns="0" rtlCol="0" anchor="ctr"/>
           <a:lstStyle/>
           <a:p>
-            <a:pPr indent="0" marL="0">
+            <a:pPr marL="0" indent="0">
               <a:buNone/>
             </a:pPr>
             <a:r>
@@ -7434,7 +7669,7 @@
           <a:bodyPr wrap="square" lIns="0" tIns="0" rIns="0" bIns="0" rtlCol="0" anchor="ctr"/>
           <a:lstStyle/>
           <a:p>
-            <a:pPr indent="0" marL="0">
+            <a:pPr marL="0" indent="0">
               <a:buNone/>
             </a:pPr>
             <a:r>
@@ -7476,6 +7711,13 @@
             <a:prstDash val="solid"/>
           </a:ln>
         </p:spPr>
+        <p:txBody>
+          <a:bodyPr/>
+          <a:lstStyle/>
+          <a:p>
+            <a:endParaRPr lang="en-US"/>
+          </a:p>
+        </p:txBody>
       </p:sp>
       <p:sp>
         <p:nvSpPr>
@@ -7498,7 +7740,7 @@
           <a:bodyPr wrap="square" lIns="0" tIns="0" rIns="0" bIns="0" rtlCol="0" anchor="ctr"/>
           <a:lstStyle/>
           <a:p>
-            <a:pPr indent="0" marL="0">
+            <a:pPr marL="0" indent="0">
               <a:buNone/>
             </a:pPr>
             <a:r>
@@ -7537,7 +7779,7 @@
           <a:bodyPr wrap="square" lIns="0" tIns="0" rIns="0" bIns="0" rtlCol="0" anchor="ctr"/>
           <a:lstStyle/>
           <a:p>
-            <a:pPr indent="0" marL="0">
+            <a:pPr marL="0" indent="0">
               <a:buNone/>
             </a:pPr>
             <a:r>
@@ -7576,7 +7818,7 @@
           <a:bodyPr wrap="square" lIns="0" tIns="0" rIns="0" bIns="0" rtlCol="0" anchor="ctr"/>
           <a:lstStyle/>
           <a:p>
-            <a:pPr indent="0" marL="0">
+            <a:pPr marL="0" indent="0">
               <a:buNone/>
             </a:pPr>
             <a:r>
@@ -7618,6 +7860,13 @@
             <a:prstDash val="solid"/>
           </a:ln>
         </p:spPr>
+        <p:txBody>
+          <a:bodyPr/>
+          <a:lstStyle/>
+          <a:p>
+            <a:endParaRPr lang="en-US"/>
+          </a:p>
+        </p:txBody>
       </p:sp>
       <p:sp>
         <p:nvSpPr>
@@ -7640,7 +7889,7 @@
           <a:bodyPr wrap="square" lIns="0" tIns="0" rIns="0" bIns="0" rtlCol="0" anchor="ctr"/>
           <a:lstStyle/>
           <a:p>
-            <a:pPr indent="0" marL="0">
+            <a:pPr marL="0" indent="0">
               <a:buNone/>
             </a:pPr>
             <a:r>
@@ -7679,7 +7928,7 @@
           <a:bodyPr wrap="square" lIns="0" tIns="0" rIns="0" bIns="0" rtlCol="0" anchor="ctr"/>
           <a:lstStyle/>
           <a:p>
-            <a:pPr indent="0" marL="0">
+            <a:pPr marL="0" indent="0">
               <a:buNone/>
             </a:pPr>
             <a:r>
@@ -7718,7 +7967,7 @@
           <a:bodyPr wrap="square" lIns="0" tIns="0" rIns="0" bIns="0" rtlCol="0" anchor="ctr"/>
           <a:lstStyle/>
           <a:p>
-            <a:pPr indent="0" marL="0">
+            <a:pPr marL="0" indent="0">
               <a:buNone/>
             </a:pPr>
             <a:r>
@@ -7760,6 +8009,13 @@
             <a:prstDash val="solid"/>
           </a:ln>
         </p:spPr>
+        <p:txBody>
+          <a:bodyPr/>
+          <a:lstStyle/>
+          <a:p>
+            <a:endParaRPr lang="en-US"/>
+          </a:p>
+        </p:txBody>
       </p:sp>
       <p:sp>
         <p:nvSpPr>
@@ -7782,7 +8038,7 @@
           <a:bodyPr wrap="square" lIns="0" tIns="0" rIns="0" bIns="0" rtlCol="0" anchor="ctr"/>
           <a:lstStyle/>
           <a:p>
-            <a:pPr indent="0" marL="0">
+            <a:pPr marL="0" indent="0">
               <a:buNone/>
             </a:pPr>
             <a:r>
@@ -7821,7 +8077,7 @@
           <a:bodyPr wrap="square" lIns="0" tIns="0" rIns="0" bIns="0" rtlCol="0" anchor="ctr"/>
           <a:lstStyle/>
           <a:p>
-            <a:pPr indent="0" marL="0">
+            <a:pPr marL="0" indent="0">
               <a:buNone/>
             </a:pPr>
             <a:r>
@@ -7860,7 +8116,7 @@
           <a:bodyPr wrap="square" lIns="0" tIns="0" rIns="0" bIns="0" rtlCol="0" anchor="ctr"/>
           <a:lstStyle/>
           <a:p>
-            <a:pPr indent="0" marL="0">
+            <a:pPr marL="0" indent="0">
               <a:buNone/>
             </a:pPr>
             <a:r>
@@ -7894,6 +8150,7 @@
         <a:solidFill>
           <a:srgbClr val="1C2B36"/>
         </a:solidFill>
+        <a:effectLst/>
       </p:bgPr>
     </p:bg>
     <p:spTree>
@@ -7938,6 +8195,13 @@
             <a:prstDash val="solid"/>
           </a:ln>
         </p:spPr>
+        <p:txBody>
+          <a:bodyPr/>
+          <a:lstStyle/>
+          <a:p>
+            <a:endParaRPr lang="en-US"/>
+          </a:p>
+        </p:txBody>
       </p:sp>
       <p:sp>
         <p:nvSpPr>
@@ -7960,7 +8224,7 @@
           <a:bodyPr wrap="square" lIns="0" tIns="0" rIns="0" bIns="0" rtlCol="0" anchor="ctr"/>
           <a:lstStyle/>
           <a:p>
-            <a:pPr indent="0" marL="0">
+            <a:pPr marL="0" indent="0">
               <a:buNone/>
             </a:pPr>
             <a:r>
@@ -7999,7 +8263,7 @@
           <a:bodyPr wrap="square" lIns="0" tIns="0" rIns="0" bIns="0" rtlCol="0" anchor="ctr"/>
           <a:lstStyle/>
           <a:p>
-            <a:pPr indent="0" marL="0">
+            <a:pPr marL="0" indent="0">
               <a:buNone/>
             </a:pPr>
             <a:r>
@@ -8016,7 +8280,7 @@
             <a:endParaRPr lang="en-US" sz="1400" dirty="0"/>
           </a:p>
           <a:p>
-            <a:pPr indent="0" marL="0">
+            <a:pPr marL="0" indent="0">
               <a:buNone/>
             </a:pPr>
             <a:r>
@@ -8033,7 +8297,7 @@
             <a:endParaRPr lang="en-US" sz="1400" dirty="0"/>
           </a:p>
           <a:p>
-            <a:pPr indent="0" marL="0">
+            <a:pPr marL="0" indent="0">
               <a:buNone/>
             </a:pPr>
             <a:r>
@@ -8079,6 +8343,13 @@
             <a:prstDash val="solid"/>
           </a:ln>
         </p:spPr>
+        <p:txBody>
+          <a:bodyPr/>
+          <a:lstStyle/>
+          <a:p>
+            <a:endParaRPr lang="en-US"/>
+          </a:p>
+        </p:txBody>
       </p:sp>
       <p:sp>
         <p:nvSpPr>
@@ -8101,7 +8372,7 @@
           <a:bodyPr wrap="square" lIns="0" tIns="0" rIns="0" bIns="0" rtlCol="0" anchor="ctr"/>
           <a:lstStyle/>
           <a:p>
-            <a:pPr indent="0" marL="0">
+            <a:pPr marL="0" indent="0">
               <a:buNone/>
             </a:pPr>
             <a:r>
@@ -8420,4 +8691,319 @@
     </a:ext>
   </a:extLst>
 </a:theme>
+</file>
+
+<file path=ppt/theme/theme2.xml><?xml version="1.0" encoding="utf-8"?>
+<a:theme xmlns:a="http://schemas.openxmlformats.org/drawingml/2006/main" name="Office Theme">
+  <a:themeElements>
+    <a:clrScheme name="Office">
+      <a:dk1>
+        <a:sysClr val="windowText" lastClr="000000"/>
+      </a:dk1>
+      <a:lt1>
+        <a:sysClr val="window" lastClr="FFFFFF"/>
+      </a:lt1>
+      <a:dk2>
+        <a:srgbClr val="0E2841"/>
+      </a:dk2>
+      <a:lt2>
+        <a:srgbClr val="E8E8E8"/>
+      </a:lt2>
+      <a:accent1>
+        <a:srgbClr val="156082"/>
+      </a:accent1>
+      <a:accent2>
+        <a:srgbClr val="E97132"/>
+      </a:accent2>
+      <a:accent3>
+        <a:srgbClr val="196B24"/>
+      </a:accent3>
+      <a:accent4>
+        <a:srgbClr val="0F9ED5"/>
+      </a:accent4>
+      <a:accent5>
+        <a:srgbClr val="A02B93"/>
+      </a:accent5>
+      <a:accent6>
+        <a:srgbClr val="4EA72E"/>
+      </a:accent6>
+      <a:hlink>
+        <a:srgbClr val="467886"/>
+      </a:hlink>
+      <a:folHlink>
+        <a:srgbClr val="96607D"/>
+      </a:folHlink>
+    </a:clrScheme>
+    <a:fontScheme name="Office">
+      <a:majorFont>
+        <a:latin typeface="Aptos Display" panose="02110004020202020204"/>
+        <a:ea typeface=""/>
+        <a:cs typeface=""/>
+        <a:font script="Jpan" typeface="游ゴシック Light"/>
+        <a:font script="Hang" typeface="맑은 고딕"/>
+        <a:font script="Hans" typeface="等线 Light"/>
+        <a:font script="Hant" typeface="新細明體"/>
+        <a:font script="Arab" typeface="Times New Roman"/>
+        <a:font script="Hebr" typeface="Times New Roman"/>
+        <a:font script="Thai" typeface="Angsana New"/>
+        <a:font script="Ethi" typeface="Nyala"/>
+        <a:font script="Beng" typeface="Vrinda"/>
+        <a:font script="Gujr" typeface="Shruti"/>
+        <a:font script="Khmr" typeface="MoolBoran"/>
+        <a:font script="Knda" typeface="Tunga"/>
+        <a:font script="Guru" typeface="Raavi"/>
+        <a:font script="Cans" typeface="Euphemia"/>
+        <a:font script="Cher" typeface="Plantagenet Cherokee"/>
+        <a:font script="Yiii" typeface="Microsoft Yi Baiti"/>
+        <a:font script="Tibt" typeface="Microsoft Himalaya"/>
+        <a:font script="Thaa" typeface="MV Boli"/>
+        <a:font script="Deva" typeface="Mangal"/>
+        <a:font script="Telu" typeface="Gautami"/>
+        <a:font script="Taml" typeface="Latha"/>
+        <a:font script="Syrc" typeface="Estrangelo Edessa"/>
+        <a:font script="Orya" typeface="Kalinga"/>
+        <a:font script="Mlym" typeface="Kartika"/>
+        <a:font script="Laoo" typeface="DokChampa"/>
+        <a:font script="Sinh" typeface="Iskoola Pota"/>
+        <a:font script="Mong" typeface="Mongolian Baiti"/>
+        <a:font script="Viet" typeface="Times New Roman"/>
+        <a:font script="Uigh" typeface="Microsoft Uighur"/>
+        <a:font script="Geor" typeface="Sylfaen"/>
+        <a:font script="Armn" typeface="Arial"/>
+        <a:font script="Bugi" typeface="Leelawadee UI"/>
+        <a:font script="Bopo" typeface="Microsoft JhengHei"/>
+        <a:font script="Java" typeface="Javanese Text"/>
+        <a:font script="Lisu" typeface="Segoe UI"/>
+        <a:font script="Mymr" typeface="Myanmar Text"/>
+        <a:font script="Nkoo" typeface="Ebrima"/>
+        <a:font script="Olck" typeface="Nirmala UI"/>
+        <a:font script="Osma" typeface="Ebrima"/>
+        <a:font script="Phag" typeface="Phagspa"/>
+        <a:font script="Syrn" typeface="Estrangelo Edessa"/>
+        <a:font script="Syrj" typeface="Estrangelo Edessa"/>
+        <a:font script="Syre" typeface="Estrangelo Edessa"/>
+        <a:font script="Sora" typeface="Nirmala UI"/>
+        <a:font script="Tale" typeface="Microsoft Tai Le"/>
+        <a:font script="Talu" typeface="Microsoft New Tai Lue"/>
+        <a:font script="Tfng" typeface="Ebrima"/>
+      </a:majorFont>
+      <a:minorFont>
+        <a:latin typeface="Aptos" panose="02110004020202020204"/>
+        <a:ea typeface=""/>
+        <a:cs typeface=""/>
+        <a:font script="Jpan" typeface="游ゴシック"/>
+        <a:font script="Hang" typeface="맑은 고딕"/>
+        <a:font script="Hans" typeface="等线"/>
+        <a:font script="Hant" typeface="新細明體"/>
+        <a:font script="Arab" typeface="Arial"/>
+        <a:font script="Hebr" typeface="Arial"/>
+        <a:font script="Thai" typeface="Cordia New"/>
+        <a:font script="Ethi" typeface="Nyala"/>
+        <a:font script="Beng" typeface="Vrinda"/>
+        <a:font script="Gujr" typeface="Shruti"/>
+        <a:font script="Khmr" typeface="DaunPenh"/>
+        <a:font script="Knda" typeface="Tunga"/>
+        <a:font script="Guru" typeface="Raavi"/>
+        <a:font script="Cans" typeface="Euphemia"/>
+        <a:font script="Cher" typeface="Plantagenet Cherokee"/>
+        <a:font script="Yiii" typeface="Microsoft Yi Baiti"/>
+        <a:font script="Tibt" typeface="Microsoft Himalaya"/>
+        <a:font script="Thaa" typeface="MV Boli"/>
+        <a:font script="Deva" typeface="Mangal"/>
+        <a:font script="Telu" typeface="Gautami"/>
+        <a:font script="Taml" typeface="Latha"/>
+        <a:font script="Syrc" typeface="Estrangelo Edessa"/>
+        <a:font script="Orya" typeface="Kalinga"/>
+        <a:font script="Mlym" typeface="Kartika"/>
+        <a:font script="Laoo" typeface="DokChampa"/>
+        <a:font script="Sinh" typeface="Iskoola Pota"/>
+        <a:font script="Mong" typeface="Mongolian Baiti"/>
+        <a:font script="Viet" typeface="Arial"/>
+        <a:font script="Uigh" typeface="Microsoft Uighur"/>
+        <a:font script="Geor" typeface="Sylfaen"/>
+        <a:font script="Armn" typeface="Arial"/>
+        <a:font script="Bugi" typeface="Leelawadee UI"/>
+        <a:font script="Bopo" typeface="Microsoft JhengHei"/>
+        <a:font script="Java" typeface="Javanese Text"/>
+        <a:font script="Lisu" typeface="Segoe UI"/>
+        <a:font script="Mymr" typeface="Myanmar Text"/>
+        <a:font script="Nkoo" typeface="Ebrima"/>
+        <a:font script="Olck" typeface="Nirmala UI"/>
+        <a:font script="Osma" typeface="Ebrima"/>
+        <a:font script="Phag" typeface="Phagspa"/>
+        <a:font script="Syrn" typeface="Estrangelo Edessa"/>
+        <a:font script="Syrj" typeface="Estrangelo Edessa"/>
+        <a:font script="Syre" typeface="Estrangelo Edessa"/>
+        <a:font script="Sora" typeface="Nirmala UI"/>
+        <a:font script="Tale" typeface="Microsoft Tai Le"/>
+        <a:font script="Talu" typeface="Microsoft New Tai Lue"/>
+        <a:font script="Tfng" typeface="Ebrima"/>
+      </a:minorFont>
+    </a:fontScheme>
+    <a:fmtScheme name="Office">
+      <a:fillStyleLst>
+        <a:solidFill>
+          <a:schemeClr val="phClr"/>
+        </a:solidFill>
+        <a:gradFill rotWithShape="1">
+          <a:gsLst>
+            <a:gs pos="0">
+              <a:schemeClr val="phClr">
+                <a:lumMod val="110000"/>
+                <a:satMod val="105000"/>
+                <a:tint val="67000"/>
+              </a:schemeClr>
+            </a:gs>
+            <a:gs pos="50000">
+              <a:schemeClr val="phClr">
+                <a:lumMod val="105000"/>
+                <a:satMod val="103000"/>
+                <a:tint val="73000"/>
+              </a:schemeClr>
+            </a:gs>
+            <a:gs pos="100000">
+              <a:schemeClr val="phClr">
+                <a:lumMod val="105000"/>
+                <a:satMod val="109000"/>
+                <a:tint val="81000"/>
+              </a:schemeClr>
+            </a:gs>
+          </a:gsLst>
+          <a:lin ang="5400000" scaled="0"/>
+        </a:gradFill>
+        <a:gradFill rotWithShape="1">
+          <a:gsLst>
+            <a:gs pos="0">
+              <a:schemeClr val="phClr">
+                <a:satMod val="103000"/>
+                <a:lumMod val="102000"/>
+                <a:tint val="94000"/>
+              </a:schemeClr>
+            </a:gs>
+            <a:gs pos="50000">
+              <a:schemeClr val="phClr">
+                <a:satMod val="110000"/>
+                <a:lumMod val="100000"/>
+                <a:shade val="100000"/>
+              </a:schemeClr>
+            </a:gs>
+            <a:gs pos="100000">
+              <a:schemeClr val="phClr">
+                <a:lumMod val="99000"/>
+                <a:satMod val="120000"/>
+                <a:shade val="78000"/>
+              </a:schemeClr>
+            </a:gs>
+          </a:gsLst>
+          <a:lin ang="5400000" scaled="0"/>
+        </a:gradFill>
+      </a:fillStyleLst>
+      <a:lnStyleLst>
+        <a:ln w="12700" cap="flat" cmpd="sng" algn="ctr">
+          <a:solidFill>
+            <a:schemeClr val="phClr"/>
+          </a:solidFill>
+          <a:prstDash val="solid"/>
+          <a:miter lim="800000"/>
+        </a:ln>
+        <a:ln w="19050" cap="flat" cmpd="sng" algn="ctr">
+          <a:solidFill>
+            <a:schemeClr val="phClr"/>
+          </a:solidFill>
+          <a:prstDash val="solid"/>
+          <a:miter lim="800000"/>
+        </a:ln>
+        <a:ln w="25400" cap="flat" cmpd="sng" algn="ctr">
+          <a:solidFill>
+            <a:schemeClr val="phClr"/>
+          </a:solidFill>
+          <a:prstDash val="solid"/>
+          <a:miter lim="800000"/>
+        </a:ln>
+      </a:lnStyleLst>
+      <a:effectStyleLst>
+        <a:effectStyle>
+          <a:effectLst/>
+        </a:effectStyle>
+        <a:effectStyle>
+          <a:effectLst/>
+        </a:effectStyle>
+        <a:effectStyle>
+          <a:effectLst>
+            <a:outerShdw blurRad="57150" dist="19050" dir="5400000" algn="ctr" rotWithShape="0">
+              <a:srgbClr val="000000">
+                <a:alpha val="63000"/>
+              </a:srgbClr>
+            </a:outerShdw>
+          </a:effectLst>
+        </a:effectStyle>
+      </a:effectStyleLst>
+      <a:bgFillStyleLst>
+        <a:solidFill>
+          <a:schemeClr val="phClr"/>
+        </a:solidFill>
+        <a:solidFill>
+          <a:schemeClr val="phClr">
+            <a:tint val="95000"/>
+            <a:satMod val="170000"/>
+          </a:schemeClr>
+        </a:solidFill>
+        <a:gradFill rotWithShape="1">
+          <a:gsLst>
+            <a:gs pos="0">
+              <a:schemeClr val="phClr">
+                <a:tint val="93000"/>
+                <a:satMod val="150000"/>
+                <a:shade val="98000"/>
+                <a:lumMod val="102000"/>
+              </a:schemeClr>
+            </a:gs>
+            <a:gs pos="50000">
+              <a:schemeClr val="phClr">
+                <a:tint val="98000"/>
+                <a:satMod val="130000"/>
+                <a:shade val="90000"/>
+                <a:lumMod val="103000"/>
+              </a:schemeClr>
+            </a:gs>
+            <a:gs pos="100000">
+              <a:schemeClr val="phClr">
+                <a:shade val="63000"/>
+                <a:satMod val="120000"/>
+              </a:schemeClr>
+            </a:gs>
+          </a:gsLst>
+          <a:lin ang="5400000" scaled="0"/>
+        </a:gradFill>
+      </a:bgFillStyleLst>
+    </a:fmtScheme>
+  </a:themeElements>
+  <a:objectDefaults>
+    <a:lnDef>
+      <a:spPr/>
+      <a:bodyPr/>
+      <a:lstStyle/>
+      <a:style>
+        <a:lnRef idx="2">
+          <a:schemeClr val="accent1"/>
+        </a:lnRef>
+        <a:fillRef idx="0">
+          <a:schemeClr val="accent1"/>
+        </a:fillRef>
+        <a:effectRef idx="1">
+          <a:schemeClr val="accent1"/>
+        </a:effectRef>
+        <a:fontRef idx="minor">
+          <a:schemeClr val="tx1"/>
+        </a:fontRef>
+      </a:style>
+    </a:lnDef>
+  </a:objectDefaults>
+  <a:extraClrSchemeLst/>
+  <a:extLst>
+    <a:ext uri="{05A4C25C-085E-4340-85A3-A5531E510DB2}">
+      <thm15:themeFamily xmlns:thm15="http://schemas.microsoft.com/office/thememl/2012/main" name="Office Theme" id="{2E142A2C-CD16-42D6-873A-C26D2A0506FA}" vid="{1BDDFF52-6CD6-40A5-AB3C-68EB2F1E4D0A}"/>
+    </a:ext>
+  </a:extLst>
+</a:theme>
 </file>
</xml_diff>